<commit_message>
Added secure boot ppt, PSCI IOCTL
Signed-off-by: Rama <embedded.training.rama@gmail.com>
</commit_message>
<xml_diff>
--- a/2_Linux_kernel_config.pptx
+++ b/2_Linux_kernel_config.pptx
@@ -57,6 +57,7 @@
     <p:sldId id="282" r:id="rId52"/>
     <p:sldId id="283" r:id="rId53"/>
     <p:sldId id="284" r:id="rId54"/>
+    <p:sldId id="285" r:id="rId55"/>
   </p:sldIdLst>
   <p:sldSz cx="9144000" cy="6858000"/>
   <p:notesSz cx="7559675" cy="10691813"/>
@@ -3007,7 +3008,16 @@
                 </a:solidFill>
                 <a:latin typeface="Arial"/>
               </a:rPr>
-              <a:t>Click to edit the title text format</a:t>
+              <a:t>Click to edit the </a:t>
+            </a:r>
+            <a:r>
+              <a:rPr b="0" lang="en-US" sz="1800" spc="-1" strike="noStrike">
+                <a:solidFill>
+                  <a:srgbClr val="000000"/>
+                </a:solidFill>
+                <a:latin typeface="Arial"/>
+              </a:rPr>
+              <a:t>title text format</a:t>
             </a:r>
             <a:endParaRPr b="0" lang="en-US" sz="1800" spc="-1" strike="noStrike">
               <a:solidFill>
@@ -11229,52 +11239,7 @@
                 </a:solidFill>
                 <a:latin typeface="Arial"/>
               </a:rPr>
-              <a:t>Click </a:t>
-            </a:r>
-            <a:r>
-              <a:rPr b="0" lang="en-US" sz="1800" spc="-1" strike="noStrike">
-                <a:solidFill>
-                  <a:srgbClr val="000000"/>
-                </a:solidFill>
-                <a:latin typeface="Arial"/>
-              </a:rPr>
-              <a:t>to edit </a:t>
-            </a:r>
-            <a:r>
-              <a:rPr b="0" lang="en-US" sz="1800" spc="-1" strike="noStrike">
-                <a:solidFill>
-                  <a:srgbClr val="000000"/>
-                </a:solidFill>
-                <a:latin typeface="Arial"/>
-              </a:rPr>
-              <a:t>the </a:t>
-            </a:r>
-            <a:r>
-              <a:rPr b="0" lang="en-US" sz="1800" spc="-1" strike="noStrike">
-                <a:solidFill>
-                  <a:srgbClr val="000000"/>
-                </a:solidFill>
-                <a:latin typeface="Arial"/>
-              </a:rPr>
-              <a:t>title </a:t>
-            </a:r>
-            <a:r>
-              <a:rPr b="0" lang="en-US" sz="1800" spc="-1" strike="noStrike">
-                <a:solidFill>
-                  <a:srgbClr val="000000"/>
-                </a:solidFill>
-                <a:latin typeface="Arial"/>
-              </a:rPr>
-              <a:t>text </a:t>
-            </a:r>
-            <a:r>
-              <a:rPr b="0" lang="en-US" sz="1800" spc="-1" strike="noStrike">
-                <a:solidFill>
-                  <a:srgbClr val="000000"/>
-                </a:solidFill>
-                <a:latin typeface="Arial"/>
-              </a:rPr>
-              <a:t>format</a:t>
+              <a:t>Click to edit the title text format</a:t>
             </a:r>
             <a:endParaRPr b="0" lang="en-US" sz="1800" spc="-1" strike="noStrike">
               <a:solidFill>
@@ -13792,7 +13757,7 @@
         <p:spPr>
           <a:xfrm>
             <a:off x="3600" y="-1634040"/>
-            <a:ext cx="9141840" cy="6093720"/>
+            <a:ext cx="9141480" cy="6093360"/>
           </a:xfrm>
           <a:prstGeom prst="rect">
             <a:avLst/>
@@ -13845,7 +13810,7 @@
         <p:spPr>
           <a:xfrm>
             <a:off x="0" y="0"/>
-            <a:ext cx="9136080" cy="6837480"/>
+            <a:ext cx="9135720" cy="6837120"/>
           </a:xfrm>
           <a:prstGeom prst="rect">
             <a:avLst/>
@@ -13864,7 +13829,7 @@
         <p:spPr>
           <a:xfrm>
             <a:off x="3271320" y="285840"/>
-            <a:ext cx="2804760" cy="708480"/>
+            <a:ext cx="2804400" cy="708120"/>
           </a:xfrm>
           <a:prstGeom prst="rect">
             <a:avLst/>
@@ -13918,7 +13883,7 @@
         <p:spPr>
           <a:xfrm>
             <a:off x="208080" y="582120"/>
-            <a:ext cx="8283240" cy="1478160"/>
+            <a:ext cx="8282880" cy="1477800"/>
           </a:xfrm>
           <a:prstGeom prst="rect">
             <a:avLst/>
@@ -14008,7 +13973,7 @@
         <p:spPr>
           <a:xfrm>
             <a:off x="231480" y="1739880"/>
-            <a:ext cx="8682120" cy="1478160"/>
+            <a:ext cx="8681760" cy="1477800"/>
           </a:xfrm>
           <a:prstGeom prst="rect">
             <a:avLst/>
@@ -14088,7 +14053,7 @@
         <p:spPr>
           <a:xfrm>
             <a:off x="251640" y="2514600"/>
-            <a:ext cx="8705160" cy="4062240"/>
+            <a:ext cx="8704800" cy="4061880"/>
           </a:xfrm>
           <a:prstGeom prst="rect">
             <a:avLst/>
@@ -14351,6 +14316,42 @@
           <a:p>
             <a:pPr>
               <a:lnSpc>
+                <a:spcPct val="100000"/>
+              </a:lnSpc>
+            </a:pPr>
+            <a:endParaRPr b="0" lang="en-US" sz="1800" spc="-1" strike="noStrike">
+              <a:solidFill>
+                <a:srgbClr val="000000"/>
+              </a:solidFill>
+              <a:latin typeface="Arial"/>
+            </a:endParaRPr>
+          </a:p>
+          <a:p>
+            <a:pPr>
+              <a:lnSpc>
+                <a:spcPct val="100000"/>
+              </a:lnSpc>
+            </a:pPr>
+            <a:r>
+              <a:rPr b="1" lang="en-US" sz="1800" spc="-1" strike="noStrike">
+                <a:solidFill>
+                  <a:srgbClr val="000000"/>
+                </a:solidFill>
+                <a:latin typeface="Calibri"/>
+                <a:ea typeface="DejaVu Sans"/>
+              </a:rPr>
+              <a:t>make olddefconfig</a:t>
+            </a:r>
+            <a:endParaRPr b="0" lang="en-US" sz="1800" spc="-1" strike="noStrike">
+              <a:solidFill>
+                <a:srgbClr val="000000"/>
+              </a:solidFill>
+              <a:latin typeface="Arial"/>
+            </a:endParaRPr>
+          </a:p>
+          <a:p>
+            <a:pPr>
+              <a:lnSpc>
                 <a:spcPts val="1375"/>
               </a:lnSpc>
             </a:pPr>
@@ -14372,7 +14373,7 @@
         <p:spPr>
           <a:xfrm>
             <a:off x="1727280" y="3479760"/>
-            <a:ext cx="91800" cy="500040"/>
+            <a:ext cx="91440" cy="499680"/>
           </a:xfrm>
           <a:prstGeom prst="rect">
             <a:avLst/>
@@ -14426,7 +14427,7 @@
         <p:spPr>
           <a:xfrm>
             <a:off x="32040" y="4508280"/>
-            <a:ext cx="360" cy="709200"/>
+            <a:ext cx="360" cy="708840"/>
           </a:xfrm>
           <a:prstGeom prst="rect">
             <a:avLst/>
@@ -14517,7 +14518,7 @@
         <p:spPr>
           <a:xfrm>
             <a:off x="0" y="0"/>
-            <a:ext cx="9136080" cy="6837480"/>
+            <a:ext cx="9135720" cy="6837120"/>
           </a:xfrm>
           <a:prstGeom prst="rect">
             <a:avLst/>
@@ -14536,7 +14537,7 @@
         <p:spPr>
           <a:xfrm>
             <a:off x="2966400" y="524880"/>
-            <a:ext cx="3088440" cy="708480"/>
+            <a:ext cx="3088080" cy="708120"/>
           </a:xfrm>
           <a:prstGeom prst="rect">
             <a:avLst/>
@@ -14590,7 +14591,7 @@
         <p:spPr>
           <a:xfrm>
             <a:off x="226080" y="1191600"/>
-            <a:ext cx="8687520" cy="708480"/>
+            <a:ext cx="8687160" cy="708120"/>
           </a:xfrm>
           <a:prstGeom prst="rect">
             <a:avLst/>
@@ -14644,7 +14645,7 @@
         <p:spPr>
           <a:xfrm>
             <a:off x="934200" y="1866960"/>
-            <a:ext cx="5713200" cy="708480"/>
+            <a:ext cx="5712840" cy="708120"/>
           </a:xfrm>
           <a:prstGeom prst="rect">
             <a:avLst/>
@@ -14698,7 +14699,7 @@
         <p:spPr>
           <a:xfrm>
             <a:off x="413280" y="2127240"/>
-            <a:ext cx="8500320" cy="1478160"/>
+            <a:ext cx="8499960" cy="1477800"/>
           </a:xfrm>
           <a:prstGeom prst="rect">
             <a:avLst/>
@@ -14788,7 +14789,7 @@
         <p:spPr>
           <a:xfrm>
             <a:off x="1804680" y="2865960"/>
-            <a:ext cx="5340240" cy="1478160"/>
+            <a:ext cx="5339880" cy="1477800"/>
           </a:xfrm>
           <a:prstGeom prst="rect">
             <a:avLst/>
@@ -14888,7 +14889,7 @@
         <p:spPr>
           <a:xfrm>
             <a:off x="2562120" y="4186800"/>
-            <a:ext cx="1881360" cy="708480"/>
+            <a:ext cx="1881000" cy="708120"/>
           </a:xfrm>
           <a:prstGeom prst="rect">
             <a:avLst/>
@@ -14942,7 +14943,7 @@
         <p:spPr>
           <a:xfrm>
             <a:off x="3203280" y="4813200"/>
-            <a:ext cx="3504240" cy="708480"/>
+            <a:ext cx="3503880" cy="708120"/>
           </a:xfrm>
           <a:prstGeom prst="rect">
             <a:avLst/>
@@ -14996,7 +14997,7 @@
         <p:spPr>
           <a:xfrm>
             <a:off x="3199320" y="5200560"/>
-            <a:ext cx="3799800" cy="708480"/>
+            <a:ext cx="3799440" cy="708120"/>
           </a:xfrm>
           <a:prstGeom prst="rect">
             <a:avLst/>
@@ -15080,7 +15081,7 @@
         <p:spPr>
           <a:xfrm>
             <a:off x="0" y="0"/>
-            <a:ext cx="9065520" cy="6010920"/>
+            <a:ext cx="9065160" cy="6010560"/>
           </a:xfrm>
           <a:prstGeom prst="rect">
             <a:avLst/>
@@ -15772,7 +15773,7 @@
         <p:spPr>
           <a:xfrm>
             <a:off x="3717000" y="355680"/>
-            <a:ext cx="2082960" cy="708480"/>
+            <a:ext cx="2082600" cy="708120"/>
           </a:xfrm>
           <a:prstGeom prst="rect">
             <a:avLst/>
@@ -15826,7 +15827,7 @@
         <p:spPr>
           <a:xfrm>
             <a:off x="72000" y="792000"/>
-            <a:ext cx="8852040" cy="924480"/>
+            <a:ext cx="8851680" cy="924120"/>
           </a:xfrm>
           <a:prstGeom prst="rect">
             <a:avLst/>
@@ -15900,7 +15901,7 @@
         <p:spPr>
           <a:xfrm>
             <a:off x="444240" y="1447920"/>
-            <a:ext cx="8628120" cy="1443240"/>
+            <a:ext cx="8627760" cy="1442880"/>
           </a:xfrm>
           <a:prstGeom prst="rect">
             <a:avLst/>
@@ -15957,7 +15958,7 @@
         <p:spPr>
           <a:xfrm>
             <a:off x="264960" y="555120"/>
-            <a:ext cx="8659080" cy="3256920"/>
+            <a:ext cx="8658720" cy="3256560"/>
           </a:xfrm>
           <a:prstGeom prst="rect">
             <a:avLst/>
@@ -16002,7 +16003,7 @@
         <p:spPr>
           <a:xfrm>
             <a:off x="667800" y="3276720"/>
-            <a:ext cx="8181360" cy="1069200"/>
+            <a:ext cx="8181000" cy="1068840"/>
           </a:xfrm>
           <a:prstGeom prst="rect">
             <a:avLst/>
@@ -16047,7 +16048,7 @@
         <p:spPr>
           <a:xfrm>
             <a:off x="47880" y="2239560"/>
-            <a:ext cx="812160" cy="708480"/>
+            <a:ext cx="811800" cy="708120"/>
           </a:xfrm>
           <a:prstGeom prst="rect">
             <a:avLst/>
@@ -16101,7 +16102,7 @@
         <p:spPr>
           <a:xfrm>
             <a:off x="216000" y="2466000"/>
-            <a:ext cx="8636040" cy="1096920"/>
+            <a:ext cx="8635680" cy="1096560"/>
           </a:xfrm>
           <a:prstGeom prst="rect">
             <a:avLst/>
@@ -16191,7 +16192,7 @@
         <p:spPr>
           <a:xfrm>
             <a:off x="216000" y="4803480"/>
-            <a:ext cx="7986240" cy="340560"/>
+            <a:ext cx="7985880" cy="340200"/>
           </a:xfrm>
           <a:prstGeom prst="rect">
             <a:avLst/>
@@ -16225,6 +16226,19 @@
                 <a:latin typeface="Arial"/>
                 <a:ea typeface="DejaVu Sans"/>
               </a:rPr>
+              <a:t>make olddefconfig</a:t>
+            </a:r>
+            <a:br>
+              <a:rPr sz="1800"/>
+            </a:br>
+            <a:r>
+              <a:rPr b="1" lang="en-IN" sz="1800" spc="-1" strike="noStrike">
+                <a:solidFill>
+                  <a:srgbClr val="000000"/>
+                </a:solidFill>
+                <a:latin typeface="Arial"/>
+                <a:ea typeface="DejaVu Sans"/>
+              </a:rPr>
               <a:t>make -jn , make modules, make modules_install, make install</a:t>
             </a:r>
             <a:endParaRPr b="0" lang="en-US" sz="1800" spc="-1" strike="noStrike">
@@ -16245,7 +16259,7 @@
         <p:spPr>
           <a:xfrm>
             <a:off x="0" y="936000"/>
-            <a:ext cx="8888040" cy="1348200"/>
+            <a:ext cx="8887680" cy="1347840"/>
           </a:xfrm>
           <a:prstGeom prst="rect">
             <a:avLst/>
@@ -16299,7 +16313,7 @@
         <p:spPr>
           <a:xfrm>
             <a:off x="93240" y="3133440"/>
-            <a:ext cx="8902800" cy="1347840"/>
+            <a:ext cx="8902440" cy="1347480"/>
           </a:xfrm>
           <a:prstGeom prst="rect">
             <a:avLst/>
@@ -16353,7 +16367,7 @@
         <p:spPr>
           <a:xfrm>
             <a:off x="264960" y="5365800"/>
-            <a:ext cx="7697880" cy="856440"/>
+            <a:ext cx="7697520" cy="856080"/>
           </a:xfrm>
           <a:prstGeom prst="rect">
             <a:avLst/>
@@ -16503,7 +16517,7 @@
         <p:spPr>
           <a:xfrm>
             <a:off x="333360" y="2514600"/>
-            <a:ext cx="8580600" cy="1493640"/>
+            <a:ext cx="8580240" cy="1493280"/>
           </a:xfrm>
           <a:prstGeom prst="rect">
             <a:avLst/>
@@ -16616,7 +16630,7 @@
         <p:spPr>
           <a:xfrm>
             <a:off x="389880" y="324000"/>
-            <a:ext cx="3026160" cy="710280"/>
+            <a:ext cx="3025800" cy="709920"/>
           </a:xfrm>
           <a:prstGeom prst="rect">
             <a:avLst/>
@@ -16670,7 +16684,7 @@
         <p:spPr>
           <a:xfrm>
             <a:off x="432000" y="756000"/>
-            <a:ext cx="7827120" cy="708480"/>
+            <a:ext cx="7826760" cy="708120"/>
           </a:xfrm>
           <a:prstGeom prst="rect">
             <a:avLst/>
@@ -16724,7 +16738,7 @@
         <p:spPr>
           <a:xfrm>
             <a:off x="4591440" y="1612440"/>
-            <a:ext cx="906120" cy="708480"/>
+            <a:ext cx="905760" cy="708120"/>
           </a:xfrm>
           <a:prstGeom prst="rect">
             <a:avLst/>
@@ -16778,7 +16792,7 @@
         <p:spPr>
           <a:xfrm>
             <a:off x="394200" y="1896120"/>
-            <a:ext cx="8508600" cy="1096920"/>
+            <a:ext cx="8508240" cy="1096560"/>
           </a:xfrm>
           <a:prstGeom prst="rect">
             <a:avLst/>
@@ -16868,7 +16882,7 @@
         <p:spPr>
           <a:xfrm>
             <a:off x="374760" y="3748680"/>
-            <a:ext cx="1851120" cy="708480"/>
+            <a:ext cx="1850760" cy="708120"/>
           </a:xfrm>
           <a:prstGeom prst="rect">
             <a:avLst/>
@@ -16922,7 +16936,7 @@
         <p:spPr>
           <a:xfrm>
             <a:off x="392040" y="3867120"/>
-            <a:ext cx="8100000" cy="1096920"/>
+            <a:ext cx="8099640" cy="1096560"/>
           </a:xfrm>
           <a:prstGeom prst="rect">
             <a:avLst/>
@@ -17025,7 +17039,7 @@
         <p:spPr>
           <a:xfrm>
             <a:off x="367200" y="5429520"/>
-            <a:ext cx="4530240" cy="708480"/>
+            <a:ext cx="4529880" cy="708120"/>
           </a:xfrm>
           <a:prstGeom prst="rect">
             <a:avLst/>
@@ -17089,7 +17103,7 @@
         <p:spPr>
           <a:xfrm>
             <a:off x="381600" y="5041800"/>
-            <a:ext cx="8136000" cy="1059840"/>
+            <a:ext cx="8135640" cy="1059480"/>
           </a:xfrm>
           <a:prstGeom prst="rect">
             <a:avLst/>
@@ -17166,7 +17180,7 @@
         <p:spPr>
           <a:xfrm>
             <a:off x="382680" y="1254240"/>
-            <a:ext cx="6381360" cy="708480"/>
+            <a:ext cx="6381000" cy="708120"/>
           </a:xfrm>
           <a:prstGeom prst="rect">
             <a:avLst/>
@@ -17299,7 +17313,7 @@
         <p:spPr>
           <a:xfrm>
             <a:off x="120600" y="313200"/>
-            <a:ext cx="8634240" cy="1108440"/>
+            <a:ext cx="8633880" cy="1108080"/>
           </a:xfrm>
           <a:prstGeom prst="rect">
             <a:avLst/>
@@ -18282,7 +18296,7 @@
         <p:spPr>
           <a:xfrm>
             <a:off x="0" y="0"/>
-            <a:ext cx="9136080" cy="6837480"/>
+            <a:ext cx="9135720" cy="6837120"/>
           </a:xfrm>
           <a:prstGeom prst="rect">
             <a:avLst/>
@@ -18301,7 +18315,7 @@
         <p:spPr>
           <a:xfrm>
             <a:off x="4573800" y="203040"/>
-            <a:ext cx="3049200" cy="708480"/>
+            <a:ext cx="3048840" cy="708120"/>
           </a:xfrm>
           <a:prstGeom prst="rect">
             <a:avLst/>
@@ -18355,7 +18369,7 @@
         <p:spPr>
           <a:xfrm>
             <a:off x="3956040" y="901800"/>
-            <a:ext cx="1668240" cy="588960"/>
+            <a:ext cx="1667880" cy="588600"/>
           </a:xfrm>
           <a:prstGeom prst="rect">
             <a:avLst/>
@@ -18409,7 +18423,7 @@
         <p:spPr>
           <a:xfrm>
             <a:off x="4280400" y="1498680"/>
-            <a:ext cx="1539720" cy="588960"/>
+            <a:ext cx="1539360" cy="588600"/>
           </a:xfrm>
           <a:prstGeom prst="rect">
             <a:avLst/>
@@ -18463,7 +18477,7 @@
         <p:spPr>
           <a:xfrm>
             <a:off x="4412880" y="2565360"/>
-            <a:ext cx="1885320" cy="588960"/>
+            <a:ext cx="1884960" cy="588600"/>
           </a:xfrm>
           <a:prstGeom prst="rect">
             <a:avLst/>
@@ -18517,7 +18531,7 @@
         <p:spPr>
           <a:xfrm>
             <a:off x="4641480" y="3632040"/>
-            <a:ext cx="1885320" cy="588960"/>
+            <a:ext cx="1884960" cy="588600"/>
           </a:xfrm>
           <a:prstGeom prst="rect">
             <a:avLst/>
@@ -18571,7 +18585,7 @@
         <p:spPr>
           <a:xfrm>
             <a:off x="5636880" y="4699080"/>
-            <a:ext cx="669240" cy="588960"/>
+            <a:ext cx="668880" cy="588600"/>
           </a:xfrm>
           <a:prstGeom prst="rect">
             <a:avLst/>
@@ -18625,7 +18639,7 @@
         <p:spPr>
           <a:xfrm>
             <a:off x="5932080" y="5765760"/>
-            <a:ext cx="307440" cy="588960"/>
+            <a:ext cx="307080" cy="588600"/>
           </a:xfrm>
           <a:prstGeom prst="rect">
             <a:avLst/>
@@ -18679,7 +18693,7 @@
         <p:spPr>
           <a:xfrm>
             <a:off x="7000920" y="1498680"/>
-            <a:ext cx="1877760" cy="588960"/>
+            <a:ext cx="1877400" cy="588600"/>
           </a:xfrm>
           <a:prstGeom prst="rect">
             <a:avLst/>
@@ -18733,7 +18747,7 @@
         <p:spPr>
           <a:xfrm>
             <a:off x="6908400" y="2565360"/>
-            <a:ext cx="2075400" cy="588960"/>
+            <a:ext cx="2075040" cy="588600"/>
           </a:xfrm>
           <a:prstGeom prst="rect">
             <a:avLst/>
@@ -18787,7 +18801,7 @@
         <p:spPr>
           <a:xfrm>
             <a:off x="7141320" y="3632040"/>
-            <a:ext cx="1686240" cy="588960"/>
+            <a:ext cx="1685880" cy="588600"/>
           </a:xfrm>
           <a:prstGeom prst="rect">
             <a:avLst/>
@@ -18841,7 +18855,7 @@
         <p:spPr>
           <a:xfrm>
             <a:off x="7707240" y="4699080"/>
-            <a:ext cx="554400" cy="588960"/>
+            <a:ext cx="554040" cy="588600"/>
           </a:xfrm>
           <a:prstGeom prst="rect">
             <a:avLst/>
@@ -18895,7 +18909,7 @@
         <p:spPr>
           <a:xfrm>
             <a:off x="7455960" y="5765760"/>
-            <a:ext cx="1208520" cy="588960"/>
+            <a:ext cx="1208160" cy="588600"/>
           </a:xfrm>
           <a:prstGeom prst="rect">
             <a:avLst/>
@@ -18949,7 +18963,7 @@
         <p:spPr>
           <a:xfrm>
             <a:off x="5283000" y="5892840"/>
-            <a:ext cx="1021320" cy="580320"/>
+            <a:ext cx="1020960" cy="579960"/>
           </a:xfrm>
           <a:prstGeom prst="rect">
             <a:avLst/>
@@ -19037,7 +19051,7 @@
         <p:spPr>
           <a:xfrm>
             <a:off x="4066200" y="2995200"/>
-            <a:ext cx="5256360" cy="3980160"/>
+            <a:ext cx="5256000" cy="3979800"/>
           </a:xfrm>
           <a:prstGeom prst="rect">
             <a:avLst/>
@@ -19056,7 +19070,7 @@
         <p:spPr>
           <a:xfrm>
             <a:off x="2225880" y="275040"/>
-            <a:ext cx="2840400" cy="708480"/>
+            <a:ext cx="2840040" cy="708120"/>
           </a:xfrm>
           <a:prstGeom prst="rect">
             <a:avLst/>
@@ -19110,7 +19124,7 @@
         <p:spPr>
           <a:xfrm>
             <a:off x="0" y="450720"/>
-            <a:ext cx="9142560" cy="3133440"/>
+            <a:ext cx="9142200" cy="3133080"/>
           </a:xfrm>
           <a:prstGeom prst="rect">
             <a:avLst/>
@@ -19524,7 +19538,7 @@
         <p:spPr>
           <a:xfrm>
             <a:off x="65520" y="75600"/>
-            <a:ext cx="9161640" cy="2136960"/>
+            <a:ext cx="9161280" cy="2136600"/>
           </a:xfrm>
           <a:prstGeom prst="rect">
             <a:avLst/>
@@ -19760,7 +19774,7 @@
         <p:spPr>
           <a:xfrm>
             <a:off x="2286000" y="1828800"/>
-            <a:ext cx="5103720" cy="4654800"/>
+            <a:ext cx="5103360" cy="4654440"/>
           </a:xfrm>
           <a:prstGeom prst="rect">
             <a:avLst/>
@@ -19809,7 +19823,7 @@
         <p:spPr>
           <a:xfrm>
             <a:off x="228600" y="457200"/>
-            <a:ext cx="6856560" cy="600840"/>
+            <a:ext cx="6856200" cy="600480"/>
           </a:xfrm>
           <a:prstGeom prst="rect">
             <a:avLst/>
@@ -19867,7 +19881,7 @@
         <p:spPr>
           <a:xfrm>
             <a:off x="460800" y="1143000"/>
-            <a:ext cx="7995960" cy="4629960"/>
+            <a:ext cx="7995600" cy="4629600"/>
           </a:xfrm>
           <a:prstGeom prst="rect">
             <a:avLst/>
@@ -19920,7 +19934,7 @@
         <p:spPr>
           <a:xfrm>
             <a:off x="0" y="0"/>
-            <a:ext cx="9136080" cy="6837480"/>
+            <a:ext cx="9135720" cy="6837120"/>
           </a:xfrm>
           <a:prstGeom prst="rect">
             <a:avLst/>
@@ -19939,7 +19953,7 @@
         <p:spPr>
           <a:xfrm>
             <a:off x="2285640" y="658440"/>
-            <a:ext cx="5022000" cy="708480"/>
+            <a:ext cx="5021640" cy="708120"/>
           </a:xfrm>
           <a:prstGeom prst="rect">
             <a:avLst/>
@@ -19993,7 +20007,7 @@
         <p:spPr>
           <a:xfrm>
             <a:off x="1398600" y="1384200"/>
-            <a:ext cx="7012080" cy="708480"/>
+            <a:ext cx="7011720" cy="708120"/>
           </a:xfrm>
           <a:prstGeom prst="rect">
             <a:avLst/>
@@ -20047,7 +20061,7 @@
         <p:spPr>
           <a:xfrm>
             <a:off x="3040920" y="2034360"/>
-            <a:ext cx="2143080" cy="708480"/>
+            <a:ext cx="2142720" cy="708120"/>
           </a:xfrm>
           <a:prstGeom prst="rect">
             <a:avLst/>
@@ -20111,7 +20125,7 @@
         <p:spPr>
           <a:xfrm>
             <a:off x="3005280" y="2601360"/>
-            <a:ext cx="2430360" cy="708480"/>
+            <a:ext cx="2430000" cy="708120"/>
           </a:xfrm>
           <a:prstGeom prst="rect">
             <a:avLst/>
@@ -20175,7 +20189,7 @@
         <p:spPr>
           <a:xfrm>
             <a:off x="3029760" y="3168720"/>
-            <a:ext cx="2237400" cy="708480"/>
+            <a:ext cx="2237040" cy="708120"/>
           </a:xfrm>
           <a:prstGeom prst="rect">
             <a:avLst/>
@@ -20239,7 +20253,7 @@
         <p:spPr>
           <a:xfrm>
             <a:off x="2969640" y="3664080"/>
-            <a:ext cx="2573640" cy="708480"/>
+            <a:ext cx="2573280" cy="708120"/>
           </a:xfrm>
           <a:prstGeom prst="rect">
             <a:avLst/>
@@ -20333,7 +20347,7 @@
         <p:spPr>
           <a:xfrm>
             <a:off x="0" y="457200"/>
-            <a:ext cx="8913960" cy="3672360"/>
+            <a:ext cx="8913600" cy="3672000"/>
           </a:xfrm>
           <a:prstGeom prst="rect">
             <a:avLst/>
@@ -20843,7 +20857,7 @@
         <p:spPr>
           <a:xfrm>
             <a:off x="38520" y="73800"/>
-            <a:ext cx="2102040" cy="600840"/>
+            <a:ext cx="2101680" cy="600480"/>
           </a:xfrm>
           <a:prstGeom prst="rect">
             <a:avLst/>
@@ -20927,7 +20941,7 @@
         <p:spPr>
           <a:xfrm>
             <a:off x="228600" y="228600"/>
-            <a:ext cx="5713560" cy="600840"/>
+            <a:ext cx="5713200" cy="600480"/>
           </a:xfrm>
           <a:prstGeom prst="rect">
             <a:avLst/>
@@ -20985,7 +20999,7 @@
         <p:spPr>
           <a:xfrm>
             <a:off x="685800" y="1600200"/>
-            <a:ext cx="7927920" cy="3875760"/>
+            <a:ext cx="7927560" cy="3875400"/>
           </a:xfrm>
           <a:prstGeom prst="rect">
             <a:avLst/>
@@ -21038,7 +21052,7 @@
         <p:spPr>
           <a:xfrm>
             <a:off x="20880" y="727920"/>
-            <a:ext cx="9136440" cy="5414040"/>
+            <a:ext cx="9136080" cy="5413680"/>
           </a:xfrm>
           <a:prstGeom prst="rect">
             <a:avLst/>
@@ -21087,7 +21101,7 @@
         <p:spPr>
           <a:xfrm>
             <a:off x="72000" y="144000"/>
-            <a:ext cx="8994240" cy="4179960"/>
+            <a:ext cx="8993880" cy="4179600"/>
           </a:xfrm>
           <a:prstGeom prst="rect">
             <a:avLst/>
@@ -21493,7 +21507,7 @@
         <p:spPr>
           <a:xfrm>
             <a:off x="-90720" y="94680"/>
-            <a:ext cx="9083520" cy="6226200"/>
+            <a:ext cx="9083160" cy="6225840"/>
           </a:xfrm>
           <a:prstGeom prst="rect">
             <a:avLst/>
@@ -21913,7 +21927,7 @@
         <p:spPr>
           <a:xfrm>
             <a:off x="145080" y="72000"/>
-            <a:ext cx="8992800" cy="6226200"/>
+            <a:ext cx="8992440" cy="6225840"/>
           </a:xfrm>
           <a:prstGeom prst="rect">
             <a:avLst/>
@@ -22308,7 +22322,7 @@
       </p:grpSpPr>
       <p:pic>
         <p:nvPicPr>
-          <p:cNvPr id="215" name="Picture 1" descr=""/>
+          <p:cNvPr id="215" name="" descr=""/>
           <p:cNvPicPr/>
           <p:nvPr/>
         </p:nvPicPr>
@@ -22318,8 +22332,8 @@
         </p:blipFill>
         <p:spPr>
           <a:xfrm>
-            <a:off x="0" y="0"/>
-            <a:ext cx="9136080" cy="6837480"/>
+            <a:off x="2860200" y="51840"/>
+            <a:ext cx="5715000" cy="6666120"/>
           </a:xfrm>
           <a:prstGeom prst="rect">
             <a:avLst/>
@@ -22331,14 +22345,14 @@
       </p:pic>
       <p:sp>
         <p:nvSpPr>
-          <p:cNvPr id="216" name="CustomShape 1"/>
-          <p:cNvSpPr/>
+          <p:cNvPr id="216" name=""/>
+          <p:cNvSpPr txBox="1"/>
           <p:nvPr/>
         </p:nvSpPr>
         <p:spPr>
           <a:xfrm>
-            <a:off x="4369680" y="254160"/>
-            <a:ext cx="828360" cy="708480"/>
+            <a:off x="228600" y="228600"/>
+            <a:ext cx="2286000" cy="685800"/>
           </a:xfrm>
           <a:prstGeom prst="rect">
             <a:avLst/>
@@ -22348,344 +22362,21 @@
             <a:noFill/>
           </a:ln>
         </p:spPr>
-        <p:style>
-          <a:lnRef idx="0"/>
-          <a:fillRef idx="0"/>
-          <a:effectRef idx="0"/>
-          <a:fontRef idx="minor"/>
-        </p:style>
-        <p:txBody>
-          <a:bodyPr wrap="none" lIns="0" rIns="0" tIns="0" bIns="0" anchor="t">
-            <a:noAutofit/>
-          </a:bodyPr>
-          <a:p>
-            <a:pPr>
-              <a:lnSpc>
-                <a:spcPts val="975"/>
-              </a:lnSpc>
-            </a:pPr>
-            <a:r>
-              <a:rPr b="1" lang="en-US" sz="2240" spc="-1" strike="noStrike">
-                <a:solidFill>
-                  <a:srgbClr val="000000"/>
-                </a:solidFill>
-                <a:latin typeface="Arial Bold"/>
-                <a:ea typeface="DejaVu Sans"/>
-              </a:rPr>
-              <a:t>GRUB</a:t>
-            </a:r>
-            <a:endParaRPr b="0" lang="en-US" sz="2240" spc="-1" strike="noStrike">
-              <a:solidFill>
-                <a:srgbClr val="000000"/>
-              </a:solidFill>
-              <a:latin typeface="Arial"/>
-            </a:endParaRPr>
-          </a:p>
-        </p:txBody>
-      </p:sp>
-      <p:sp>
-        <p:nvSpPr>
-          <p:cNvPr id="217" name=""/>
-          <p:cNvSpPr/>
-          <p:nvPr/>
-        </p:nvSpPr>
-        <p:spPr>
-          <a:xfrm>
-            <a:off x="130320" y="457200"/>
-            <a:ext cx="8555040" cy="3672720"/>
-          </a:xfrm>
-          <a:prstGeom prst="rect">
-            <a:avLst/>
-          </a:prstGeom>
-          <a:noFill/>
-          <a:ln w="0">
-            <a:noFill/>
-          </a:ln>
-        </p:spPr>
-        <p:style>
-          <a:lnRef idx="0"/>
-          <a:fillRef idx="0"/>
-          <a:effectRef idx="0"/>
-          <a:fontRef idx="minor"/>
-        </p:style>
         <p:txBody>
           <a:bodyPr lIns="90000" rIns="90000" tIns="45000" bIns="45000" anchor="t">
             <a:noAutofit/>
           </a:bodyPr>
           <a:p>
-            <a:pPr>
-              <a:lnSpc>
-                <a:spcPct val="100000"/>
-              </a:lnSpc>
-            </a:pPr>
-            <a:r>
-              <a:rPr b="0" lang="en-US" sz="1800" spc="-1" strike="noStrike">
-                <a:solidFill>
-                  <a:srgbClr val="000000"/>
-                </a:solidFill>
-                <a:latin typeface="Arial"/>
-                <a:ea typeface="DejaVu Sans"/>
-              </a:rPr>
-              <a:t>Grand Unified Bootloader, from the GNU project</a:t>
-            </a:r>
-            <a:br>
-              <a:rPr sz="1800"/>
-            </a:br>
-            <a:endParaRPr b="0" lang="en-US" sz="1800" spc="-1" strike="noStrike">
-              <a:solidFill>
-                <a:srgbClr val="000000"/>
-              </a:solidFill>
-              <a:latin typeface="Arial"/>
-            </a:endParaRPr>
-          </a:p>
-          <a:p>
-            <a:pPr>
-              <a:lnSpc>
-                <a:spcPct val="100000"/>
-              </a:lnSpc>
-            </a:pPr>
-            <a:r>
-              <a:rPr b="0" lang="en-US" sz="1800" spc="-1" strike="noStrike">
-                <a:solidFill>
-                  <a:srgbClr val="000000"/>
-                </a:solidFill>
-                <a:latin typeface="Arial"/>
-                <a:ea typeface="DejaVu Sans"/>
-              </a:rPr>
-              <a:t>▶ </a:t>
-            </a:r>
-            <a:r>
-              <a:rPr b="0" lang="en-US" sz="1800" spc="-1" strike="noStrike">
-                <a:solidFill>
-                  <a:srgbClr val="000000"/>
-                </a:solidFill>
-                <a:latin typeface="Arial"/>
-                <a:ea typeface="DejaVu Sans"/>
-              </a:rPr>
-              <a:t>De-facto standard in most Linux distributions for x86 platforms</a:t>
-            </a:r>
-            <a:endParaRPr b="0" lang="en-US" sz="1800" spc="-1" strike="noStrike">
-              <a:solidFill>
-                <a:srgbClr val="000000"/>
-              </a:solidFill>
-              <a:latin typeface="Arial"/>
-            </a:endParaRPr>
-          </a:p>
-          <a:p>
-            <a:pPr>
-              <a:lnSpc>
-                <a:spcPct val="100000"/>
-              </a:lnSpc>
-            </a:pPr>
-            <a:r>
-              <a:rPr b="0" lang="en-US" sz="1800" spc="-1" strike="noStrike">
-                <a:solidFill>
-                  <a:srgbClr val="000000"/>
-                </a:solidFill>
-                <a:latin typeface="Arial"/>
-                <a:ea typeface="DejaVu Sans"/>
-              </a:rPr>
-              <a:t>▶ </a:t>
-            </a:r>
-            <a:r>
-              <a:rPr b="0" lang="en-US" sz="1800" spc="-1" strike="noStrike">
-                <a:solidFill>
-                  <a:srgbClr val="000000"/>
-                </a:solidFill>
-                <a:latin typeface="Arial"/>
-                <a:ea typeface="DejaVu Sans"/>
-              </a:rPr>
-              <a:t>Supports x86 legacy and UEFI systems</a:t>
-            </a:r>
-            <a:endParaRPr b="0" lang="en-US" sz="1800" spc="-1" strike="noStrike">
-              <a:solidFill>
-                <a:srgbClr val="000000"/>
-              </a:solidFill>
-              <a:latin typeface="Arial"/>
-            </a:endParaRPr>
-          </a:p>
-          <a:p>
-            <a:pPr>
-              <a:lnSpc>
-                <a:spcPct val="100000"/>
-              </a:lnSpc>
-            </a:pPr>
-            <a:r>
-              <a:rPr b="0" lang="en-US" sz="1800" spc="-1" strike="noStrike">
-                <a:solidFill>
-                  <a:srgbClr val="000000"/>
-                </a:solidFill>
-                <a:latin typeface="Arial"/>
-                <a:ea typeface="DejaVu Sans"/>
-              </a:rPr>
-              <a:t>▶ </a:t>
-            </a:r>
-            <a:r>
-              <a:rPr b="0" lang="en-US" sz="1800" spc="-1" strike="noStrike">
-                <a:solidFill>
-                  <a:srgbClr val="000000"/>
-                </a:solidFill>
-                <a:latin typeface="Arial"/>
-                <a:ea typeface="DejaVu Sans"/>
-              </a:rPr>
-              <a:t>Can read many filesystem formats to load the kernel image, modules and configuration</a:t>
-            </a:r>
-            <a:endParaRPr b="0" lang="en-US" sz="1800" spc="-1" strike="noStrike">
-              <a:solidFill>
-                <a:srgbClr val="000000"/>
-              </a:solidFill>
-              <a:latin typeface="Arial"/>
-            </a:endParaRPr>
-          </a:p>
-          <a:p>
-            <a:pPr>
-              <a:lnSpc>
-                <a:spcPct val="100000"/>
-              </a:lnSpc>
-            </a:pPr>
-            <a:r>
-              <a:rPr b="0" lang="en-US" sz="1800" spc="-1" strike="noStrike">
-                <a:solidFill>
-                  <a:srgbClr val="000000"/>
-                </a:solidFill>
-                <a:latin typeface="Arial"/>
-                <a:ea typeface="DejaVu Sans"/>
-              </a:rPr>
-              <a:t>▶ </a:t>
-            </a:r>
-            <a:r>
-              <a:rPr b="0" lang="en-US" sz="1800" spc="-1" strike="noStrike">
-                <a:solidFill>
-                  <a:srgbClr val="000000"/>
-                </a:solidFill>
-                <a:latin typeface="Arial"/>
-                <a:ea typeface="DejaVu Sans"/>
-              </a:rPr>
-              <a:t>Provides a menu and powerful shell with various commands</a:t>
-            </a:r>
-            <a:endParaRPr b="0" lang="en-US" sz="1800" spc="-1" strike="noStrike">
-              <a:solidFill>
-                <a:srgbClr val="000000"/>
-              </a:solidFill>
-              <a:latin typeface="Arial"/>
-            </a:endParaRPr>
-          </a:p>
-          <a:p>
-            <a:pPr>
-              <a:lnSpc>
-                <a:spcPct val="100000"/>
-              </a:lnSpc>
-            </a:pPr>
-            <a:r>
-              <a:rPr b="0" lang="en-US" sz="1800" spc="-1" strike="noStrike">
-                <a:solidFill>
-                  <a:srgbClr val="000000"/>
-                </a:solidFill>
-                <a:latin typeface="Arial"/>
-                <a:ea typeface="DejaVu Sans"/>
-              </a:rPr>
-              <a:t>▶ </a:t>
-            </a:r>
-            <a:r>
-              <a:rPr b="0" lang="en-US" sz="1800" spc="-1" strike="noStrike">
-                <a:solidFill>
-                  <a:srgbClr val="000000"/>
-                </a:solidFill>
-                <a:latin typeface="Arial"/>
-                <a:ea typeface="DejaVu Sans"/>
-              </a:rPr>
-              <a:t>Can load kernel images over the network</a:t>
-            </a:r>
-            <a:endParaRPr b="0" lang="en-US" sz="1800" spc="-1" strike="noStrike">
-              <a:solidFill>
-                <a:srgbClr val="000000"/>
-              </a:solidFill>
-              <a:latin typeface="Arial"/>
-            </a:endParaRPr>
-          </a:p>
-          <a:p>
-            <a:pPr>
-              <a:lnSpc>
-                <a:spcPct val="100000"/>
-              </a:lnSpc>
-            </a:pPr>
-            <a:r>
-              <a:rPr b="0" lang="en-US" sz="1800" spc="-1" strike="noStrike">
-                <a:solidFill>
-                  <a:srgbClr val="000000"/>
-                </a:solidFill>
-                <a:latin typeface="Arial"/>
-                <a:ea typeface="DejaVu Sans"/>
-              </a:rPr>
-              <a:t>▶ </a:t>
-            </a:r>
-            <a:r>
-              <a:rPr b="0" lang="en-US" sz="1800" spc="-1" strike="noStrike">
-                <a:solidFill>
-                  <a:srgbClr val="000000"/>
-                </a:solidFill>
-                <a:latin typeface="Arial"/>
-                <a:ea typeface="DejaVu Sans"/>
-              </a:rPr>
-              <a:t>Also supports ARM, ARM64, RISC-V, PowerPC, but less popular than other</a:t>
-            </a:r>
-            <a:endParaRPr b="0" lang="en-US" sz="1800" spc="-1" strike="noStrike">
-              <a:solidFill>
-                <a:srgbClr val="000000"/>
-              </a:solidFill>
-              <a:latin typeface="Arial"/>
-            </a:endParaRPr>
-          </a:p>
-          <a:p>
-            <a:pPr>
-              <a:lnSpc>
-                <a:spcPct val="100000"/>
-              </a:lnSpc>
-            </a:pPr>
-            <a:r>
-              <a:rPr b="0" lang="en-US" sz="1800" spc="-1" strike="noStrike">
-                <a:solidFill>
-                  <a:srgbClr val="000000"/>
-                </a:solidFill>
-                <a:latin typeface="Arial"/>
-                <a:ea typeface="DejaVu Sans"/>
-              </a:rPr>
-              <a:t>bootloaders on those platforms</a:t>
-            </a:r>
-            <a:endParaRPr b="0" lang="en-US" sz="1800" spc="-1" strike="noStrike">
-              <a:solidFill>
-                <a:srgbClr val="000000"/>
-              </a:solidFill>
-              <a:latin typeface="Arial"/>
-            </a:endParaRPr>
-          </a:p>
-          <a:p>
-            <a:pPr>
-              <a:lnSpc>
-                <a:spcPct val="100000"/>
-              </a:lnSpc>
-            </a:pPr>
-            <a:r>
-              <a:rPr b="0" lang="en-US" sz="1800" spc="-1" strike="noStrike">
-                <a:solidFill>
-                  <a:srgbClr val="000000"/>
-                </a:solidFill>
-                <a:latin typeface="Arial"/>
-                <a:ea typeface="DejaVu Sans"/>
-              </a:rPr>
-              <a:t>▶ </a:t>
-            </a:r>
-            <a:r>
-              <a:rPr b="0" lang="en-US" sz="1800" spc="-1" strike="noStrike">
-                <a:solidFill>
-                  <a:srgbClr val="000000"/>
-                </a:solidFill>
-                <a:latin typeface="Arial"/>
-                <a:ea typeface="DejaVu Sans"/>
-              </a:rPr>
-              <a:t>https://www.gnu.org/software/grub/</a:t>
-            </a:r>
-            <a:endParaRPr b="0" lang="en-US" sz="1800" spc="-1" strike="noStrike">
+            <a:r>
+              <a:rPr b="1" lang="en-US" sz="1800" spc="-1" strike="noStrike">
+                <a:solidFill>
+                  <a:srgbClr val="000000"/>
+                </a:solidFill>
+                <a:latin typeface="Arial"/>
+              </a:rPr>
+              <a:t>X86 Boot Process</a:t>
+            </a:r>
+            <a:endParaRPr b="1" lang="en-US" sz="1800" spc="-1" strike="noStrike">
               <a:solidFill>
                 <a:srgbClr val="000000"/>
               </a:solidFill>
@@ -22694,29 +22385,6 @@
           </a:p>
         </p:txBody>
       </p:sp>
-      <p:pic>
-        <p:nvPicPr>
-          <p:cNvPr id="218" name="" descr=""/>
-          <p:cNvPicPr/>
-          <p:nvPr/>
-        </p:nvPicPr>
-        <p:blipFill>
-          <a:blip r:embed="rId2"/>
-          <a:stretch/>
-        </p:blipFill>
-        <p:spPr>
-          <a:xfrm>
-            <a:off x="1600200" y="3429000"/>
-            <a:ext cx="6170760" cy="3256560"/>
-          </a:xfrm>
-          <a:prstGeom prst="rect">
-            <a:avLst/>
-          </a:prstGeom>
-          <a:ln w="0">
-            <a:noFill/>
-          </a:ln>
-        </p:spPr>
-      </p:pic>
     </p:spTree>
   </p:cSld>
   <mc:AlternateContent>
@@ -22749,7 +22417,7 @@
       </p:grpSpPr>
       <p:pic>
         <p:nvPicPr>
-          <p:cNvPr id="219" name="Picture 1" descr=""/>
+          <p:cNvPr id="217" name="Picture 1" descr=""/>
           <p:cNvPicPr/>
           <p:nvPr/>
         </p:nvPicPr>
@@ -22760,7 +22428,7 @@
         <p:spPr>
           <a:xfrm>
             <a:off x="0" y="0"/>
-            <a:ext cx="9136080" cy="6837480"/>
+            <a:ext cx="9135720" cy="6837120"/>
           </a:xfrm>
           <a:prstGeom prst="rect">
             <a:avLst/>
@@ -22772,14 +22440,14 @@
       </p:pic>
       <p:sp>
         <p:nvSpPr>
-          <p:cNvPr id="220" name="CustomShape 1"/>
+          <p:cNvPr id="218" name="CustomShape 1"/>
           <p:cNvSpPr/>
           <p:nvPr/>
         </p:nvSpPr>
         <p:spPr>
           <a:xfrm>
-            <a:off x="3277800" y="431640"/>
-            <a:ext cx="2961360" cy="708480"/>
+            <a:off x="4369680" y="254160"/>
+            <a:ext cx="828000" cy="708120"/>
           </a:xfrm>
           <a:prstGeom prst="rect">
             <a:avLst/>
@@ -22813,7 +22481,7 @@
                 <a:latin typeface="Arial Bold"/>
                 <a:ea typeface="DejaVu Sans"/>
               </a:rPr>
-              <a:t>Initialization Overview</a:t>
+              <a:t>GRUB</a:t>
             </a:r>
             <a:endParaRPr b="0" lang="en-US" sz="2240" spc="-1" strike="noStrike">
               <a:solidFill>
@@ -22826,14 +22494,14 @@
       </p:sp>
       <p:sp>
         <p:nvSpPr>
-          <p:cNvPr id="221" name="CustomShape 2"/>
+          <p:cNvPr id="219" name=""/>
           <p:cNvSpPr/>
           <p:nvPr/>
         </p:nvSpPr>
         <p:spPr>
           <a:xfrm>
-            <a:off x="253080" y="651600"/>
-            <a:ext cx="8506800" cy="1443240"/>
+            <a:off x="130320" y="457200"/>
+            <a:ext cx="8554680" cy="3672360"/>
           </a:xfrm>
           <a:prstGeom prst="rect">
             <a:avLst/>
@@ -22850,7 +22518,7 @@
           <a:fontRef idx="minor"/>
         </p:style>
         <p:txBody>
-          <a:bodyPr wrap="none" lIns="0" rIns="0" tIns="0" bIns="0" anchor="t">
+          <a:bodyPr lIns="90000" rIns="90000" tIns="45000" bIns="45000" anchor="t">
             <a:noAutofit/>
           </a:bodyPr>
           <a:p>
@@ -22860,16 +22528,19 @@
               </a:lnSpc>
             </a:pPr>
             <a:r>
-              <a:rPr b="0" lang="en-US" sz="2230" spc="-1" strike="noStrike">
-                <a:solidFill>
-                  <a:srgbClr val="000000"/>
-                </a:solidFill>
-                <a:latin typeface="Arial"/>
-                <a:ea typeface="DejaVu Sans"/>
-              </a:rPr>
-              <a:t>When the operating system starts, the kernel runs /sbin/init. This can</a:t>
-            </a:r>
-            <a:endParaRPr b="0" lang="en-US" sz="2230" spc="-1" strike="noStrike">
+              <a:rPr b="0" lang="en-US" sz="1800" spc="-1" strike="noStrike">
+                <a:solidFill>
+                  <a:srgbClr val="000000"/>
+                </a:solidFill>
+                <a:latin typeface="Arial"/>
+                <a:ea typeface="DejaVu Sans"/>
+              </a:rPr>
+              <a:t>Grand Unified Bootloader, from the GNU project</a:t>
+            </a:r>
+            <a:br>
+              <a:rPr sz="1800"/>
+            </a:br>
+            <a:endParaRPr b="0" lang="en-US" sz="1800" spc="-1" strike="noStrike">
               <a:solidFill>
                 <a:srgbClr val="000000"/>
               </a:solidFill>
@@ -22883,89 +22554,32 @@
               </a:lnSpc>
             </a:pPr>
             <a:r>
-              <a:rPr b="0" lang="en-US" sz="2230" spc="-1" strike="noStrike">
-                <a:solidFill>
-                  <a:srgbClr val="000000"/>
-                </a:solidFill>
-                <a:latin typeface="Arial"/>
-                <a:ea typeface="DejaVu Sans"/>
-              </a:rPr>
-              <a:t>be either a script or a program, but typically it is a program that</a:t>
-            </a:r>
-            <a:endParaRPr b="0" lang="en-US" sz="2230" spc="-1" strike="noStrike">
-              <a:solidFill>
-                <a:srgbClr val="000000"/>
-              </a:solidFill>
-              <a:latin typeface="Arial"/>
-            </a:endParaRPr>
-          </a:p>
-          <a:p>
-            <a:pPr>
-              <a:lnSpc>
-                <a:spcPts val="1006"/>
-              </a:lnSpc>
-            </a:pPr>
-            <a:endParaRPr b="0" lang="en-US" sz="2230" spc="-1" strike="noStrike">
-              <a:solidFill>
-                <a:srgbClr val="000000"/>
-              </a:solidFill>
-              <a:latin typeface="Arial"/>
-            </a:endParaRPr>
-          </a:p>
-          <a:p>
-            <a:pPr>
-              <a:lnSpc>
-                <a:spcPts val="1006"/>
-              </a:lnSpc>
-            </a:pPr>
-            <a:r>
-              <a:rPr b="0" lang="en-US" sz="2230" spc="-1" strike="noStrike">
-                <a:solidFill>
-                  <a:srgbClr val="000000"/>
-                </a:solidFill>
-                <a:latin typeface="Arial"/>
-                <a:ea typeface="DejaVu Sans"/>
-              </a:rPr>
-              <a:t>processes the statements in /etc/initab.</a:t>
-            </a:r>
-            <a:endParaRPr b="0" lang="en-US" sz="2230" spc="-1" strike="noStrike">
-              <a:solidFill>
-                <a:srgbClr val="000000"/>
-              </a:solidFill>
-              <a:latin typeface="Arial"/>
-            </a:endParaRPr>
-          </a:p>
-        </p:txBody>
-      </p:sp>
-      <p:sp>
-        <p:nvSpPr>
-          <p:cNvPr id="222" name="CustomShape 3"/>
-          <p:cNvSpPr/>
-          <p:nvPr/>
-        </p:nvSpPr>
-        <p:spPr>
-          <a:xfrm>
-            <a:off x="274320" y="1698480"/>
-            <a:ext cx="8604360" cy="1465200"/>
-          </a:xfrm>
-          <a:prstGeom prst="rect">
-            <a:avLst/>
-          </a:prstGeom>
-          <a:noFill/>
-          <a:ln w="0">
-            <a:noFill/>
-          </a:ln>
-        </p:spPr>
-        <p:style>
-          <a:lnRef idx="0"/>
-          <a:fillRef idx="0"/>
-          <a:effectRef idx="0"/>
-          <a:fontRef idx="minor"/>
-        </p:style>
-        <p:txBody>
-          <a:bodyPr wrap="none" lIns="0" rIns="0" tIns="0" bIns="0" anchor="t">
-            <a:noAutofit/>
-          </a:bodyPr>
+              <a:rPr b="0" lang="en-US" sz="1800" spc="-1" strike="noStrike">
+                <a:solidFill>
+                  <a:srgbClr val="000000"/>
+                </a:solidFill>
+                <a:latin typeface="Arial"/>
+                <a:ea typeface="DejaVu Sans"/>
+              </a:rPr>
+              <a:t>▶ </a:t>
+            </a:r>
+            <a:r>
+              <a:rPr b="0" lang="en-US" sz="1800" spc="-1" strike="noStrike">
+                <a:solidFill>
+                  <a:srgbClr val="000000"/>
+                </a:solidFill>
+                <a:latin typeface="Arial"/>
+                <a:ea typeface="DejaVu Sans"/>
+              </a:rPr>
+              <a:t>De-facto standard in most Linux distributions for x86 platforms</a:t>
+            </a:r>
+            <a:endParaRPr b="0" lang="en-US" sz="1800" spc="-1" strike="noStrike">
+              <a:solidFill>
+                <a:srgbClr val="000000"/>
+              </a:solidFill>
+              <a:latin typeface="Arial"/>
+            </a:endParaRPr>
+          </a:p>
           <a:p>
             <a:pPr>
               <a:lnSpc>
@@ -22973,16 +22587,26 @@
               </a:lnSpc>
             </a:pPr>
             <a:r>
-              <a:rPr b="0" lang="en-US" sz="2230" spc="-1" strike="noStrike">
-                <a:solidFill>
-                  <a:srgbClr val="000000"/>
-                </a:solidFill>
-                <a:latin typeface="Arial"/>
-                <a:ea typeface="DejaVu Sans"/>
-              </a:rPr>
-              <a:t>The default inittab file tells init to run the commands in the file</a:t>
-            </a:r>
-            <a:endParaRPr b="0" lang="en-US" sz="2230" spc="-1" strike="noStrike">
+              <a:rPr b="0" lang="en-US" sz="1800" spc="-1" strike="noStrike">
+                <a:solidFill>
+                  <a:srgbClr val="000000"/>
+                </a:solidFill>
+                <a:latin typeface="Arial"/>
+                <a:ea typeface="DejaVu Sans"/>
+              </a:rPr>
+              <a:t>▶ </a:t>
+            </a:r>
+            <a:r>
+              <a:rPr b="0" lang="en-US" sz="1800" spc="-1" strike="noStrike">
+                <a:solidFill>
+                  <a:srgbClr val="000000"/>
+                </a:solidFill>
+                <a:latin typeface="Arial"/>
+                <a:ea typeface="DejaVu Sans"/>
+              </a:rPr>
+              <a:t>Supports x86 legacy and UEFI systems</a:t>
+            </a:r>
+            <a:endParaRPr b="0" lang="en-US" sz="1800" spc="-1" strike="noStrike">
               <a:solidFill>
                 <a:srgbClr val="000000"/>
               </a:solidFill>
@@ -22996,165 +22620,181 @@
               </a:lnSpc>
             </a:pPr>
             <a:r>
-              <a:rPr b="0" lang="en-US" sz="2230" spc="-1" strike="noStrike">
-                <a:solidFill>
-                  <a:srgbClr val="000000"/>
-                </a:solidFill>
-                <a:latin typeface="Arial"/>
-                <a:ea typeface="DejaVu Sans"/>
-              </a:rPr>
-              <a:t>/etc/rc.d/rcS. In addition, init spawns programs to present login</a:t>
-            </a:r>
-            <a:endParaRPr b="0" lang="en-US" sz="2230" spc="-1" strike="noStrike">
-              <a:solidFill>
-                <a:srgbClr val="000000"/>
-              </a:solidFill>
-              <a:latin typeface="Arial"/>
-            </a:endParaRPr>
-          </a:p>
-          <a:p>
-            <a:pPr>
-              <a:lnSpc>
-                <a:spcPts val="1023"/>
-              </a:lnSpc>
-            </a:pPr>
-            <a:endParaRPr b="0" lang="en-US" sz="2230" spc="-1" strike="noStrike">
-              <a:solidFill>
-                <a:srgbClr val="000000"/>
-              </a:solidFill>
-              <a:latin typeface="Arial"/>
-            </a:endParaRPr>
-          </a:p>
-          <a:p>
-            <a:pPr>
-              <a:lnSpc>
-                <a:spcPts val="1023"/>
-              </a:lnSpc>
-            </a:pPr>
-            <a:endParaRPr b="0" lang="en-US" sz="2230" spc="-1" strike="noStrike">
-              <a:solidFill>
-                <a:srgbClr val="000000"/>
-              </a:solidFill>
-              <a:latin typeface="Arial"/>
-            </a:endParaRPr>
-          </a:p>
-          <a:p>
-            <a:pPr>
-              <a:lnSpc>
-                <a:spcPts val="1023"/>
-              </a:lnSpc>
-            </a:pPr>
-            <a:r>
-              <a:rPr b="0" lang="en-US" sz="2230" spc="-1" strike="noStrike">
-                <a:solidFill>
-                  <a:srgbClr val="000000"/>
-                </a:solidFill>
-                <a:latin typeface="Arial"/>
-                <a:ea typeface="DejaVu Sans"/>
-              </a:rPr>
-              <a:t>prompts on two virtual terminals.</a:t>
-            </a:r>
-            <a:endParaRPr b="0" lang="en-US" sz="2230" spc="-1" strike="noStrike">
-              <a:solidFill>
-                <a:srgbClr val="000000"/>
-              </a:solidFill>
-              <a:latin typeface="Arial"/>
-            </a:endParaRPr>
-          </a:p>
-          <a:p>
-            <a:pPr>
-              <a:lnSpc>
-                <a:spcPts val="1023"/>
-              </a:lnSpc>
-            </a:pPr>
-            <a:endParaRPr b="0" lang="en-US" sz="2230" spc="-1" strike="noStrike">
-              <a:solidFill>
-                <a:srgbClr val="000000"/>
-              </a:solidFill>
-              <a:latin typeface="Arial"/>
-            </a:endParaRPr>
-          </a:p>
-          <a:p>
-            <a:pPr>
-              <a:lnSpc>
-                <a:spcPts val="1023"/>
-              </a:lnSpc>
-            </a:pPr>
-            <a:endParaRPr b="0" lang="en-US" sz="2230" spc="-1" strike="noStrike">
-              <a:solidFill>
-                <a:srgbClr val="000000"/>
-              </a:solidFill>
-              <a:latin typeface="Arial"/>
-            </a:endParaRPr>
-          </a:p>
-          <a:p>
-            <a:pPr>
-              <a:lnSpc>
-                <a:spcPts val="1023"/>
-              </a:lnSpc>
-            </a:pPr>
-            <a:endParaRPr b="0" lang="en-US" sz="2230" spc="-1" strike="noStrike">
-              <a:solidFill>
-                <a:srgbClr val="000000"/>
-              </a:solidFill>
-              <a:latin typeface="Arial"/>
-            </a:endParaRPr>
-          </a:p>
-          <a:p>
-            <a:pPr>
-              <a:lnSpc>
-                <a:spcPts val="1023"/>
-              </a:lnSpc>
-              <a:spcBef>
-                <a:spcPts val="1191"/>
-              </a:spcBef>
-              <a:spcAft>
-                <a:spcPts val="992"/>
-              </a:spcAft>
-            </a:pPr>
-            <a:r>
-              <a:rPr b="0" lang="en-IN" sz="2230" spc="-1" strike="noStrike">
-                <a:solidFill>
-                  <a:srgbClr val="000000"/>
-                </a:solidFill>
-                <a:latin typeface="Arial"/>
-                <a:ea typeface="DejaVu Sans"/>
-              </a:rPr>
-              <a:t>In Ubuntu: systemd is in use, but /etc/rc0.d still exists for</a:t>
-            </a:r>
-            <a:endParaRPr b="0" lang="en-US" sz="2230" spc="-1" strike="noStrike">
-              <a:solidFill>
-                <a:srgbClr val="000000"/>
-              </a:solidFill>
-              <a:latin typeface="Arial"/>
-            </a:endParaRPr>
-          </a:p>
-          <a:p>
-            <a:pPr>
-              <a:lnSpc>
-                <a:spcPts val="1023"/>
-              </a:lnSpc>
-              <a:spcBef>
-                <a:spcPts val="1191"/>
-              </a:spcBef>
-              <a:spcAft>
-                <a:spcPts val="992"/>
-              </a:spcAft>
-            </a:pPr>
-            <a:br>
-              <a:rPr sz="2230"/>
-            </a:br>
-            <a:r>
-              <a:rPr b="0" lang="en-IN" sz="2230" spc="-1" strike="noStrike">
-                <a:solidFill>
-                  <a:srgbClr val="000000"/>
-                </a:solidFill>
-                <a:latin typeface="Arial"/>
-                <a:ea typeface="DejaVu Sans"/>
-              </a:rPr>
-              <a:t>compatibility reasons.</a:t>
-            </a:r>
-            <a:endParaRPr b="0" lang="en-US" sz="2230" spc="-1" strike="noStrike">
+              <a:rPr b="0" lang="en-US" sz="1800" spc="-1" strike="noStrike">
+                <a:solidFill>
+                  <a:srgbClr val="000000"/>
+                </a:solidFill>
+                <a:latin typeface="Arial"/>
+                <a:ea typeface="DejaVu Sans"/>
+              </a:rPr>
+              <a:t>▶ </a:t>
+            </a:r>
+            <a:r>
+              <a:rPr b="0" lang="en-US" sz="1800" spc="-1" strike="noStrike">
+                <a:solidFill>
+                  <a:srgbClr val="000000"/>
+                </a:solidFill>
+                <a:latin typeface="Arial"/>
+                <a:ea typeface="DejaVu Sans"/>
+              </a:rPr>
+              <a:t>Can read many filesystem formats to load the kernel image, modules and configuration</a:t>
+            </a:r>
+            <a:endParaRPr b="0" lang="en-US" sz="1800" spc="-1" strike="noStrike">
+              <a:solidFill>
+                <a:srgbClr val="000000"/>
+              </a:solidFill>
+              <a:latin typeface="Arial"/>
+            </a:endParaRPr>
+          </a:p>
+          <a:p>
+            <a:pPr>
+              <a:lnSpc>
+                <a:spcPct val="100000"/>
+              </a:lnSpc>
+            </a:pPr>
+            <a:r>
+              <a:rPr b="0" lang="en-US" sz="1800" spc="-1" strike="noStrike">
+                <a:solidFill>
+                  <a:srgbClr val="000000"/>
+                </a:solidFill>
+                <a:latin typeface="Arial"/>
+                <a:ea typeface="DejaVu Sans"/>
+              </a:rPr>
+              <a:t>▶ </a:t>
+            </a:r>
+            <a:r>
+              <a:rPr b="0" lang="en-US" sz="1800" spc="-1" strike="noStrike">
+                <a:solidFill>
+                  <a:srgbClr val="000000"/>
+                </a:solidFill>
+                <a:latin typeface="Arial"/>
+                <a:ea typeface="DejaVu Sans"/>
+              </a:rPr>
+              <a:t>Provides a menu and powerful shell with various commands</a:t>
+            </a:r>
+            <a:endParaRPr b="0" lang="en-US" sz="1800" spc="-1" strike="noStrike">
+              <a:solidFill>
+                <a:srgbClr val="000000"/>
+              </a:solidFill>
+              <a:latin typeface="Arial"/>
+            </a:endParaRPr>
+          </a:p>
+          <a:p>
+            <a:pPr>
+              <a:lnSpc>
+                <a:spcPct val="100000"/>
+              </a:lnSpc>
+            </a:pPr>
+            <a:r>
+              <a:rPr b="0" lang="en-US" sz="1800" spc="-1" strike="noStrike">
+                <a:solidFill>
+                  <a:srgbClr val="000000"/>
+                </a:solidFill>
+                <a:latin typeface="Arial"/>
+                <a:ea typeface="DejaVu Sans"/>
+              </a:rPr>
+              <a:t>▶ </a:t>
+            </a:r>
+            <a:r>
+              <a:rPr b="0" lang="en-US" sz="1800" spc="-1" strike="noStrike">
+                <a:solidFill>
+                  <a:srgbClr val="000000"/>
+                </a:solidFill>
+                <a:latin typeface="Arial"/>
+                <a:ea typeface="DejaVu Sans"/>
+              </a:rPr>
+              <a:t>Can load kernel images over the network</a:t>
+            </a:r>
+            <a:endParaRPr b="0" lang="en-US" sz="1800" spc="-1" strike="noStrike">
+              <a:solidFill>
+                <a:srgbClr val="000000"/>
+              </a:solidFill>
+              <a:latin typeface="Arial"/>
+            </a:endParaRPr>
+          </a:p>
+          <a:p>
+            <a:pPr>
+              <a:lnSpc>
+                <a:spcPct val="100000"/>
+              </a:lnSpc>
+            </a:pPr>
+            <a:r>
+              <a:rPr b="0" lang="en-US" sz="1800" spc="-1" strike="noStrike">
+                <a:solidFill>
+                  <a:srgbClr val="000000"/>
+                </a:solidFill>
+                <a:latin typeface="Arial"/>
+                <a:ea typeface="DejaVu Sans"/>
+              </a:rPr>
+              <a:t>▶ </a:t>
+            </a:r>
+            <a:r>
+              <a:rPr b="0" lang="en-US" sz="1800" spc="-1" strike="noStrike">
+                <a:solidFill>
+                  <a:srgbClr val="000000"/>
+                </a:solidFill>
+                <a:latin typeface="Arial"/>
+                <a:ea typeface="DejaVu Sans"/>
+              </a:rPr>
+              <a:t>Also supports ARM, ARM64, RISC-V, PowerPC, but less popular than other</a:t>
+            </a:r>
+            <a:endParaRPr b="0" lang="en-US" sz="1800" spc="-1" strike="noStrike">
+              <a:solidFill>
+                <a:srgbClr val="000000"/>
+              </a:solidFill>
+              <a:latin typeface="Arial"/>
+            </a:endParaRPr>
+          </a:p>
+          <a:p>
+            <a:pPr>
+              <a:lnSpc>
+                <a:spcPct val="100000"/>
+              </a:lnSpc>
+            </a:pPr>
+            <a:r>
+              <a:rPr b="0" lang="en-US" sz="1800" spc="-1" strike="noStrike">
+                <a:solidFill>
+                  <a:srgbClr val="000000"/>
+                </a:solidFill>
+                <a:latin typeface="Arial"/>
+                <a:ea typeface="DejaVu Sans"/>
+              </a:rPr>
+              <a:t>bootloaders on those platforms</a:t>
+            </a:r>
+            <a:endParaRPr b="0" lang="en-US" sz="1800" spc="-1" strike="noStrike">
+              <a:solidFill>
+                <a:srgbClr val="000000"/>
+              </a:solidFill>
+              <a:latin typeface="Arial"/>
+            </a:endParaRPr>
+          </a:p>
+          <a:p>
+            <a:pPr>
+              <a:lnSpc>
+                <a:spcPct val="100000"/>
+              </a:lnSpc>
+            </a:pPr>
+            <a:r>
+              <a:rPr b="0" lang="en-US" sz="1800" spc="-1" strike="noStrike">
+                <a:solidFill>
+                  <a:srgbClr val="000000"/>
+                </a:solidFill>
+                <a:latin typeface="Arial"/>
+                <a:ea typeface="DejaVu Sans"/>
+              </a:rPr>
+              <a:t>▶ </a:t>
+            </a:r>
+            <a:r>
+              <a:rPr b="0" lang="en-US" sz="1800" spc="-1" strike="noStrike">
+                <a:solidFill>
+                  <a:srgbClr val="000000"/>
+                </a:solidFill>
+                <a:latin typeface="Arial"/>
+                <a:ea typeface="DejaVu Sans"/>
+              </a:rPr>
+              <a:t>https://www.gnu.org/software/grub/</a:t>
+            </a:r>
+            <a:endParaRPr b="0" lang="en-US" sz="1800" spc="-1" strike="noStrike">
               <a:solidFill>
                 <a:srgbClr val="000000"/>
               </a:solidFill>
@@ -23165,7 +22805,7 @@
       </p:sp>
       <p:pic>
         <p:nvPicPr>
-          <p:cNvPr id="223" name="" descr=""/>
+          <p:cNvPr id="220" name="" descr=""/>
           <p:cNvPicPr/>
           <p:nvPr/>
         </p:nvPicPr>
@@ -23175,8 +22815,8 @@
         </p:blipFill>
         <p:spPr>
           <a:xfrm>
-            <a:off x="228600" y="4148640"/>
-            <a:ext cx="8913960" cy="1996920"/>
+            <a:off x="2968200" y="3537000"/>
+            <a:ext cx="6170400" cy="3256200"/>
           </a:xfrm>
           <a:prstGeom prst="rect">
             <a:avLst/>
@@ -23216,16 +22856,39 @@
           <a:chExt cx="0" cy="0"/>
         </a:xfrm>
       </p:grpSpPr>
+      <p:pic>
+        <p:nvPicPr>
+          <p:cNvPr id="221" name="Picture 1" descr=""/>
+          <p:cNvPicPr/>
+          <p:nvPr/>
+        </p:nvPicPr>
+        <p:blipFill>
+          <a:blip r:embed="rId1"/>
+          <a:stretch/>
+        </p:blipFill>
+        <p:spPr>
+          <a:xfrm>
+            <a:off x="0" y="0"/>
+            <a:ext cx="9135720" cy="6837120"/>
+          </a:xfrm>
+          <a:prstGeom prst="rect">
+            <a:avLst/>
+          </a:prstGeom>
+          <a:ln w="0">
+            <a:noFill/>
+          </a:ln>
+        </p:spPr>
+      </p:pic>
       <p:sp>
         <p:nvSpPr>
-          <p:cNvPr id="224" name=""/>
+          <p:cNvPr id="222" name="CustomShape 1"/>
           <p:cNvSpPr/>
           <p:nvPr/>
         </p:nvSpPr>
         <p:spPr>
           <a:xfrm>
-            <a:off x="505080" y="457200"/>
-            <a:ext cx="5437080" cy="600840"/>
+            <a:off x="3277800" y="431640"/>
+            <a:ext cx="2961000" cy="708120"/>
           </a:xfrm>
           <a:prstGeom prst="rect">
             <a:avLst/>
@@ -23242,26 +22905,26 @@
           <a:fontRef idx="minor"/>
         </p:style>
         <p:txBody>
-          <a:bodyPr lIns="90000" rIns="90000" tIns="45000" bIns="45000" anchor="t">
+          <a:bodyPr wrap="none" lIns="0" rIns="0" tIns="0" bIns="0" anchor="t">
             <a:noAutofit/>
           </a:bodyPr>
           <a:p>
             <a:pPr>
               <a:lnSpc>
-                <a:spcPct val="100000"/>
-              </a:lnSpc>
-            </a:pPr>
-            <a:r>
-              <a:rPr b="1" lang="en-US" sz="1800" spc="-1" strike="noStrike">
-                <a:solidFill>
-                  <a:srgbClr val="000000"/>
-                </a:solidFill>
-                <a:latin typeface="Arial"/>
-                <a:ea typeface="Noto Sans CJK SC"/>
-              </a:rPr>
-              <a:t>Systemd-boot : Simple UEFI boot manager</a:t>
-            </a:r>
-            <a:endParaRPr b="0" lang="en-US" sz="1800" spc="-1" strike="noStrike">
+                <a:spcPts val="975"/>
+              </a:lnSpc>
+            </a:pPr>
+            <a:r>
+              <a:rPr b="1" lang="en-US" sz="2240" spc="-1" strike="noStrike">
+                <a:solidFill>
+                  <a:srgbClr val="000000"/>
+                </a:solidFill>
+                <a:latin typeface="Arial Bold"/>
+                <a:ea typeface="DejaVu Sans"/>
+              </a:rPr>
+              <a:t>Initialization Overview</a:t>
+            </a:r>
+            <a:endParaRPr b="0" lang="en-US" sz="2240" spc="-1" strike="noStrike">
               <a:solidFill>
                 <a:srgbClr val="000000"/>
               </a:solidFill>
@@ -23272,14 +22935,14 @@
       </p:sp>
       <p:sp>
         <p:nvSpPr>
-          <p:cNvPr id="225" name=""/>
+          <p:cNvPr id="223" name="CustomShape 2"/>
           <p:cNvSpPr/>
           <p:nvPr/>
         </p:nvSpPr>
         <p:spPr>
           <a:xfrm>
-            <a:off x="411480" y="1057320"/>
-            <a:ext cx="8502480" cy="5173560"/>
+            <a:off x="253080" y="651600"/>
+            <a:ext cx="8506440" cy="1442880"/>
           </a:xfrm>
           <a:prstGeom prst="rect">
             <a:avLst/>
@@ -23296,7 +22959,7 @@
           <a:fontRef idx="minor"/>
         </p:style>
         <p:txBody>
-          <a:bodyPr lIns="90000" rIns="90000" tIns="45000" bIns="45000" anchor="t">
+          <a:bodyPr wrap="none" lIns="0" rIns="0" tIns="0" bIns="0" anchor="t">
             <a:noAutofit/>
           </a:bodyPr>
           <a:p>
@@ -23305,7 +22968,17 @@
                 <a:spcPct val="100000"/>
               </a:lnSpc>
             </a:pPr>
-            <a:endParaRPr b="0" lang="en-US" sz="1800" spc="-1" strike="noStrike">
+            <a:r>
+              <a:rPr b="0" lang="en-US" sz="2230" spc="-1" strike="noStrike">
+                <a:solidFill>
+                  <a:srgbClr val="000000"/>
+                </a:solidFill>
+                <a:latin typeface="Arial"/>
+                <a:ea typeface="DejaVu Sans"/>
+              </a:rPr>
+              <a:t>When the operating system starts, the kernel runs /sbin/init. This can</a:t>
+            </a:r>
+            <a:endParaRPr b="0" lang="en-US" sz="2230" spc="-1" strike="noStrike">
               <a:solidFill>
                 <a:srgbClr val="000000"/>
               </a:solidFill>
@@ -23319,39 +22992,106 @@
               </a:lnSpc>
             </a:pPr>
             <a:r>
-              <a:rPr b="0" lang="en-US" sz="1800" spc="-1" strike="noStrike">
-                <a:solidFill>
-                  <a:srgbClr val="000000"/>
-                </a:solidFill>
-                <a:latin typeface="Arial"/>
-                <a:ea typeface="DejaVu Sans"/>
-              </a:rPr>
-              <a:t>▶ </a:t>
-            </a:r>
-            <a:r>
-              <a:rPr b="0" lang="en-US" sz="1800" spc="-1" strike="noStrike">
-                <a:solidFill>
-                  <a:srgbClr val="000000"/>
-                </a:solidFill>
-                <a:latin typeface="Arial"/>
-                <a:ea typeface="DejaVu Sans"/>
-              </a:rPr>
-              <a:t>Useful alternative to GRUB for UEFI systems: simpler than GRUB</a:t>
-            </a:r>
-            <a:endParaRPr b="0" lang="en-US" sz="1800" spc="-1" strike="noStrike">
-              <a:solidFill>
-                <a:srgbClr val="000000"/>
-              </a:solidFill>
-              <a:latin typeface="Arial"/>
-            </a:endParaRPr>
-          </a:p>
+              <a:rPr b="0" lang="en-US" sz="2230" spc="-1" strike="noStrike">
+                <a:solidFill>
+                  <a:srgbClr val="000000"/>
+                </a:solidFill>
+                <a:latin typeface="Arial"/>
+                <a:ea typeface="DejaVu Sans"/>
+              </a:rPr>
+              <a:t>be either a script or a program, but typically it is a program that</a:t>
+            </a:r>
+            <a:endParaRPr b="0" lang="en-US" sz="2230" spc="-1" strike="noStrike">
+              <a:solidFill>
+                <a:srgbClr val="000000"/>
+              </a:solidFill>
+              <a:latin typeface="Arial"/>
+            </a:endParaRPr>
+          </a:p>
+          <a:p>
+            <a:pPr>
+              <a:lnSpc>
+                <a:spcPts val="1006"/>
+              </a:lnSpc>
+            </a:pPr>
+            <a:endParaRPr b="0" lang="en-US" sz="2230" spc="-1" strike="noStrike">
+              <a:solidFill>
+                <a:srgbClr val="000000"/>
+              </a:solidFill>
+              <a:latin typeface="Arial"/>
+            </a:endParaRPr>
+          </a:p>
+          <a:p>
+            <a:pPr>
+              <a:lnSpc>
+                <a:spcPts val="1006"/>
+              </a:lnSpc>
+            </a:pPr>
+            <a:r>
+              <a:rPr b="0" lang="en-US" sz="2230" spc="-1" strike="noStrike">
+                <a:solidFill>
+                  <a:srgbClr val="000000"/>
+                </a:solidFill>
+                <a:latin typeface="Arial"/>
+                <a:ea typeface="DejaVu Sans"/>
+              </a:rPr>
+              <a:t>processes the statements in /etc/initab.</a:t>
+            </a:r>
+            <a:endParaRPr b="0" lang="en-US" sz="2230" spc="-1" strike="noStrike">
+              <a:solidFill>
+                <a:srgbClr val="000000"/>
+              </a:solidFill>
+              <a:latin typeface="Arial"/>
+            </a:endParaRPr>
+          </a:p>
+        </p:txBody>
+      </p:sp>
+      <p:sp>
+        <p:nvSpPr>
+          <p:cNvPr id="224" name="CustomShape 3"/>
+          <p:cNvSpPr/>
+          <p:nvPr/>
+        </p:nvSpPr>
+        <p:spPr>
+          <a:xfrm>
+            <a:off x="274320" y="1698480"/>
+            <a:ext cx="8604000" cy="1464840"/>
+          </a:xfrm>
+          <a:prstGeom prst="rect">
+            <a:avLst/>
+          </a:prstGeom>
+          <a:noFill/>
+          <a:ln w="0">
+            <a:noFill/>
+          </a:ln>
+        </p:spPr>
+        <p:style>
+          <a:lnRef idx="0"/>
+          <a:fillRef idx="0"/>
+          <a:effectRef idx="0"/>
+          <a:fontRef idx="minor"/>
+        </p:style>
+        <p:txBody>
+          <a:bodyPr wrap="none" lIns="0" rIns="0" tIns="0" bIns="0" anchor="t">
+            <a:noAutofit/>
+          </a:bodyPr>
           <a:p>
             <a:pPr>
               <a:lnSpc>
                 <a:spcPct val="100000"/>
               </a:lnSpc>
             </a:pPr>
-            <a:endParaRPr b="0" lang="en-US" sz="1800" spc="-1" strike="noStrike">
+            <a:r>
+              <a:rPr b="0" lang="en-US" sz="2230" spc="-1" strike="noStrike">
+                <a:solidFill>
+                  <a:srgbClr val="000000"/>
+                </a:solidFill>
+                <a:latin typeface="Arial"/>
+                <a:ea typeface="DejaVu Sans"/>
+              </a:rPr>
+              <a:t>The default inittab file tells init to run the commands in the file</a:t>
+            </a:r>
+            <a:endParaRPr b="0" lang="en-US" sz="2230" spc="-1" strike="noStrike">
               <a:solidFill>
                 <a:srgbClr val="000000"/>
               </a:solidFill>
@@ -23365,111 +23105,114 @@
               </a:lnSpc>
             </a:pPr>
             <a:r>
-              <a:rPr b="0" lang="en-US" sz="1800" spc="-1" strike="noStrike">
-                <a:solidFill>
-                  <a:srgbClr val="000000"/>
-                </a:solidFill>
-                <a:latin typeface="Arial"/>
-                <a:ea typeface="DejaVu Sans"/>
-              </a:rPr>
-              <a:t>▶ </a:t>
-            </a:r>
-            <a:r>
-              <a:rPr b="0" lang="en-US" sz="1800" spc="-1" strike="noStrike">
-                <a:solidFill>
-                  <a:srgbClr val="000000"/>
-                </a:solidFill>
-                <a:latin typeface="Arial"/>
-                <a:ea typeface="DejaVu Sans"/>
-              </a:rPr>
-              <a:t>Configured using files stored in the EFI System Partition</a:t>
-            </a:r>
-            <a:br>
-              <a:rPr sz="1800"/>
-            </a:br>
-            <a:br>
-              <a:rPr sz="1800"/>
-            </a:br>
-            <a:r>
-              <a:rPr b="0" lang="en-US" sz="1800" spc="-1" strike="noStrike">
-                <a:solidFill>
-                  <a:srgbClr val="000000"/>
-                </a:solidFill>
-                <a:latin typeface="Arial"/>
-                <a:ea typeface="DejaVu Sans"/>
-              </a:rPr>
-              <a:t>▶ Part of the systemd project, even though obviously distinct from systemd itself</a:t>
-            </a:r>
-            <a:endParaRPr b="0" lang="en-US" sz="1800" spc="-1" strike="noStrike">
-              <a:solidFill>
-                <a:srgbClr val="000000"/>
-              </a:solidFill>
-              <a:latin typeface="Arial"/>
-            </a:endParaRPr>
-          </a:p>
-          <a:p>
-            <a:pPr>
-              <a:lnSpc>
-                <a:spcPct val="100000"/>
-              </a:lnSpc>
-            </a:pPr>
-            <a:endParaRPr b="0" lang="en-US" sz="1800" spc="-1" strike="noStrike">
-              <a:solidFill>
-                <a:srgbClr val="000000"/>
-              </a:solidFill>
-              <a:latin typeface="Arial"/>
-            </a:endParaRPr>
-          </a:p>
-          <a:p>
-            <a:pPr>
-              <a:lnSpc>
-                <a:spcPct val="100000"/>
-              </a:lnSpc>
-            </a:pPr>
-            <a:r>
-              <a:rPr b="0" lang="en-US" sz="1800" spc="-1" strike="noStrike">
-                <a:solidFill>
-                  <a:srgbClr val="000000"/>
-                </a:solidFill>
-                <a:latin typeface="Arial"/>
-                <a:ea typeface="DejaVu Sans"/>
-              </a:rPr>
-              <a:t>▶ </a:t>
-            </a:r>
-            <a:r>
-              <a:rPr b="0" lang="en-US" sz="1800" spc="-1" strike="noStrike">
-                <a:solidFill>
-                  <a:srgbClr val="000000"/>
-                </a:solidFill>
-                <a:latin typeface="Arial"/>
-                <a:ea typeface="DejaVu Sans"/>
-              </a:rPr>
-              <a:t>systemd-boot is a UEFI boot manager which executes configured EFI images.</a:t>
-            </a:r>
-            <a:endParaRPr b="0" lang="en-US" sz="1800" spc="-1" strike="noStrike">
-              <a:solidFill>
-                <a:srgbClr val="000000"/>
-              </a:solidFill>
-              <a:latin typeface="Arial"/>
-            </a:endParaRPr>
-          </a:p>
-          <a:p>
-            <a:pPr>
-              <a:lnSpc>
-                <a:spcPct val="100000"/>
-              </a:lnSpc>
-            </a:pPr>
-            <a:endParaRPr b="0" lang="en-US" sz="1800" spc="-1" strike="noStrike">
-              <a:solidFill>
-                <a:srgbClr val="000000"/>
-              </a:solidFill>
-              <a:latin typeface="Arial"/>
-            </a:endParaRPr>
-          </a:p>
-          <a:p>
-            <a:pPr>
-              <a:lnSpc>
-                <a:spcPct val="100000"/>
+              <a:rPr b="0" lang="en-US" sz="2230" spc="-1" strike="noStrike">
+                <a:solidFill>
+                  <a:srgbClr val="000000"/>
+                </a:solidFill>
+                <a:latin typeface="Arial"/>
+                <a:ea typeface="DejaVu Sans"/>
+              </a:rPr>
+              <a:t>/etc/rc.d/rcS. In addition, init spawns programs to present login</a:t>
+            </a:r>
+            <a:endParaRPr b="0" lang="en-US" sz="2230" spc="-1" strike="noStrike">
+              <a:solidFill>
+                <a:srgbClr val="000000"/>
+              </a:solidFill>
+              <a:latin typeface="Arial"/>
+            </a:endParaRPr>
+          </a:p>
+          <a:p>
+            <a:pPr>
+              <a:lnSpc>
+                <a:spcPts val="1023"/>
+              </a:lnSpc>
+            </a:pPr>
+            <a:endParaRPr b="0" lang="en-US" sz="2230" spc="-1" strike="noStrike">
+              <a:solidFill>
+                <a:srgbClr val="000000"/>
+              </a:solidFill>
+              <a:latin typeface="Arial"/>
+            </a:endParaRPr>
+          </a:p>
+          <a:p>
+            <a:pPr>
+              <a:lnSpc>
+                <a:spcPts val="1023"/>
+              </a:lnSpc>
+            </a:pPr>
+            <a:endParaRPr b="0" lang="en-US" sz="2230" spc="-1" strike="noStrike">
+              <a:solidFill>
+                <a:srgbClr val="000000"/>
+              </a:solidFill>
+              <a:latin typeface="Arial"/>
+            </a:endParaRPr>
+          </a:p>
+          <a:p>
+            <a:pPr>
+              <a:lnSpc>
+                <a:spcPts val="1023"/>
+              </a:lnSpc>
+            </a:pPr>
+            <a:r>
+              <a:rPr b="0" lang="en-US" sz="2230" spc="-1" strike="noStrike">
+                <a:solidFill>
+                  <a:srgbClr val="000000"/>
+                </a:solidFill>
+                <a:latin typeface="Arial"/>
+                <a:ea typeface="DejaVu Sans"/>
+              </a:rPr>
+              <a:t>prompts on two virtual terminals.</a:t>
+            </a:r>
+            <a:endParaRPr b="0" lang="en-US" sz="2230" spc="-1" strike="noStrike">
+              <a:solidFill>
+                <a:srgbClr val="000000"/>
+              </a:solidFill>
+              <a:latin typeface="Arial"/>
+            </a:endParaRPr>
+          </a:p>
+          <a:p>
+            <a:pPr>
+              <a:lnSpc>
+                <a:spcPts val="1023"/>
+              </a:lnSpc>
+            </a:pPr>
+            <a:endParaRPr b="0" lang="en-US" sz="2230" spc="-1" strike="noStrike">
+              <a:solidFill>
+                <a:srgbClr val="000000"/>
+              </a:solidFill>
+              <a:latin typeface="Arial"/>
+            </a:endParaRPr>
+          </a:p>
+          <a:p>
+            <a:pPr>
+              <a:lnSpc>
+                <a:spcPts val="1023"/>
+              </a:lnSpc>
+            </a:pPr>
+            <a:endParaRPr b="0" lang="en-US" sz="2230" spc="-1" strike="noStrike">
+              <a:solidFill>
+                <a:srgbClr val="000000"/>
+              </a:solidFill>
+              <a:latin typeface="Arial"/>
+            </a:endParaRPr>
+          </a:p>
+          <a:p>
+            <a:pPr>
+              <a:lnSpc>
+                <a:spcPts val="1023"/>
+              </a:lnSpc>
+            </a:pPr>
+            <a:endParaRPr b="0" lang="en-US" sz="2230" spc="-1" strike="noStrike">
+              <a:solidFill>
+                <a:srgbClr val="000000"/>
+              </a:solidFill>
+              <a:latin typeface="Arial"/>
+            </a:endParaRPr>
+          </a:p>
+          <a:p>
+            <a:pPr>
+              <a:lnSpc>
+                <a:spcPts val="1023"/>
               </a:lnSpc>
               <a:spcBef>
                 <a:spcPts val="1191"/>
@@ -23479,59 +23222,26 @@
               </a:spcAft>
             </a:pPr>
             <a:r>
-              <a:rPr b="0" lang="en-US" sz="1800" spc="-1" strike="noStrike">
-                <a:solidFill>
-                  <a:srgbClr val="000000"/>
-                </a:solidFill>
-                <a:latin typeface="Arial"/>
-                <a:ea typeface="DejaVu Sans"/>
-              </a:rPr>
-              <a:t>▶ </a:t>
-            </a:r>
-            <a:r>
-              <a:rPr b="0" lang="en-US" sz="1800" spc="-1" strike="noStrike">
-                <a:solidFill>
-                  <a:srgbClr val="000000"/>
-                </a:solidFill>
-                <a:latin typeface="Arial"/>
-                <a:ea typeface="DejaVu Sans"/>
-              </a:rPr>
-              <a:t>systemd-boot operates on the EFI System Partition (ESP) only. Configuration file fragments, kernels, initrds, other EFI images need to reside on the ESP. Linux kernels need to be built with CONFIG_EFI_STUB to be able to be directly executed as an EFI image.  </a:t>
-            </a:r>
-            <a:endParaRPr b="0" lang="en-US" sz="1800" spc="-1" strike="noStrike">
-              <a:solidFill>
-                <a:srgbClr val="000000"/>
-              </a:solidFill>
-              <a:latin typeface="Arial"/>
-            </a:endParaRPr>
-          </a:p>
-          <a:p>
-            <a:pPr>
-              <a:lnSpc>
-                <a:spcPct val="100000"/>
-              </a:lnSpc>
-            </a:pPr>
-            <a:r>
-              <a:rPr b="1" lang="en-US" sz="1800" spc="-1" strike="noStrike">
-                <a:solidFill>
-                  <a:srgbClr val="000000"/>
-                </a:solidFill>
-                <a:latin typeface="Arial"/>
-                <a:ea typeface="DejaVu Sans"/>
-              </a:rPr>
-              <a:t>https://www.freedesktop.org/wiki/Software/systemd/systemd-boot/</a:t>
-            </a:r>
-            <a:endParaRPr b="0" lang="en-US" sz="1800" spc="-1" strike="noStrike">
-              <a:solidFill>
-                <a:srgbClr val="000000"/>
-              </a:solidFill>
-              <a:latin typeface="Arial"/>
-            </a:endParaRPr>
-          </a:p>
-          <a:p>
-            <a:pPr>
-              <a:lnSpc>
-                <a:spcPct val="100000"/>
+              <a:rPr b="0" lang="en-IN" sz="2230" spc="-1" strike="noStrike">
+                <a:solidFill>
+                  <a:srgbClr val="000000"/>
+                </a:solidFill>
+                <a:latin typeface="Arial"/>
+                <a:ea typeface="DejaVu Sans"/>
+              </a:rPr>
+              <a:t>In Ubuntu: systemd is in use, but /etc/rc0.d still exists for</a:t>
+            </a:r>
+            <a:endParaRPr b="0" lang="en-US" sz="2230" spc="-1" strike="noStrike">
+              <a:solidFill>
+                <a:srgbClr val="000000"/>
+              </a:solidFill>
+              <a:latin typeface="Arial"/>
+            </a:endParaRPr>
+          </a:p>
+          <a:p>
+            <a:pPr>
+              <a:lnSpc>
+                <a:spcPts val="1023"/>
               </a:lnSpc>
               <a:spcBef>
                 <a:spcPts val="1191"/>
@@ -23541,9 +23251,19 @@
               </a:spcAft>
             </a:pPr>
             <a:br>
-              <a:rPr sz="1000"/>
+              <a:rPr sz="2230"/>
             </a:br>
-            <a:endParaRPr b="0" lang="en-US" sz="1000" spc="-1" strike="noStrike">
+            <a:r>
+              <a:rPr b="0" lang="en-IN" sz="2230" spc="-1" strike="noStrike">
+                <a:solidFill>
+                  <a:srgbClr val="000000"/>
+                </a:solidFill>
+                <a:latin typeface="Arial"/>
+                <a:ea typeface="DejaVu Sans"/>
+              </a:rPr>
+              <a:t>compatibility reasons.</a:t>
+            </a:r>
+            <a:endParaRPr b="0" lang="en-US" sz="2230" spc="-1" strike="noStrike">
               <a:solidFill>
                 <a:srgbClr val="000000"/>
               </a:solidFill>
@@ -23552,6 +23272,29 @@
           </a:p>
         </p:txBody>
       </p:sp>
+      <p:pic>
+        <p:nvPicPr>
+          <p:cNvPr id="225" name="" descr=""/>
+          <p:cNvPicPr/>
+          <p:nvPr/>
+        </p:nvPicPr>
+        <p:blipFill>
+          <a:blip r:embed="rId2"/>
+          <a:stretch/>
+        </p:blipFill>
+        <p:spPr>
+          <a:xfrm>
+            <a:off x="228600" y="4148640"/>
+            <a:ext cx="8913600" cy="1996560"/>
+          </a:xfrm>
+          <a:prstGeom prst="rect">
+            <a:avLst/>
+          </a:prstGeom>
+          <a:ln w="0">
+            <a:noFill/>
+          </a:ln>
+        </p:spPr>
+      </p:pic>
     </p:spTree>
   </p:cSld>
   <mc:AlternateContent>
@@ -23582,39 +23325,16 @@
           <a:chExt cx="0" cy="0"/>
         </a:xfrm>
       </p:grpSpPr>
-      <p:pic>
-        <p:nvPicPr>
-          <p:cNvPr id="226" name="Picture 1" descr=""/>
-          <p:cNvPicPr/>
-          <p:nvPr/>
-        </p:nvPicPr>
-        <p:blipFill>
-          <a:blip r:embed="rId1"/>
-          <a:stretch/>
-        </p:blipFill>
-        <p:spPr>
-          <a:xfrm>
-            <a:off x="146160" y="68760"/>
-            <a:ext cx="8539200" cy="1758600"/>
-          </a:xfrm>
-          <a:prstGeom prst="rect">
-            <a:avLst/>
-          </a:prstGeom>
-          <a:ln w="0">
-            <a:noFill/>
-          </a:ln>
-        </p:spPr>
-      </p:pic>
       <p:sp>
         <p:nvSpPr>
-          <p:cNvPr id="227" name="CustomShape 1"/>
+          <p:cNvPr id="226" name=""/>
           <p:cNvSpPr/>
           <p:nvPr/>
         </p:nvSpPr>
         <p:spPr>
           <a:xfrm>
-            <a:off x="331920" y="266760"/>
-            <a:ext cx="7781400" cy="1833480"/>
+            <a:off x="505080" y="457200"/>
+            <a:ext cx="5436720" cy="600480"/>
           </a:xfrm>
           <a:prstGeom prst="rect">
             <a:avLst/>
@@ -23631,9 +23351,230 @@
           <a:fontRef idx="minor"/>
         </p:style>
         <p:txBody>
-          <a:bodyPr wrap="none" lIns="0" rIns="0" tIns="0" bIns="0" anchor="t">
+          <a:bodyPr lIns="90000" rIns="90000" tIns="45000" bIns="45000" anchor="t">
             <a:noAutofit/>
           </a:bodyPr>
+          <a:p>
+            <a:pPr>
+              <a:lnSpc>
+                <a:spcPct val="100000"/>
+              </a:lnSpc>
+            </a:pPr>
+            <a:r>
+              <a:rPr b="1" lang="en-US" sz="1800" spc="-1" strike="noStrike">
+                <a:solidFill>
+                  <a:srgbClr val="000000"/>
+                </a:solidFill>
+                <a:latin typeface="Arial"/>
+                <a:ea typeface="Noto Sans CJK SC"/>
+              </a:rPr>
+              <a:t>Systemd-boot : Simple UEFI boot manager</a:t>
+            </a:r>
+            <a:endParaRPr b="0" lang="en-US" sz="1800" spc="-1" strike="noStrike">
+              <a:solidFill>
+                <a:srgbClr val="000000"/>
+              </a:solidFill>
+              <a:latin typeface="Arial"/>
+            </a:endParaRPr>
+          </a:p>
+        </p:txBody>
+      </p:sp>
+      <p:sp>
+        <p:nvSpPr>
+          <p:cNvPr id="227" name=""/>
+          <p:cNvSpPr/>
+          <p:nvPr/>
+        </p:nvSpPr>
+        <p:spPr>
+          <a:xfrm>
+            <a:off x="411480" y="1057320"/>
+            <a:ext cx="8502120" cy="5173200"/>
+          </a:xfrm>
+          <a:prstGeom prst="rect">
+            <a:avLst/>
+          </a:prstGeom>
+          <a:noFill/>
+          <a:ln w="0">
+            <a:noFill/>
+          </a:ln>
+        </p:spPr>
+        <p:style>
+          <a:lnRef idx="0"/>
+          <a:fillRef idx="0"/>
+          <a:effectRef idx="0"/>
+          <a:fontRef idx="minor"/>
+        </p:style>
+        <p:txBody>
+          <a:bodyPr lIns="90000" rIns="90000" tIns="45000" bIns="45000" anchor="t">
+            <a:noAutofit/>
+          </a:bodyPr>
+          <a:p>
+            <a:pPr>
+              <a:lnSpc>
+                <a:spcPct val="100000"/>
+              </a:lnSpc>
+            </a:pPr>
+            <a:endParaRPr b="0" lang="en-US" sz="1800" spc="-1" strike="noStrike">
+              <a:solidFill>
+                <a:srgbClr val="000000"/>
+              </a:solidFill>
+              <a:latin typeface="Arial"/>
+            </a:endParaRPr>
+          </a:p>
+          <a:p>
+            <a:pPr>
+              <a:lnSpc>
+                <a:spcPct val="100000"/>
+              </a:lnSpc>
+            </a:pPr>
+            <a:r>
+              <a:rPr b="0" lang="en-US" sz="1800" spc="-1" strike="noStrike">
+                <a:solidFill>
+                  <a:srgbClr val="000000"/>
+                </a:solidFill>
+                <a:latin typeface="Arial"/>
+                <a:ea typeface="DejaVu Sans"/>
+              </a:rPr>
+              <a:t>▶ </a:t>
+            </a:r>
+            <a:r>
+              <a:rPr b="0" lang="en-US" sz="1800" spc="-1" strike="noStrike">
+                <a:solidFill>
+                  <a:srgbClr val="000000"/>
+                </a:solidFill>
+                <a:latin typeface="Arial"/>
+                <a:ea typeface="DejaVu Sans"/>
+              </a:rPr>
+              <a:t>Useful alternative to GRUB for UEFI systems: simpler than GRUB</a:t>
+            </a:r>
+            <a:endParaRPr b="0" lang="en-US" sz="1800" spc="-1" strike="noStrike">
+              <a:solidFill>
+                <a:srgbClr val="000000"/>
+              </a:solidFill>
+              <a:latin typeface="Arial"/>
+            </a:endParaRPr>
+          </a:p>
+          <a:p>
+            <a:pPr>
+              <a:lnSpc>
+                <a:spcPct val="100000"/>
+              </a:lnSpc>
+            </a:pPr>
+            <a:endParaRPr b="0" lang="en-US" sz="1800" spc="-1" strike="noStrike">
+              <a:solidFill>
+                <a:srgbClr val="000000"/>
+              </a:solidFill>
+              <a:latin typeface="Arial"/>
+            </a:endParaRPr>
+          </a:p>
+          <a:p>
+            <a:pPr>
+              <a:lnSpc>
+                <a:spcPct val="100000"/>
+              </a:lnSpc>
+            </a:pPr>
+            <a:r>
+              <a:rPr b="0" lang="en-US" sz="1800" spc="-1" strike="noStrike">
+                <a:solidFill>
+                  <a:srgbClr val="000000"/>
+                </a:solidFill>
+                <a:latin typeface="Arial"/>
+                <a:ea typeface="DejaVu Sans"/>
+              </a:rPr>
+              <a:t>▶ </a:t>
+            </a:r>
+            <a:r>
+              <a:rPr b="0" lang="en-US" sz="1800" spc="-1" strike="noStrike">
+                <a:solidFill>
+                  <a:srgbClr val="000000"/>
+                </a:solidFill>
+                <a:latin typeface="Arial"/>
+                <a:ea typeface="DejaVu Sans"/>
+              </a:rPr>
+              <a:t>Configured using files stored in the EFI System Partition</a:t>
+            </a:r>
+            <a:br>
+              <a:rPr sz="1800"/>
+            </a:br>
+            <a:br>
+              <a:rPr sz="1800"/>
+            </a:br>
+            <a:r>
+              <a:rPr b="0" lang="en-US" sz="1800" spc="-1" strike="noStrike">
+                <a:solidFill>
+                  <a:srgbClr val="000000"/>
+                </a:solidFill>
+                <a:latin typeface="Arial"/>
+                <a:ea typeface="DejaVu Sans"/>
+              </a:rPr>
+              <a:t>▶ Part of the systemd project, even though obviously distinct from systemd itself</a:t>
+            </a:r>
+            <a:endParaRPr b="0" lang="en-US" sz="1800" spc="-1" strike="noStrike">
+              <a:solidFill>
+                <a:srgbClr val="000000"/>
+              </a:solidFill>
+              <a:latin typeface="Arial"/>
+            </a:endParaRPr>
+          </a:p>
+          <a:p>
+            <a:pPr>
+              <a:lnSpc>
+                <a:spcPct val="100000"/>
+              </a:lnSpc>
+            </a:pPr>
+            <a:endParaRPr b="0" lang="en-US" sz="1800" spc="-1" strike="noStrike">
+              <a:solidFill>
+                <a:srgbClr val="000000"/>
+              </a:solidFill>
+              <a:latin typeface="Arial"/>
+            </a:endParaRPr>
+          </a:p>
+          <a:p>
+            <a:pPr>
+              <a:lnSpc>
+                <a:spcPct val="100000"/>
+              </a:lnSpc>
+            </a:pPr>
+            <a:r>
+              <a:rPr b="0" lang="en-US" sz="1800" spc="-1" strike="noStrike">
+                <a:solidFill>
+                  <a:srgbClr val="000000"/>
+                </a:solidFill>
+                <a:latin typeface="Arial"/>
+                <a:ea typeface="DejaVu Sans"/>
+              </a:rPr>
+              <a:t>▶ </a:t>
+            </a:r>
+            <a:r>
+              <a:rPr b="0" lang="en-US" sz="1800" spc="-1" strike="noStrike">
+                <a:solidFill>
+                  <a:srgbClr val="000000"/>
+                </a:solidFill>
+                <a:latin typeface="Arial"/>
+                <a:ea typeface="DejaVu Sans"/>
+              </a:rPr>
+              <a:t>systemd-boot is a UEFI boot manager which executes configured EFI images.</a:t>
+            </a:r>
+            <a:endParaRPr b="0" lang="en-US" sz="1800" spc="-1" strike="noStrike">
+              <a:solidFill>
+                <a:srgbClr val="000000"/>
+              </a:solidFill>
+              <a:latin typeface="Arial"/>
+            </a:endParaRPr>
+          </a:p>
+          <a:p>
+            <a:pPr>
+              <a:lnSpc>
+                <a:spcPct val="100000"/>
+              </a:lnSpc>
+            </a:pPr>
+            <a:endParaRPr b="0" lang="en-US" sz="1800" spc="-1" strike="noStrike">
+              <a:solidFill>
+                <a:srgbClr val="000000"/>
+              </a:solidFill>
+              <a:latin typeface="Arial"/>
+            </a:endParaRPr>
+          </a:p>
           <a:p>
             <a:pPr>
               <a:lnSpc>
@@ -23647,144 +23588,71 @@
               </a:spcAft>
             </a:pPr>
             <a:r>
-              <a:rPr b="1" lang="en-US" sz="2240" spc="-1" strike="noStrike">
-                <a:solidFill>
-                  <a:srgbClr val="000000"/>
-                </a:solidFill>
-                <a:latin typeface="Arial Bold"/>
-                <a:ea typeface="DejaVu Sans"/>
-              </a:rPr>
-              <a:t>Init Runlevels</a:t>
-            </a:r>
-            <a:r>
-              <a:rPr b="0" lang="en-US" sz="2230" spc="-1" strike="noStrike">
-                <a:solidFill>
-                  <a:srgbClr val="000000"/>
-                </a:solidFill>
-                <a:latin typeface="Arial"/>
-                <a:ea typeface="DejaVu Sans"/>
-              </a:rPr>
-              <a:t>: </a:t>
-            </a:r>
-            <a:r>
-              <a:rPr b="1" lang="en-US" sz="2230" spc="-1" strike="noStrike">
-                <a:solidFill>
-                  <a:srgbClr val="000000"/>
-                </a:solidFill>
-                <a:latin typeface="Arial"/>
-                <a:ea typeface="DejaVu Sans"/>
-              </a:rPr>
-              <a:t>/etc/rc0.d (SysVinit)</a:t>
-            </a:r>
+              <a:rPr b="0" lang="en-US" sz="1800" spc="-1" strike="noStrike">
+                <a:solidFill>
+                  <a:srgbClr val="000000"/>
+                </a:solidFill>
+                <a:latin typeface="Arial"/>
+                <a:ea typeface="DejaVu Sans"/>
+              </a:rPr>
+              <a:t>▶ </a:t>
+            </a:r>
+            <a:r>
+              <a:rPr b="0" lang="en-US" sz="1800" spc="-1" strike="noStrike">
+                <a:solidFill>
+                  <a:srgbClr val="000000"/>
+                </a:solidFill>
+                <a:latin typeface="Arial"/>
+                <a:ea typeface="DejaVu Sans"/>
+              </a:rPr>
+              <a:t>systemd-boot operates on the EFI System Partition (ESP) only. Configuration file fragments, kernels, initrds, other EFI images need to reside on the ESP. Linux kernels need to be built with CONFIG_EFI_STUB to be able to be directly executed as an EFI image.  </a:t>
+            </a:r>
+            <a:endParaRPr b="0" lang="en-US" sz="1800" spc="-1" strike="noStrike">
+              <a:solidFill>
+                <a:srgbClr val="000000"/>
+              </a:solidFill>
+              <a:latin typeface="Arial"/>
+            </a:endParaRPr>
+          </a:p>
+          <a:p>
+            <a:pPr>
+              <a:lnSpc>
+                <a:spcPct val="100000"/>
+              </a:lnSpc>
+            </a:pPr>
+            <a:r>
+              <a:rPr b="1" lang="en-US" sz="1800" spc="-1" strike="noStrike">
+                <a:solidFill>
+                  <a:srgbClr val="000000"/>
+                </a:solidFill>
+                <a:latin typeface="Arial"/>
+                <a:ea typeface="DejaVu Sans"/>
+              </a:rPr>
+              <a:t>https://www.freedesktop.org/wiki/Software/systemd/systemd-boot/</a:t>
+            </a:r>
+            <a:endParaRPr b="0" lang="en-US" sz="1800" spc="-1" strike="noStrike">
+              <a:solidFill>
+                <a:srgbClr val="000000"/>
+              </a:solidFill>
+              <a:latin typeface="Arial"/>
+            </a:endParaRPr>
+          </a:p>
+          <a:p>
+            <a:pPr>
+              <a:lnSpc>
+                <a:spcPct val="100000"/>
+              </a:lnSpc>
+              <a:spcBef>
+                <a:spcPts val="1191"/>
+              </a:spcBef>
+              <a:spcAft>
+                <a:spcPts val="992"/>
+              </a:spcAft>
+            </a:pPr>
             <a:br>
-              <a:rPr sz="2230"/>
+              <a:rPr sz="1000"/>
             </a:br>
-            <a:r>
-              <a:rPr b="0" lang="en-US" sz="2230" spc="-1" strike="noStrike">
-                <a:solidFill>
-                  <a:srgbClr val="000000"/>
-                </a:solidFill>
-                <a:latin typeface="Arial"/>
-                <a:ea typeface="DejaVu Sans"/>
-              </a:rPr>
-              <a:t>The idea behind operating different services at</a:t>
-            </a:r>
-            <a:endParaRPr b="0" lang="en-US" sz="2230" spc="-1" strike="noStrike">
-              <a:solidFill>
-                <a:srgbClr val="000000"/>
-              </a:solidFill>
-              <a:latin typeface="Arial"/>
-            </a:endParaRPr>
-          </a:p>
-          <a:p>
-            <a:pPr>
-              <a:lnSpc>
-                <a:spcPct val="100000"/>
-              </a:lnSpc>
-            </a:pPr>
-            <a:r>
-              <a:rPr b="0" lang="en-US" sz="2230" spc="-1" strike="noStrike">
-                <a:solidFill>
-                  <a:srgbClr val="000000"/>
-                </a:solidFill>
-                <a:latin typeface="Arial"/>
-                <a:ea typeface="DejaVu Sans"/>
-              </a:rPr>
-              <a:t>different run levels essentially revolves around the fact that</a:t>
-            </a:r>
-            <a:endParaRPr b="0" lang="en-US" sz="2230" spc="-1" strike="noStrike">
-              <a:solidFill>
-                <a:srgbClr val="000000"/>
-              </a:solidFill>
-              <a:latin typeface="Arial"/>
-            </a:endParaRPr>
-          </a:p>
-          <a:p>
-            <a:pPr>
-              <a:lnSpc>
-                <a:spcPct val="100000"/>
-              </a:lnSpc>
-            </a:pPr>
-            <a:r>
-              <a:rPr b="0" lang="en-US" sz="2230" spc="-1" strike="noStrike">
-                <a:solidFill>
-                  <a:srgbClr val="000000"/>
-                </a:solidFill>
-                <a:latin typeface="Arial"/>
-                <a:ea typeface="DejaVu Sans"/>
-              </a:rPr>
-              <a:t>different systems can be used in a different ways. The following</a:t>
-            </a:r>
-            <a:endParaRPr b="0" lang="en-US" sz="2230" spc="-1" strike="noStrike">
-              <a:solidFill>
-                <a:srgbClr val="000000"/>
-              </a:solidFill>
-              <a:latin typeface="Arial"/>
-            </a:endParaRPr>
-          </a:p>
-          <a:p>
-            <a:pPr>
-              <a:lnSpc>
-                <a:spcPts val="1023"/>
-              </a:lnSpc>
-            </a:pPr>
-            <a:endParaRPr b="0" lang="en-US" sz="2230" spc="-1" strike="noStrike">
-              <a:solidFill>
-                <a:srgbClr val="000000"/>
-              </a:solidFill>
-              <a:latin typeface="Arial"/>
-            </a:endParaRPr>
-          </a:p>
-          <a:p>
-            <a:pPr>
-              <a:lnSpc>
-                <a:spcPts val="1023"/>
-              </a:lnSpc>
-            </a:pPr>
-            <a:endParaRPr b="0" lang="en-US" sz="2230" spc="-1" strike="noStrike">
-              <a:solidFill>
-                <a:srgbClr val="000000"/>
-              </a:solidFill>
-              <a:latin typeface="Arial"/>
-            </a:endParaRPr>
-          </a:p>
-          <a:p>
-            <a:pPr>
-              <a:lnSpc>
-                <a:spcPts val="1023"/>
-              </a:lnSpc>
-            </a:pPr>
-            <a:r>
-              <a:rPr b="0" lang="en-US" sz="2230" spc="-1" strike="noStrike">
-                <a:solidFill>
-                  <a:srgbClr val="000000"/>
-                </a:solidFill>
-                <a:latin typeface="Arial"/>
-                <a:ea typeface="DejaVu Sans"/>
-              </a:rPr>
-              <a:t>runlevels are defined in Red Hat Linux :</a:t>
-            </a:r>
-            <a:endParaRPr b="0" lang="en-US" sz="2230" spc="-1" strike="noStrike">
+            <a:endParaRPr b="0" lang="en-US" sz="1000" spc="-1" strike="noStrike">
               <a:solidFill>
                 <a:srgbClr val="000000"/>
               </a:solidFill>
@@ -23793,29 +23661,6 @@
           </a:p>
         </p:txBody>
       </p:sp>
-      <p:pic>
-        <p:nvPicPr>
-          <p:cNvPr id="228" name="" descr=""/>
-          <p:cNvPicPr/>
-          <p:nvPr/>
-        </p:nvPicPr>
-        <p:blipFill>
-          <a:blip r:embed="rId2"/>
-          <a:stretch/>
-        </p:blipFill>
-        <p:spPr>
-          <a:xfrm>
-            <a:off x="1143000" y="1855800"/>
-            <a:ext cx="5996160" cy="4314960"/>
-          </a:xfrm>
-          <a:prstGeom prst="rect">
-            <a:avLst/>
-          </a:prstGeom>
-          <a:ln w="0">
-            <a:noFill/>
-          </a:ln>
-        </p:spPr>
-      </p:pic>
     </p:spTree>
   </p:cSld>
   <mc:AlternateContent>
@@ -23855,7 +23700,7 @@
         <p:spPr>
           <a:xfrm>
             <a:off x="60840" y="298080"/>
-            <a:ext cx="7709760" cy="2900520"/>
+            <a:ext cx="7709400" cy="2900160"/>
           </a:xfrm>
           <a:prstGeom prst="rect">
             <a:avLst/>
@@ -24189,6 +24034,270 @@
           </a:p>
         </p:txBody>
       </p:sp>
+    </p:spTree>
+  </p:cSld>
+  <mc:AlternateContent>
+    <mc:Choice Requires="p14">
+      <p:transition spd="slow" p14:dur="2000"/>
+    </mc:Choice>
+    <mc:Fallback>
+      <p:transition spd="slow"/>
+    </mc:Fallback>
+  </mc:AlternateContent>
+</p:sld>
+</file>
+
+<file path=ppt/slides/slide30.xml><?xml version="1.0" encoding="utf-8"?>
+<p:sld xmlns:a="http://schemas.openxmlformats.org/drawingml/2006/main" xmlns:p="http://schemas.openxmlformats.org/presentationml/2006/main" xmlns:r="http://schemas.openxmlformats.org/officeDocument/2006/relationships" xmlns:p14="http://schemas.microsoft.com/office/powerpoint/2010/main" xmlns:p15="http://schemas.microsoft.com/office/powerpoint/2012/main" xmlns:mc="http://schemas.openxmlformats.org/markup-compatibility/2006">
+  <p:cSld>
+    <p:spTree>
+      <p:nvGrpSpPr>
+        <p:cNvPr id="1" name=""/>
+        <p:cNvGrpSpPr/>
+        <p:nvPr/>
+      </p:nvGrpSpPr>
+      <p:grpSpPr>
+        <a:xfrm>
+          <a:off x="0" y="0"/>
+          <a:ext cx="0" cy="0"/>
+          <a:chOff x="0" y="0"/>
+          <a:chExt cx="0" cy="0"/>
+        </a:xfrm>
+      </p:grpSpPr>
+      <p:pic>
+        <p:nvPicPr>
+          <p:cNvPr id="228" name="Picture 1" descr=""/>
+          <p:cNvPicPr/>
+          <p:nvPr/>
+        </p:nvPicPr>
+        <p:blipFill>
+          <a:blip r:embed="rId1"/>
+          <a:stretch/>
+        </p:blipFill>
+        <p:spPr>
+          <a:xfrm>
+            <a:off x="146160" y="68760"/>
+            <a:ext cx="8538840" cy="1758240"/>
+          </a:xfrm>
+          <a:prstGeom prst="rect">
+            <a:avLst/>
+          </a:prstGeom>
+          <a:ln w="0">
+            <a:noFill/>
+          </a:ln>
+        </p:spPr>
+      </p:pic>
+      <p:sp>
+        <p:nvSpPr>
+          <p:cNvPr id="229" name="CustomShape 1"/>
+          <p:cNvSpPr/>
+          <p:nvPr/>
+        </p:nvSpPr>
+        <p:spPr>
+          <a:xfrm>
+            <a:off x="331920" y="266760"/>
+            <a:ext cx="7781040" cy="1833120"/>
+          </a:xfrm>
+          <a:prstGeom prst="rect">
+            <a:avLst/>
+          </a:prstGeom>
+          <a:noFill/>
+          <a:ln w="0">
+            <a:noFill/>
+          </a:ln>
+        </p:spPr>
+        <p:style>
+          <a:lnRef idx="0"/>
+          <a:fillRef idx="0"/>
+          <a:effectRef idx="0"/>
+          <a:fontRef idx="minor"/>
+        </p:style>
+        <p:txBody>
+          <a:bodyPr wrap="none" lIns="0" rIns="0" tIns="0" bIns="0" anchor="t">
+            <a:noAutofit/>
+          </a:bodyPr>
+          <a:p>
+            <a:pPr>
+              <a:lnSpc>
+                <a:spcPct val="100000"/>
+              </a:lnSpc>
+              <a:spcBef>
+                <a:spcPts val="1191"/>
+              </a:spcBef>
+              <a:spcAft>
+                <a:spcPts val="992"/>
+              </a:spcAft>
+            </a:pPr>
+            <a:r>
+              <a:rPr b="1" lang="en-US" sz="2240" spc="-1" strike="noStrike">
+                <a:solidFill>
+                  <a:srgbClr val="000000"/>
+                </a:solidFill>
+                <a:latin typeface="Arial Bold"/>
+                <a:ea typeface="DejaVu Sans"/>
+              </a:rPr>
+              <a:t>Init Runlevels</a:t>
+            </a:r>
+            <a:r>
+              <a:rPr b="0" lang="en-US" sz="2230" spc="-1" strike="noStrike">
+                <a:solidFill>
+                  <a:srgbClr val="000000"/>
+                </a:solidFill>
+                <a:latin typeface="Arial"/>
+                <a:ea typeface="DejaVu Sans"/>
+              </a:rPr>
+              <a:t>: </a:t>
+            </a:r>
+            <a:r>
+              <a:rPr b="1" lang="en-US" sz="2230" spc="-1" strike="noStrike">
+                <a:solidFill>
+                  <a:srgbClr val="000000"/>
+                </a:solidFill>
+                <a:latin typeface="Arial"/>
+                <a:ea typeface="DejaVu Sans"/>
+              </a:rPr>
+              <a:t>/etc/rc0.d (SysVinit)</a:t>
+            </a:r>
+            <a:br>
+              <a:rPr sz="2230"/>
+            </a:br>
+            <a:r>
+              <a:rPr b="0" lang="en-US" sz="2230" spc="-1" strike="noStrike">
+                <a:solidFill>
+                  <a:srgbClr val="000000"/>
+                </a:solidFill>
+                <a:latin typeface="Arial"/>
+                <a:ea typeface="DejaVu Sans"/>
+              </a:rPr>
+              <a:t>The idea behind operating different services at</a:t>
+            </a:r>
+            <a:endParaRPr b="0" lang="en-US" sz="2230" spc="-1" strike="noStrike">
+              <a:solidFill>
+                <a:srgbClr val="000000"/>
+              </a:solidFill>
+              <a:latin typeface="Arial"/>
+            </a:endParaRPr>
+          </a:p>
+          <a:p>
+            <a:pPr>
+              <a:lnSpc>
+                <a:spcPct val="100000"/>
+              </a:lnSpc>
+            </a:pPr>
+            <a:r>
+              <a:rPr b="0" lang="en-US" sz="2230" spc="-1" strike="noStrike">
+                <a:solidFill>
+                  <a:srgbClr val="000000"/>
+                </a:solidFill>
+                <a:latin typeface="Arial"/>
+                <a:ea typeface="DejaVu Sans"/>
+              </a:rPr>
+              <a:t>different run levels essentially revolves around the fact that</a:t>
+            </a:r>
+            <a:endParaRPr b="0" lang="en-US" sz="2230" spc="-1" strike="noStrike">
+              <a:solidFill>
+                <a:srgbClr val="000000"/>
+              </a:solidFill>
+              <a:latin typeface="Arial"/>
+            </a:endParaRPr>
+          </a:p>
+          <a:p>
+            <a:pPr>
+              <a:lnSpc>
+                <a:spcPct val="100000"/>
+              </a:lnSpc>
+            </a:pPr>
+            <a:r>
+              <a:rPr b="0" lang="en-US" sz="2230" spc="-1" strike="noStrike">
+                <a:solidFill>
+                  <a:srgbClr val="000000"/>
+                </a:solidFill>
+                <a:latin typeface="Arial"/>
+                <a:ea typeface="DejaVu Sans"/>
+              </a:rPr>
+              <a:t>different systems can be used in a different ways. The following</a:t>
+            </a:r>
+            <a:endParaRPr b="0" lang="en-US" sz="2230" spc="-1" strike="noStrike">
+              <a:solidFill>
+                <a:srgbClr val="000000"/>
+              </a:solidFill>
+              <a:latin typeface="Arial"/>
+            </a:endParaRPr>
+          </a:p>
+          <a:p>
+            <a:pPr>
+              <a:lnSpc>
+                <a:spcPts val="1023"/>
+              </a:lnSpc>
+            </a:pPr>
+            <a:endParaRPr b="0" lang="en-US" sz="2230" spc="-1" strike="noStrike">
+              <a:solidFill>
+                <a:srgbClr val="000000"/>
+              </a:solidFill>
+              <a:latin typeface="Arial"/>
+            </a:endParaRPr>
+          </a:p>
+          <a:p>
+            <a:pPr>
+              <a:lnSpc>
+                <a:spcPts val="1023"/>
+              </a:lnSpc>
+            </a:pPr>
+            <a:endParaRPr b="0" lang="en-US" sz="2230" spc="-1" strike="noStrike">
+              <a:solidFill>
+                <a:srgbClr val="000000"/>
+              </a:solidFill>
+              <a:latin typeface="Arial"/>
+            </a:endParaRPr>
+          </a:p>
+          <a:p>
+            <a:pPr>
+              <a:lnSpc>
+                <a:spcPts val="1023"/>
+              </a:lnSpc>
+            </a:pPr>
+            <a:r>
+              <a:rPr b="0" lang="en-US" sz="2230" spc="-1" strike="noStrike">
+                <a:solidFill>
+                  <a:srgbClr val="000000"/>
+                </a:solidFill>
+                <a:latin typeface="Arial"/>
+                <a:ea typeface="DejaVu Sans"/>
+              </a:rPr>
+              <a:t>runlevels are defined in Red Hat Linux :</a:t>
+            </a:r>
+            <a:endParaRPr b="0" lang="en-US" sz="2230" spc="-1" strike="noStrike">
+              <a:solidFill>
+                <a:srgbClr val="000000"/>
+              </a:solidFill>
+              <a:latin typeface="Arial"/>
+            </a:endParaRPr>
+          </a:p>
+        </p:txBody>
+      </p:sp>
+      <p:pic>
+        <p:nvPicPr>
+          <p:cNvPr id="230" name="" descr=""/>
+          <p:cNvPicPr/>
+          <p:nvPr/>
+        </p:nvPicPr>
+        <p:blipFill>
+          <a:blip r:embed="rId2"/>
+          <a:stretch/>
+        </p:blipFill>
+        <p:spPr>
+          <a:xfrm>
+            <a:off x="1143000" y="1855800"/>
+            <a:ext cx="5995800" cy="4314600"/>
+          </a:xfrm>
+          <a:prstGeom prst="rect">
+            <a:avLst/>
+          </a:prstGeom>
+          <a:ln w="0">
+            <a:noFill/>
+          </a:ln>
+        </p:spPr>
+      </p:pic>
     </p:spTree>
   </p:cSld>
   <mc:AlternateContent>
@@ -24228,7 +24337,7 @@
         <p:spPr>
           <a:xfrm>
             <a:off x="467640" y="72000"/>
-            <a:ext cx="8201160" cy="1454400"/>
+            <a:ext cx="8200800" cy="1454040"/>
           </a:xfrm>
           <a:prstGeom prst="rect">
             <a:avLst/>
@@ -24744,7 +24853,7 @@
         <p:spPr>
           <a:xfrm>
             <a:off x="183600" y="147600"/>
-            <a:ext cx="8958240" cy="2391840"/>
+            <a:ext cx="8957880" cy="2391480"/>
           </a:xfrm>
           <a:prstGeom prst="rect">
             <a:avLst/>
@@ -25002,7 +25111,7 @@
         <p:spPr>
           <a:xfrm>
             <a:off x="192600" y="2658600"/>
-            <a:ext cx="8685000" cy="2903760"/>
+            <a:ext cx="8684640" cy="2903400"/>
           </a:xfrm>
           <a:prstGeom prst="rect">
             <a:avLst/>
@@ -25362,8 +25471,8 @@
         </p:blipFill>
         <p:spPr>
           <a:xfrm>
-            <a:off x="1371600" y="-1209240"/>
-            <a:ext cx="7112160" cy="5322240"/>
+            <a:off x="1371600" y="228600"/>
+            <a:ext cx="7111800" cy="3920040"/>
           </a:xfrm>
           <a:prstGeom prst="rect">
             <a:avLst/>
@@ -25382,7 +25491,7 @@
         <p:spPr>
           <a:xfrm>
             <a:off x="2541960" y="648000"/>
-            <a:ext cx="2493720" cy="708480"/>
+            <a:ext cx="2493360" cy="708120"/>
           </a:xfrm>
           <a:prstGeom prst="rect">
             <a:avLst/>
@@ -25436,7 +25545,7 @@
         <p:spPr>
           <a:xfrm>
             <a:off x="204120" y="1008000"/>
-            <a:ext cx="8790120" cy="1813680"/>
+            <a:ext cx="8789760" cy="1813320"/>
           </a:xfrm>
           <a:prstGeom prst="rect">
             <a:avLst/>
@@ -25605,7 +25714,7 @@
         <p:spPr>
           <a:xfrm>
             <a:off x="224280" y="2869920"/>
-            <a:ext cx="7774920" cy="708480"/>
+            <a:ext cx="7774560" cy="708120"/>
           </a:xfrm>
           <a:prstGeom prst="rect">
             <a:avLst/>
@@ -25659,7 +25768,7 @@
         <p:spPr>
           <a:xfrm>
             <a:off x="225720" y="3009600"/>
-            <a:ext cx="9033840" cy="1809720"/>
+            <a:ext cx="9033480" cy="1809360"/>
           </a:xfrm>
           <a:prstGeom prst="rect">
             <a:avLst/>
@@ -25798,7 +25907,7 @@
         <p:spPr>
           <a:xfrm>
             <a:off x="216000" y="4343400"/>
-            <a:ext cx="8697600" cy="1096920"/>
+            <a:ext cx="8697240" cy="1096560"/>
           </a:xfrm>
           <a:prstGeom prst="rect">
             <a:avLst/>
@@ -25944,7 +26053,7 @@
         <p:spPr>
           <a:xfrm>
             <a:off x="108000" y="5297760"/>
-            <a:ext cx="8898120" cy="852480"/>
+            <a:ext cx="8897760" cy="852120"/>
           </a:xfrm>
           <a:prstGeom prst="rect">
             <a:avLst/>
@@ -26052,7 +26161,7 @@
         <p:spPr>
           <a:xfrm>
             <a:off x="0" y="-76320"/>
-            <a:ext cx="9136080" cy="6837480"/>
+            <a:ext cx="9135720" cy="6837120"/>
           </a:xfrm>
           <a:prstGeom prst="rect">
             <a:avLst/>
@@ -26071,7 +26180,7 @@
         <p:spPr>
           <a:xfrm>
             <a:off x="271080" y="266760"/>
-            <a:ext cx="8642520" cy="906840"/>
+            <a:ext cx="8642160" cy="906480"/>
           </a:xfrm>
           <a:prstGeom prst="rect">
             <a:avLst/>
@@ -26597,7 +26706,7 @@
         <p:spPr>
           <a:xfrm>
             <a:off x="252360" y="1371600"/>
-            <a:ext cx="7778520" cy="1211760"/>
+            <a:ext cx="7778160" cy="1211400"/>
           </a:xfrm>
           <a:prstGeom prst="rect">
             <a:avLst/>
@@ -26710,7 +26819,7 @@
         <p:spPr>
           <a:xfrm>
             <a:off x="267120" y="2309040"/>
-            <a:ext cx="8228880" cy="3346200"/>
+            <a:ext cx="8228520" cy="3345840"/>
           </a:xfrm>
           <a:prstGeom prst="rect">
             <a:avLst/>
@@ -27011,7 +27120,7 @@
         <p:spPr>
           <a:xfrm>
             <a:off x="288000" y="187560"/>
-            <a:ext cx="7917120" cy="1821600"/>
+            <a:ext cx="7916760" cy="1821240"/>
           </a:xfrm>
           <a:prstGeom prst="rect">
             <a:avLst/>
@@ -27330,7 +27439,7 @@
         <p:spPr>
           <a:xfrm>
             <a:off x="288000" y="1924200"/>
-            <a:ext cx="4111560" cy="588960"/>
+            <a:ext cx="4111200" cy="588600"/>
           </a:xfrm>
           <a:prstGeom prst="rect">
             <a:avLst/>
@@ -27384,7 +27493,7 @@
         <p:spPr>
           <a:xfrm>
             <a:off x="312120" y="2083680"/>
-            <a:ext cx="7023600" cy="588960"/>
+            <a:ext cx="7023240" cy="588600"/>
           </a:xfrm>
           <a:prstGeom prst="rect">
             <a:avLst/>
@@ -27500,7 +27609,7 @@
         <p:spPr>
           <a:xfrm>
             <a:off x="288000" y="2480040"/>
-            <a:ext cx="8063640" cy="3346200"/>
+            <a:ext cx="8063280" cy="3345840"/>
           </a:xfrm>
           <a:prstGeom prst="rect">
             <a:avLst/>
@@ -27837,7 +27946,7 @@
         <p:spPr>
           <a:xfrm>
             <a:off x="331560" y="5496480"/>
-            <a:ext cx="8353440" cy="1211760"/>
+            <a:ext cx="8353080" cy="1211400"/>
           </a:xfrm>
           <a:prstGeom prst="rect">
             <a:avLst/>
@@ -28062,7 +28171,7 @@
         <p:spPr>
           <a:xfrm>
             <a:off x="432000" y="360000"/>
-            <a:ext cx="8710200" cy="1875240"/>
+            <a:ext cx="8709840" cy="1874880"/>
           </a:xfrm>
           <a:prstGeom prst="rect">
             <a:avLst/>

</xml_diff>

<commit_message>
Added secure boot ppt
Signed-off-by: Rama <embedded.training.rama@gmail.com>
</commit_message>
<xml_diff>
--- a/2_Linux_kernel_config.pptx
+++ b/2_Linux_kernel_config.pptx
@@ -57,6 +57,7 @@
     <p:sldId id="282" r:id="rId52"/>
     <p:sldId id="283" r:id="rId53"/>
     <p:sldId id="284" r:id="rId54"/>
+    <p:sldId id="285" r:id="rId55"/>
   </p:sldIdLst>
   <p:sldSz cx="9144000" cy="6858000"/>
   <p:notesSz cx="7559675" cy="10691813"/>
@@ -3007,7 +3008,16 @@
                 </a:solidFill>
                 <a:latin typeface="Arial"/>
               </a:rPr>
-              <a:t>Click to edit the title text format</a:t>
+              <a:t>Click to edit the </a:t>
+            </a:r>
+            <a:r>
+              <a:rPr b="0" lang="en-US" sz="1800" spc="-1" strike="noStrike">
+                <a:solidFill>
+                  <a:srgbClr val="000000"/>
+                </a:solidFill>
+                <a:latin typeface="Arial"/>
+              </a:rPr>
+              <a:t>title text format</a:t>
             </a:r>
             <a:endParaRPr b="0" lang="en-US" sz="1800" spc="-1" strike="noStrike">
               <a:solidFill>
@@ -11229,52 +11239,7 @@
                 </a:solidFill>
                 <a:latin typeface="Arial"/>
               </a:rPr>
-              <a:t>Click </a:t>
-            </a:r>
-            <a:r>
-              <a:rPr b="0" lang="en-US" sz="1800" spc="-1" strike="noStrike">
-                <a:solidFill>
-                  <a:srgbClr val="000000"/>
-                </a:solidFill>
-                <a:latin typeface="Arial"/>
-              </a:rPr>
-              <a:t>to edit </a:t>
-            </a:r>
-            <a:r>
-              <a:rPr b="0" lang="en-US" sz="1800" spc="-1" strike="noStrike">
-                <a:solidFill>
-                  <a:srgbClr val="000000"/>
-                </a:solidFill>
-                <a:latin typeface="Arial"/>
-              </a:rPr>
-              <a:t>the </a:t>
-            </a:r>
-            <a:r>
-              <a:rPr b="0" lang="en-US" sz="1800" spc="-1" strike="noStrike">
-                <a:solidFill>
-                  <a:srgbClr val="000000"/>
-                </a:solidFill>
-                <a:latin typeface="Arial"/>
-              </a:rPr>
-              <a:t>title </a:t>
-            </a:r>
-            <a:r>
-              <a:rPr b="0" lang="en-US" sz="1800" spc="-1" strike="noStrike">
-                <a:solidFill>
-                  <a:srgbClr val="000000"/>
-                </a:solidFill>
-                <a:latin typeface="Arial"/>
-              </a:rPr>
-              <a:t>text </a:t>
-            </a:r>
-            <a:r>
-              <a:rPr b="0" lang="en-US" sz="1800" spc="-1" strike="noStrike">
-                <a:solidFill>
-                  <a:srgbClr val="000000"/>
-                </a:solidFill>
-                <a:latin typeface="Arial"/>
-              </a:rPr>
-              <a:t>format</a:t>
+              <a:t>Click to edit the title text format</a:t>
             </a:r>
             <a:endParaRPr b="0" lang="en-US" sz="1800" spc="-1" strike="noStrike">
               <a:solidFill>
@@ -13792,7 +13757,7 @@
         <p:spPr>
           <a:xfrm>
             <a:off x="3600" y="-1634040"/>
-            <a:ext cx="9141840" cy="6093720"/>
+            <a:ext cx="9141480" cy="6093360"/>
           </a:xfrm>
           <a:prstGeom prst="rect">
             <a:avLst/>
@@ -13845,7 +13810,7 @@
         <p:spPr>
           <a:xfrm>
             <a:off x="0" y="0"/>
-            <a:ext cx="9136080" cy="6837480"/>
+            <a:ext cx="9135720" cy="6837120"/>
           </a:xfrm>
           <a:prstGeom prst="rect">
             <a:avLst/>
@@ -13864,7 +13829,7 @@
         <p:spPr>
           <a:xfrm>
             <a:off x="3271320" y="285840"/>
-            <a:ext cx="2804760" cy="708480"/>
+            <a:ext cx="2804400" cy="708120"/>
           </a:xfrm>
           <a:prstGeom prst="rect">
             <a:avLst/>
@@ -13918,7 +13883,7 @@
         <p:spPr>
           <a:xfrm>
             <a:off x="208080" y="582120"/>
-            <a:ext cx="8283240" cy="1478160"/>
+            <a:ext cx="8282880" cy="1477800"/>
           </a:xfrm>
           <a:prstGeom prst="rect">
             <a:avLst/>
@@ -14008,7 +13973,7 @@
         <p:spPr>
           <a:xfrm>
             <a:off x="231480" y="1739880"/>
-            <a:ext cx="8682120" cy="1478160"/>
+            <a:ext cx="8681760" cy="1477800"/>
           </a:xfrm>
           <a:prstGeom prst="rect">
             <a:avLst/>
@@ -14088,7 +14053,7 @@
         <p:spPr>
           <a:xfrm>
             <a:off x="251640" y="2514600"/>
-            <a:ext cx="8705160" cy="4062240"/>
+            <a:ext cx="8704800" cy="4061880"/>
           </a:xfrm>
           <a:prstGeom prst="rect">
             <a:avLst/>
@@ -14351,6 +14316,42 @@
           <a:p>
             <a:pPr>
               <a:lnSpc>
+                <a:spcPct val="100000"/>
+              </a:lnSpc>
+            </a:pPr>
+            <a:endParaRPr b="0" lang="en-US" sz="1800" spc="-1" strike="noStrike">
+              <a:solidFill>
+                <a:srgbClr val="000000"/>
+              </a:solidFill>
+              <a:latin typeface="Arial"/>
+            </a:endParaRPr>
+          </a:p>
+          <a:p>
+            <a:pPr>
+              <a:lnSpc>
+                <a:spcPct val="100000"/>
+              </a:lnSpc>
+            </a:pPr>
+            <a:r>
+              <a:rPr b="1" lang="en-US" sz="1800" spc="-1" strike="noStrike">
+                <a:solidFill>
+                  <a:srgbClr val="000000"/>
+                </a:solidFill>
+                <a:latin typeface="Calibri"/>
+                <a:ea typeface="DejaVu Sans"/>
+              </a:rPr>
+              <a:t>make olddefconfig</a:t>
+            </a:r>
+            <a:endParaRPr b="0" lang="en-US" sz="1800" spc="-1" strike="noStrike">
+              <a:solidFill>
+                <a:srgbClr val="000000"/>
+              </a:solidFill>
+              <a:latin typeface="Arial"/>
+            </a:endParaRPr>
+          </a:p>
+          <a:p>
+            <a:pPr>
+              <a:lnSpc>
                 <a:spcPts val="1375"/>
               </a:lnSpc>
             </a:pPr>
@@ -14372,7 +14373,7 @@
         <p:spPr>
           <a:xfrm>
             <a:off x="1727280" y="3479760"/>
-            <a:ext cx="91800" cy="500040"/>
+            <a:ext cx="91440" cy="499680"/>
           </a:xfrm>
           <a:prstGeom prst="rect">
             <a:avLst/>
@@ -14426,7 +14427,7 @@
         <p:spPr>
           <a:xfrm>
             <a:off x="32040" y="4508280"/>
-            <a:ext cx="360" cy="709200"/>
+            <a:ext cx="360" cy="708840"/>
           </a:xfrm>
           <a:prstGeom prst="rect">
             <a:avLst/>
@@ -14517,7 +14518,7 @@
         <p:spPr>
           <a:xfrm>
             <a:off x="0" y="0"/>
-            <a:ext cx="9136080" cy="6837480"/>
+            <a:ext cx="9135720" cy="6837120"/>
           </a:xfrm>
           <a:prstGeom prst="rect">
             <a:avLst/>
@@ -14536,7 +14537,7 @@
         <p:spPr>
           <a:xfrm>
             <a:off x="2966400" y="524880"/>
-            <a:ext cx="3088440" cy="708480"/>
+            <a:ext cx="3088080" cy="708120"/>
           </a:xfrm>
           <a:prstGeom prst="rect">
             <a:avLst/>
@@ -14590,7 +14591,7 @@
         <p:spPr>
           <a:xfrm>
             <a:off x="226080" y="1191600"/>
-            <a:ext cx="8687520" cy="708480"/>
+            <a:ext cx="8687160" cy="708120"/>
           </a:xfrm>
           <a:prstGeom prst="rect">
             <a:avLst/>
@@ -14644,7 +14645,7 @@
         <p:spPr>
           <a:xfrm>
             <a:off x="934200" y="1866960"/>
-            <a:ext cx="5713200" cy="708480"/>
+            <a:ext cx="5712840" cy="708120"/>
           </a:xfrm>
           <a:prstGeom prst="rect">
             <a:avLst/>
@@ -14698,7 +14699,7 @@
         <p:spPr>
           <a:xfrm>
             <a:off x="413280" y="2127240"/>
-            <a:ext cx="8500320" cy="1478160"/>
+            <a:ext cx="8499960" cy="1477800"/>
           </a:xfrm>
           <a:prstGeom prst="rect">
             <a:avLst/>
@@ -14788,7 +14789,7 @@
         <p:spPr>
           <a:xfrm>
             <a:off x="1804680" y="2865960"/>
-            <a:ext cx="5340240" cy="1478160"/>
+            <a:ext cx="5339880" cy="1477800"/>
           </a:xfrm>
           <a:prstGeom prst="rect">
             <a:avLst/>
@@ -14888,7 +14889,7 @@
         <p:spPr>
           <a:xfrm>
             <a:off x="2562120" y="4186800"/>
-            <a:ext cx="1881360" cy="708480"/>
+            <a:ext cx="1881000" cy="708120"/>
           </a:xfrm>
           <a:prstGeom prst="rect">
             <a:avLst/>
@@ -14942,7 +14943,7 @@
         <p:spPr>
           <a:xfrm>
             <a:off x="3203280" y="4813200"/>
-            <a:ext cx="3504240" cy="708480"/>
+            <a:ext cx="3503880" cy="708120"/>
           </a:xfrm>
           <a:prstGeom prst="rect">
             <a:avLst/>
@@ -14996,7 +14997,7 @@
         <p:spPr>
           <a:xfrm>
             <a:off x="3199320" y="5200560"/>
-            <a:ext cx="3799800" cy="708480"/>
+            <a:ext cx="3799440" cy="708120"/>
           </a:xfrm>
           <a:prstGeom prst="rect">
             <a:avLst/>
@@ -15080,7 +15081,7 @@
         <p:spPr>
           <a:xfrm>
             <a:off x="0" y="0"/>
-            <a:ext cx="9065520" cy="6010920"/>
+            <a:ext cx="9065160" cy="6010560"/>
           </a:xfrm>
           <a:prstGeom prst="rect">
             <a:avLst/>
@@ -15772,7 +15773,7 @@
         <p:spPr>
           <a:xfrm>
             <a:off x="3717000" y="355680"/>
-            <a:ext cx="2082960" cy="708480"/>
+            <a:ext cx="2082600" cy="708120"/>
           </a:xfrm>
           <a:prstGeom prst="rect">
             <a:avLst/>
@@ -15826,7 +15827,7 @@
         <p:spPr>
           <a:xfrm>
             <a:off x="72000" y="792000"/>
-            <a:ext cx="8852040" cy="924480"/>
+            <a:ext cx="8851680" cy="924120"/>
           </a:xfrm>
           <a:prstGeom prst="rect">
             <a:avLst/>
@@ -15900,7 +15901,7 @@
         <p:spPr>
           <a:xfrm>
             <a:off x="444240" y="1447920"/>
-            <a:ext cx="8628120" cy="1443240"/>
+            <a:ext cx="8627760" cy="1442880"/>
           </a:xfrm>
           <a:prstGeom prst="rect">
             <a:avLst/>
@@ -15957,7 +15958,7 @@
         <p:spPr>
           <a:xfrm>
             <a:off x="264960" y="555120"/>
-            <a:ext cx="8659080" cy="3256920"/>
+            <a:ext cx="8658720" cy="3256560"/>
           </a:xfrm>
           <a:prstGeom prst="rect">
             <a:avLst/>
@@ -16002,7 +16003,7 @@
         <p:spPr>
           <a:xfrm>
             <a:off x="667800" y="3276720"/>
-            <a:ext cx="8181360" cy="1069200"/>
+            <a:ext cx="8181000" cy="1068840"/>
           </a:xfrm>
           <a:prstGeom prst="rect">
             <a:avLst/>
@@ -16047,7 +16048,7 @@
         <p:spPr>
           <a:xfrm>
             <a:off x="47880" y="2239560"/>
-            <a:ext cx="812160" cy="708480"/>
+            <a:ext cx="811800" cy="708120"/>
           </a:xfrm>
           <a:prstGeom prst="rect">
             <a:avLst/>
@@ -16101,7 +16102,7 @@
         <p:spPr>
           <a:xfrm>
             <a:off x="216000" y="2466000"/>
-            <a:ext cx="8636040" cy="1096920"/>
+            <a:ext cx="8635680" cy="1096560"/>
           </a:xfrm>
           <a:prstGeom prst="rect">
             <a:avLst/>
@@ -16191,7 +16192,7 @@
         <p:spPr>
           <a:xfrm>
             <a:off x="216000" y="4803480"/>
-            <a:ext cx="7986240" cy="340560"/>
+            <a:ext cx="7985880" cy="340200"/>
           </a:xfrm>
           <a:prstGeom prst="rect">
             <a:avLst/>
@@ -16225,6 +16226,19 @@
                 <a:latin typeface="Arial"/>
                 <a:ea typeface="DejaVu Sans"/>
               </a:rPr>
+              <a:t>make olddefconfig</a:t>
+            </a:r>
+            <a:br>
+              <a:rPr sz="1800"/>
+            </a:br>
+            <a:r>
+              <a:rPr b="1" lang="en-IN" sz="1800" spc="-1" strike="noStrike">
+                <a:solidFill>
+                  <a:srgbClr val="000000"/>
+                </a:solidFill>
+                <a:latin typeface="Arial"/>
+                <a:ea typeface="DejaVu Sans"/>
+              </a:rPr>
               <a:t>make -jn , make modules, make modules_install, make install</a:t>
             </a:r>
             <a:endParaRPr b="0" lang="en-US" sz="1800" spc="-1" strike="noStrike">
@@ -16245,7 +16259,7 @@
         <p:spPr>
           <a:xfrm>
             <a:off x="0" y="936000"/>
-            <a:ext cx="8888040" cy="1348200"/>
+            <a:ext cx="8887680" cy="1347840"/>
           </a:xfrm>
           <a:prstGeom prst="rect">
             <a:avLst/>
@@ -16299,7 +16313,7 @@
         <p:spPr>
           <a:xfrm>
             <a:off x="93240" y="3133440"/>
-            <a:ext cx="8902800" cy="1347840"/>
+            <a:ext cx="8902440" cy="1347480"/>
           </a:xfrm>
           <a:prstGeom prst="rect">
             <a:avLst/>
@@ -16353,7 +16367,7 @@
         <p:spPr>
           <a:xfrm>
             <a:off x="264960" y="5365800"/>
-            <a:ext cx="7697880" cy="856440"/>
+            <a:ext cx="7697520" cy="856080"/>
           </a:xfrm>
           <a:prstGeom prst="rect">
             <a:avLst/>
@@ -16503,7 +16517,7 @@
         <p:spPr>
           <a:xfrm>
             <a:off x="333360" y="2514600"/>
-            <a:ext cx="8580600" cy="1493640"/>
+            <a:ext cx="8580240" cy="1493280"/>
           </a:xfrm>
           <a:prstGeom prst="rect">
             <a:avLst/>
@@ -16616,7 +16630,7 @@
         <p:spPr>
           <a:xfrm>
             <a:off x="389880" y="324000"/>
-            <a:ext cx="3026160" cy="710280"/>
+            <a:ext cx="3025800" cy="709920"/>
           </a:xfrm>
           <a:prstGeom prst="rect">
             <a:avLst/>
@@ -16670,7 +16684,7 @@
         <p:spPr>
           <a:xfrm>
             <a:off x="432000" y="756000"/>
-            <a:ext cx="7827120" cy="708480"/>
+            <a:ext cx="7826760" cy="708120"/>
           </a:xfrm>
           <a:prstGeom prst="rect">
             <a:avLst/>
@@ -16724,7 +16738,7 @@
         <p:spPr>
           <a:xfrm>
             <a:off x="4591440" y="1612440"/>
-            <a:ext cx="906120" cy="708480"/>
+            <a:ext cx="905760" cy="708120"/>
           </a:xfrm>
           <a:prstGeom prst="rect">
             <a:avLst/>
@@ -16778,7 +16792,7 @@
         <p:spPr>
           <a:xfrm>
             <a:off x="394200" y="1896120"/>
-            <a:ext cx="8508600" cy="1096920"/>
+            <a:ext cx="8508240" cy="1096560"/>
           </a:xfrm>
           <a:prstGeom prst="rect">
             <a:avLst/>
@@ -16868,7 +16882,7 @@
         <p:spPr>
           <a:xfrm>
             <a:off x="374760" y="3748680"/>
-            <a:ext cx="1851120" cy="708480"/>
+            <a:ext cx="1850760" cy="708120"/>
           </a:xfrm>
           <a:prstGeom prst="rect">
             <a:avLst/>
@@ -16922,7 +16936,7 @@
         <p:spPr>
           <a:xfrm>
             <a:off x="392040" y="3867120"/>
-            <a:ext cx="8100000" cy="1096920"/>
+            <a:ext cx="8099640" cy="1096560"/>
           </a:xfrm>
           <a:prstGeom prst="rect">
             <a:avLst/>
@@ -17025,7 +17039,7 @@
         <p:spPr>
           <a:xfrm>
             <a:off x="367200" y="5429520"/>
-            <a:ext cx="4530240" cy="708480"/>
+            <a:ext cx="4529880" cy="708120"/>
           </a:xfrm>
           <a:prstGeom prst="rect">
             <a:avLst/>
@@ -17089,7 +17103,7 @@
         <p:spPr>
           <a:xfrm>
             <a:off x="381600" y="5041800"/>
-            <a:ext cx="8136000" cy="1059840"/>
+            <a:ext cx="8135640" cy="1059480"/>
           </a:xfrm>
           <a:prstGeom prst="rect">
             <a:avLst/>
@@ -17166,7 +17180,7 @@
         <p:spPr>
           <a:xfrm>
             <a:off x="382680" y="1254240"/>
-            <a:ext cx="6381360" cy="708480"/>
+            <a:ext cx="6381000" cy="708120"/>
           </a:xfrm>
           <a:prstGeom prst="rect">
             <a:avLst/>
@@ -17299,7 +17313,7 @@
         <p:spPr>
           <a:xfrm>
             <a:off x="120600" y="313200"/>
-            <a:ext cx="8634240" cy="1108440"/>
+            <a:ext cx="8633880" cy="1108080"/>
           </a:xfrm>
           <a:prstGeom prst="rect">
             <a:avLst/>
@@ -18282,7 +18296,7 @@
         <p:spPr>
           <a:xfrm>
             <a:off x="0" y="0"/>
-            <a:ext cx="9136080" cy="6837480"/>
+            <a:ext cx="9135720" cy="6837120"/>
           </a:xfrm>
           <a:prstGeom prst="rect">
             <a:avLst/>
@@ -18301,7 +18315,7 @@
         <p:spPr>
           <a:xfrm>
             <a:off x="4573800" y="203040"/>
-            <a:ext cx="3049200" cy="708480"/>
+            <a:ext cx="3048840" cy="708120"/>
           </a:xfrm>
           <a:prstGeom prst="rect">
             <a:avLst/>
@@ -18355,7 +18369,7 @@
         <p:spPr>
           <a:xfrm>
             <a:off x="3956040" y="901800"/>
-            <a:ext cx="1668240" cy="588960"/>
+            <a:ext cx="1667880" cy="588600"/>
           </a:xfrm>
           <a:prstGeom prst="rect">
             <a:avLst/>
@@ -18409,7 +18423,7 @@
         <p:spPr>
           <a:xfrm>
             <a:off x="4280400" y="1498680"/>
-            <a:ext cx="1539720" cy="588960"/>
+            <a:ext cx="1539360" cy="588600"/>
           </a:xfrm>
           <a:prstGeom prst="rect">
             <a:avLst/>
@@ -18463,7 +18477,7 @@
         <p:spPr>
           <a:xfrm>
             <a:off x="4412880" y="2565360"/>
-            <a:ext cx="1885320" cy="588960"/>
+            <a:ext cx="1884960" cy="588600"/>
           </a:xfrm>
           <a:prstGeom prst="rect">
             <a:avLst/>
@@ -18517,7 +18531,7 @@
         <p:spPr>
           <a:xfrm>
             <a:off x="4641480" y="3632040"/>
-            <a:ext cx="1885320" cy="588960"/>
+            <a:ext cx="1884960" cy="588600"/>
           </a:xfrm>
           <a:prstGeom prst="rect">
             <a:avLst/>
@@ -18571,7 +18585,7 @@
         <p:spPr>
           <a:xfrm>
             <a:off x="5636880" y="4699080"/>
-            <a:ext cx="669240" cy="588960"/>
+            <a:ext cx="668880" cy="588600"/>
           </a:xfrm>
           <a:prstGeom prst="rect">
             <a:avLst/>
@@ -18625,7 +18639,7 @@
         <p:spPr>
           <a:xfrm>
             <a:off x="5932080" y="5765760"/>
-            <a:ext cx="307440" cy="588960"/>
+            <a:ext cx="307080" cy="588600"/>
           </a:xfrm>
           <a:prstGeom prst="rect">
             <a:avLst/>
@@ -18679,7 +18693,7 @@
         <p:spPr>
           <a:xfrm>
             <a:off x="7000920" y="1498680"/>
-            <a:ext cx="1877760" cy="588960"/>
+            <a:ext cx="1877400" cy="588600"/>
           </a:xfrm>
           <a:prstGeom prst="rect">
             <a:avLst/>
@@ -18733,7 +18747,7 @@
         <p:spPr>
           <a:xfrm>
             <a:off x="6908400" y="2565360"/>
-            <a:ext cx="2075400" cy="588960"/>
+            <a:ext cx="2075040" cy="588600"/>
           </a:xfrm>
           <a:prstGeom prst="rect">
             <a:avLst/>
@@ -18787,7 +18801,7 @@
         <p:spPr>
           <a:xfrm>
             <a:off x="7141320" y="3632040"/>
-            <a:ext cx="1686240" cy="588960"/>
+            <a:ext cx="1685880" cy="588600"/>
           </a:xfrm>
           <a:prstGeom prst="rect">
             <a:avLst/>
@@ -18841,7 +18855,7 @@
         <p:spPr>
           <a:xfrm>
             <a:off x="7707240" y="4699080"/>
-            <a:ext cx="554400" cy="588960"/>
+            <a:ext cx="554040" cy="588600"/>
           </a:xfrm>
           <a:prstGeom prst="rect">
             <a:avLst/>
@@ -18895,7 +18909,7 @@
         <p:spPr>
           <a:xfrm>
             <a:off x="7455960" y="5765760"/>
-            <a:ext cx="1208520" cy="588960"/>
+            <a:ext cx="1208160" cy="588600"/>
           </a:xfrm>
           <a:prstGeom prst="rect">
             <a:avLst/>
@@ -18949,7 +18963,7 @@
         <p:spPr>
           <a:xfrm>
             <a:off x="5283000" y="5892840"/>
-            <a:ext cx="1021320" cy="580320"/>
+            <a:ext cx="1020960" cy="579960"/>
           </a:xfrm>
           <a:prstGeom prst="rect">
             <a:avLst/>
@@ -19037,7 +19051,7 @@
         <p:spPr>
           <a:xfrm>
             <a:off x="4066200" y="2995200"/>
-            <a:ext cx="5256360" cy="3980160"/>
+            <a:ext cx="5256000" cy="3979800"/>
           </a:xfrm>
           <a:prstGeom prst="rect">
             <a:avLst/>
@@ -19056,7 +19070,7 @@
         <p:spPr>
           <a:xfrm>
             <a:off x="2225880" y="275040"/>
-            <a:ext cx="2840400" cy="708480"/>
+            <a:ext cx="2840040" cy="708120"/>
           </a:xfrm>
           <a:prstGeom prst="rect">
             <a:avLst/>
@@ -19110,7 +19124,7 @@
         <p:spPr>
           <a:xfrm>
             <a:off x="0" y="450720"/>
-            <a:ext cx="9142560" cy="3133440"/>
+            <a:ext cx="9142200" cy="3133080"/>
           </a:xfrm>
           <a:prstGeom prst="rect">
             <a:avLst/>
@@ -19524,7 +19538,7 @@
         <p:spPr>
           <a:xfrm>
             <a:off x="65520" y="75600"/>
-            <a:ext cx="9161640" cy="2136960"/>
+            <a:ext cx="9161280" cy="2136600"/>
           </a:xfrm>
           <a:prstGeom prst="rect">
             <a:avLst/>
@@ -19760,7 +19774,7 @@
         <p:spPr>
           <a:xfrm>
             <a:off x="2286000" y="1828800"/>
-            <a:ext cx="5103720" cy="4654800"/>
+            <a:ext cx="5103360" cy="4654440"/>
           </a:xfrm>
           <a:prstGeom prst="rect">
             <a:avLst/>
@@ -19809,7 +19823,7 @@
         <p:spPr>
           <a:xfrm>
             <a:off x="228600" y="457200"/>
-            <a:ext cx="6856560" cy="600840"/>
+            <a:ext cx="6856200" cy="600480"/>
           </a:xfrm>
           <a:prstGeom prst="rect">
             <a:avLst/>
@@ -19867,7 +19881,7 @@
         <p:spPr>
           <a:xfrm>
             <a:off x="460800" y="1143000"/>
-            <a:ext cx="7995960" cy="4629960"/>
+            <a:ext cx="7995600" cy="4629600"/>
           </a:xfrm>
           <a:prstGeom prst="rect">
             <a:avLst/>
@@ -19920,7 +19934,7 @@
         <p:spPr>
           <a:xfrm>
             <a:off x="0" y="0"/>
-            <a:ext cx="9136080" cy="6837480"/>
+            <a:ext cx="9135720" cy="6837120"/>
           </a:xfrm>
           <a:prstGeom prst="rect">
             <a:avLst/>
@@ -19939,7 +19953,7 @@
         <p:spPr>
           <a:xfrm>
             <a:off x="2285640" y="658440"/>
-            <a:ext cx="5022000" cy="708480"/>
+            <a:ext cx="5021640" cy="708120"/>
           </a:xfrm>
           <a:prstGeom prst="rect">
             <a:avLst/>
@@ -19993,7 +20007,7 @@
         <p:spPr>
           <a:xfrm>
             <a:off x="1398600" y="1384200"/>
-            <a:ext cx="7012080" cy="708480"/>
+            <a:ext cx="7011720" cy="708120"/>
           </a:xfrm>
           <a:prstGeom prst="rect">
             <a:avLst/>
@@ -20047,7 +20061,7 @@
         <p:spPr>
           <a:xfrm>
             <a:off x="3040920" y="2034360"/>
-            <a:ext cx="2143080" cy="708480"/>
+            <a:ext cx="2142720" cy="708120"/>
           </a:xfrm>
           <a:prstGeom prst="rect">
             <a:avLst/>
@@ -20111,7 +20125,7 @@
         <p:spPr>
           <a:xfrm>
             <a:off x="3005280" y="2601360"/>
-            <a:ext cx="2430360" cy="708480"/>
+            <a:ext cx="2430000" cy="708120"/>
           </a:xfrm>
           <a:prstGeom prst="rect">
             <a:avLst/>
@@ -20175,7 +20189,7 @@
         <p:spPr>
           <a:xfrm>
             <a:off x="3029760" y="3168720"/>
-            <a:ext cx="2237400" cy="708480"/>
+            <a:ext cx="2237040" cy="708120"/>
           </a:xfrm>
           <a:prstGeom prst="rect">
             <a:avLst/>
@@ -20239,7 +20253,7 @@
         <p:spPr>
           <a:xfrm>
             <a:off x="2969640" y="3664080"/>
-            <a:ext cx="2573640" cy="708480"/>
+            <a:ext cx="2573280" cy="708120"/>
           </a:xfrm>
           <a:prstGeom prst="rect">
             <a:avLst/>
@@ -20333,7 +20347,7 @@
         <p:spPr>
           <a:xfrm>
             <a:off x="0" y="457200"/>
-            <a:ext cx="8913960" cy="3672360"/>
+            <a:ext cx="8913600" cy="3672000"/>
           </a:xfrm>
           <a:prstGeom prst="rect">
             <a:avLst/>
@@ -20843,7 +20857,7 @@
         <p:spPr>
           <a:xfrm>
             <a:off x="38520" y="73800"/>
-            <a:ext cx="2102040" cy="600840"/>
+            <a:ext cx="2101680" cy="600480"/>
           </a:xfrm>
           <a:prstGeom prst="rect">
             <a:avLst/>
@@ -20927,7 +20941,7 @@
         <p:spPr>
           <a:xfrm>
             <a:off x="228600" y="228600"/>
-            <a:ext cx="5713560" cy="600840"/>
+            <a:ext cx="5713200" cy="600480"/>
           </a:xfrm>
           <a:prstGeom prst="rect">
             <a:avLst/>
@@ -20985,7 +20999,7 @@
         <p:spPr>
           <a:xfrm>
             <a:off x="685800" y="1600200"/>
-            <a:ext cx="7927920" cy="3875760"/>
+            <a:ext cx="7927560" cy="3875400"/>
           </a:xfrm>
           <a:prstGeom prst="rect">
             <a:avLst/>
@@ -21038,7 +21052,7 @@
         <p:spPr>
           <a:xfrm>
             <a:off x="20880" y="727920"/>
-            <a:ext cx="9136440" cy="5414040"/>
+            <a:ext cx="9136080" cy="5413680"/>
           </a:xfrm>
           <a:prstGeom prst="rect">
             <a:avLst/>
@@ -21087,7 +21101,7 @@
         <p:spPr>
           <a:xfrm>
             <a:off x="72000" y="144000"/>
-            <a:ext cx="8994240" cy="4179960"/>
+            <a:ext cx="8993880" cy="4179600"/>
           </a:xfrm>
           <a:prstGeom prst="rect">
             <a:avLst/>
@@ -21493,7 +21507,7 @@
         <p:spPr>
           <a:xfrm>
             <a:off x="-90720" y="94680"/>
-            <a:ext cx="9083520" cy="6226200"/>
+            <a:ext cx="9083160" cy="6225840"/>
           </a:xfrm>
           <a:prstGeom prst="rect">
             <a:avLst/>
@@ -21913,7 +21927,7 @@
         <p:spPr>
           <a:xfrm>
             <a:off x="145080" y="72000"/>
-            <a:ext cx="8992800" cy="6226200"/>
+            <a:ext cx="8992440" cy="6225840"/>
           </a:xfrm>
           <a:prstGeom prst="rect">
             <a:avLst/>
@@ -22308,7 +22322,7 @@
       </p:grpSpPr>
       <p:pic>
         <p:nvPicPr>
-          <p:cNvPr id="215" name="Picture 1" descr=""/>
+          <p:cNvPr id="215" name="" descr=""/>
           <p:cNvPicPr/>
           <p:nvPr/>
         </p:nvPicPr>
@@ -22318,8 +22332,8 @@
         </p:blipFill>
         <p:spPr>
           <a:xfrm>
-            <a:off x="0" y="0"/>
-            <a:ext cx="9136080" cy="6837480"/>
+            <a:off x="2860200" y="51840"/>
+            <a:ext cx="5715000" cy="6666120"/>
           </a:xfrm>
           <a:prstGeom prst="rect">
             <a:avLst/>
@@ -22331,14 +22345,14 @@
       </p:pic>
       <p:sp>
         <p:nvSpPr>
-          <p:cNvPr id="216" name="CustomShape 1"/>
-          <p:cNvSpPr/>
+          <p:cNvPr id="216" name=""/>
+          <p:cNvSpPr txBox="1"/>
           <p:nvPr/>
         </p:nvSpPr>
         <p:spPr>
           <a:xfrm>
-            <a:off x="4369680" y="254160"/>
-            <a:ext cx="828360" cy="708480"/>
+            <a:off x="228600" y="228600"/>
+            <a:ext cx="2286000" cy="685800"/>
           </a:xfrm>
           <a:prstGeom prst="rect">
             <a:avLst/>
@@ -22348,344 +22362,21 @@
             <a:noFill/>
           </a:ln>
         </p:spPr>
-        <p:style>
-          <a:lnRef idx="0"/>
-          <a:fillRef idx="0"/>
-          <a:effectRef idx="0"/>
-          <a:fontRef idx="minor"/>
-        </p:style>
-        <p:txBody>
-          <a:bodyPr wrap="none" lIns="0" rIns="0" tIns="0" bIns="0" anchor="t">
-            <a:noAutofit/>
-          </a:bodyPr>
-          <a:p>
-            <a:pPr>
-              <a:lnSpc>
-                <a:spcPts val="975"/>
-              </a:lnSpc>
-            </a:pPr>
-            <a:r>
-              <a:rPr b="1" lang="en-US" sz="2240" spc="-1" strike="noStrike">
-                <a:solidFill>
-                  <a:srgbClr val="000000"/>
-                </a:solidFill>
-                <a:latin typeface="Arial Bold"/>
-                <a:ea typeface="DejaVu Sans"/>
-              </a:rPr>
-              <a:t>GRUB</a:t>
-            </a:r>
-            <a:endParaRPr b="0" lang="en-US" sz="2240" spc="-1" strike="noStrike">
-              <a:solidFill>
-                <a:srgbClr val="000000"/>
-              </a:solidFill>
-              <a:latin typeface="Arial"/>
-            </a:endParaRPr>
-          </a:p>
-        </p:txBody>
-      </p:sp>
-      <p:sp>
-        <p:nvSpPr>
-          <p:cNvPr id="217" name=""/>
-          <p:cNvSpPr/>
-          <p:nvPr/>
-        </p:nvSpPr>
-        <p:spPr>
-          <a:xfrm>
-            <a:off x="130320" y="457200"/>
-            <a:ext cx="8555040" cy="3672720"/>
-          </a:xfrm>
-          <a:prstGeom prst="rect">
-            <a:avLst/>
-          </a:prstGeom>
-          <a:noFill/>
-          <a:ln w="0">
-            <a:noFill/>
-          </a:ln>
-        </p:spPr>
-        <p:style>
-          <a:lnRef idx="0"/>
-          <a:fillRef idx="0"/>
-          <a:effectRef idx="0"/>
-          <a:fontRef idx="minor"/>
-        </p:style>
         <p:txBody>
           <a:bodyPr lIns="90000" rIns="90000" tIns="45000" bIns="45000" anchor="t">
             <a:noAutofit/>
           </a:bodyPr>
           <a:p>
-            <a:pPr>
-              <a:lnSpc>
-                <a:spcPct val="100000"/>
-              </a:lnSpc>
-            </a:pPr>
-            <a:r>
-              <a:rPr b="0" lang="en-US" sz="1800" spc="-1" strike="noStrike">
-                <a:solidFill>
-                  <a:srgbClr val="000000"/>
-                </a:solidFill>
-                <a:latin typeface="Arial"/>
-                <a:ea typeface="DejaVu Sans"/>
-              </a:rPr>
-              <a:t>Grand Unified Bootloader, from the GNU project</a:t>
-            </a:r>
-            <a:br>
-              <a:rPr sz="1800"/>
-            </a:br>
-            <a:endParaRPr b="0" lang="en-US" sz="1800" spc="-1" strike="noStrike">
-              <a:solidFill>
-                <a:srgbClr val="000000"/>
-              </a:solidFill>
-              <a:latin typeface="Arial"/>
-            </a:endParaRPr>
-          </a:p>
-          <a:p>
-            <a:pPr>
-              <a:lnSpc>
-                <a:spcPct val="100000"/>
-              </a:lnSpc>
-            </a:pPr>
-            <a:r>
-              <a:rPr b="0" lang="en-US" sz="1800" spc="-1" strike="noStrike">
-                <a:solidFill>
-                  <a:srgbClr val="000000"/>
-                </a:solidFill>
-                <a:latin typeface="Arial"/>
-                <a:ea typeface="DejaVu Sans"/>
-              </a:rPr>
-              <a:t>▶ </a:t>
-            </a:r>
-            <a:r>
-              <a:rPr b="0" lang="en-US" sz="1800" spc="-1" strike="noStrike">
-                <a:solidFill>
-                  <a:srgbClr val="000000"/>
-                </a:solidFill>
-                <a:latin typeface="Arial"/>
-                <a:ea typeface="DejaVu Sans"/>
-              </a:rPr>
-              <a:t>De-facto standard in most Linux distributions for x86 platforms</a:t>
-            </a:r>
-            <a:endParaRPr b="0" lang="en-US" sz="1800" spc="-1" strike="noStrike">
-              <a:solidFill>
-                <a:srgbClr val="000000"/>
-              </a:solidFill>
-              <a:latin typeface="Arial"/>
-            </a:endParaRPr>
-          </a:p>
-          <a:p>
-            <a:pPr>
-              <a:lnSpc>
-                <a:spcPct val="100000"/>
-              </a:lnSpc>
-            </a:pPr>
-            <a:r>
-              <a:rPr b="0" lang="en-US" sz="1800" spc="-1" strike="noStrike">
-                <a:solidFill>
-                  <a:srgbClr val="000000"/>
-                </a:solidFill>
-                <a:latin typeface="Arial"/>
-                <a:ea typeface="DejaVu Sans"/>
-              </a:rPr>
-              <a:t>▶ </a:t>
-            </a:r>
-            <a:r>
-              <a:rPr b="0" lang="en-US" sz="1800" spc="-1" strike="noStrike">
-                <a:solidFill>
-                  <a:srgbClr val="000000"/>
-                </a:solidFill>
-                <a:latin typeface="Arial"/>
-                <a:ea typeface="DejaVu Sans"/>
-              </a:rPr>
-              <a:t>Supports x86 legacy and UEFI systems</a:t>
-            </a:r>
-            <a:endParaRPr b="0" lang="en-US" sz="1800" spc="-1" strike="noStrike">
-              <a:solidFill>
-                <a:srgbClr val="000000"/>
-              </a:solidFill>
-              <a:latin typeface="Arial"/>
-            </a:endParaRPr>
-          </a:p>
-          <a:p>
-            <a:pPr>
-              <a:lnSpc>
-                <a:spcPct val="100000"/>
-              </a:lnSpc>
-            </a:pPr>
-            <a:r>
-              <a:rPr b="0" lang="en-US" sz="1800" spc="-1" strike="noStrike">
-                <a:solidFill>
-                  <a:srgbClr val="000000"/>
-                </a:solidFill>
-                <a:latin typeface="Arial"/>
-                <a:ea typeface="DejaVu Sans"/>
-              </a:rPr>
-              <a:t>▶ </a:t>
-            </a:r>
-            <a:r>
-              <a:rPr b="0" lang="en-US" sz="1800" spc="-1" strike="noStrike">
-                <a:solidFill>
-                  <a:srgbClr val="000000"/>
-                </a:solidFill>
-                <a:latin typeface="Arial"/>
-                <a:ea typeface="DejaVu Sans"/>
-              </a:rPr>
-              <a:t>Can read many filesystem formats to load the kernel image, modules and configuration</a:t>
-            </a:r>
-            <a:endParaRPr b="0" lang="en-US" sz="1800" spc="-1" strike="noStrike">
-              <a:solidFill>
-                <a:srgbClr val="000000"/>
-              </a:solidFill>
-              <a:latin typeface="Arial"/>
-            </a:endParaRPr>
-          </a:p>
-          <a:p>
-            <a:pPr>
-              <a:lnSpc>
-                <a:spcPct val="100000"/>
-              </a:lnSpc>
-            </a:pPr>
-            <a:r>
-              <a:rPr b="0" lang="en-US" sz="1800" spc="-1" strike="noStrike">
-                <a:solidFill>
-                  <a:srgbClr val="000000"/>
-                </a:solidFill>
-                <a:latin typeface="Arial"/>
-                <a:ea typeface="DejaVu Sans"/>
-              </a:rPr>
-              <a:t>▶ </a:t>
-            </a:r>
-            <a:r>
-              <a:rPr b="0" lang="en-US" sz="1800" spc="-1" strike="noStrike">
-                <a:solidFill>
-                  <a:srgbClr val="000000"/>
-                </a:solidFill>
-                <a:latin typeface="Arial"/>
-                <a:ea typeface="DejaVu Sans"/>
-              </a:rPr>
-              <a:t>Provides a menu and powerful shell with various commands</a:t>
-            </a:r>
-            <a:endParaRPr b="0" lang="en-US" sz="1800" spc="-1" strike="noStrike">
-              <a:solidFill>
-                <a:srgbClr val="000000"/>
-              </a:solidFill>
-              <a:latin typeface="Arial"/>
-            </a:endParaRPr>
-          </a:p>
-          <a:p>
-            <a:pPr>
-              <a:lnSpc>
-                <a:spcPct val="100000"/>
-              </a:lnSpc>
-            </a:pPr>
-            <a:r>
-              <a:rPr b="0" lang="en-US" sz="1800" spc="-1" strike="noStrike">
-                <a:solidFill>
-                  <a:srgbClr val="000000"/>
-                </a:solidFill>
-                <a:latin typeface="Arial"/>
-                <a:ea typeface="DejaVu Sans"/>
-              </a:rPr>
-              <a:t>▶ </a:t>
-            </a:r>
-            <a:r>
-              <a:rPr b="0" lang="en-US" sz="1800" spc="-1" strike="noStrike">
-                <a:solidFill>
-                  <a:srgbClr val="000000"/>
-                </a:solidFill>
-                <a:latin typeface="Arial"/>
-                <a:ea typeface="DejaVu Sans"/>
-              </a:rPr>
-              <a:t>Can load kernel images over the network</a:t>
-            </a:r>
-            <a:endParaRPr b="0" lang="en-US" sz="1800" spc="-1" strike="noStrike">
-              <a:solidFill>
-                <a:srgbClr val="000000"/>
-              </a:solidFill>
-              <a:latin typeface="Arial"/>
-            </a:endParaRPr>
-          </a:p>
-          <a:p>
-            <a:pPr>
-              <a:lnSpc>
-                <a:spcPct val="100000"/>
-              </a:lnSpc>
-            </a:pPr>
-            <a:r>
-              <a:rPr b="0" lang="en-US" sz="1800" spc="-1" strike="noStrike">
-                <a:solidFill>
-                  <a:srgbClr val="000000"/>
-                </a:solidFill>
-                <a:latin typeface="Arial"/>
-                <a:ea typeface="DejaVu Sans"/>
-              </a:rPr>
-              <a:t>▶ </a:t>
-            </a:r>
-            <a:r>
-              <a:rPr b="0" lang="en-US" sz="1800" spc="-1" strike="noStrike">
-                <a:solidFill>
-                  <a:srgbClr val="000000"/>
-                </a:solidFill>
-                <a:latin typeface="Arial"/>
-                <a:ea typeface="DejaVu Sans"/>
-              </a:rPr>
-              <a:t>Also supports ARM, ARM64, RISC-V, PowerPC, but less popular than other</a:t>
-            </a:r>
-            <a:endParaRPr b="0" lang="en-US" sz="1800" spc="-1" strike="noStrike">
-              <a:solidFill>
-                <a:srgbClr val="000000"/>
-              </a:solidFill>
-              <a:latin typeface="Arial"/>
-            </a:endParaRPr>
-          </a:p>
-          <a:p>
-            <a:pPr>
-              <a:lnSpc>
-                <a:spcPct val="100000"/>
-              </a:lnSpc>
-            </a:pPr>
-            <a:r>
-              <a:rPr b="0" lang="en-US" sz="1800" spc="-1" strike="noStrike">
-                <a:solidFill>
-                  <a:srgbClr val="000000"/>
-                </a:solidFill>
-                <a:latin typeface="Arial"/>
-                <a:ea typeface="DejaVu Sans"/>
-              </a:rPr>
-              <a:t>bootloaders on those platforms</a:t>
-            </a:r>
-            <a:endParaRPr b="0" lang="en-US" sz="1800" spc="-1" strike="noStrike">
-              <a:solidFill>
-                <a:srgbClr val="000000"/>
-              </a:solidFill>
-              <a:latin typeface="Arial"/>
-            </a:endParaRPr>
-          </a:p>
-          <a:p>
-            <a:pPr>
-              <a:lnSpc>
-                <a:spcPct val="100000"/>
-              </a:lnSpc>
-            </a:pPr>
-            <a:r>
-              <a:rPr b="0" lang="en-US" sz="1800" spc="-1" strike="noStrike">
-                <a:solidFill>
-                  <a:srgbClr val="000000"/>
-                </a:solidFill>
-                <a:latin typeface="Arial"/>
-                <a:ea typeface="DejaVu Sans"/>
-              </a:rPr>
-              <a:t>▶ </a:t>
-            </a:r>
-            <a:r>
-              <a:rPr b="0" lang="en-US" sz="1800" spc="-1" strike="noStrike">
-                <a:solidFill>
-                  <a:srgbClr val="000000"/>
-                </a:solidFill>
-                <a:latin typeface="Arial"/>
-                <a:ea typeface="DejaVu Sans"/>
-              </a:rPr>
-              <a:t>https://www.gnu.org/software/grub/</a:t>
-            </a:r>
-            <a:endParaRPr b="0" lang="en-US" sz="1800" spc="-1" strike="noStrike">
+            <a:r>
+              <a:rPr b="1" lang="en-US" sz="1800" spc="-1" strike="noStrike">
+                <a:solidFill>
+                  <a:srgbClr val="000000"/>
+                </a:solidFill>
+                <a:latin typeface="Arial"/>
+              </a:rPr>
+              <a:t>X86 Boot Process</a:t>
+            </a:r>
+            <a:endParaRPr b="1" lang="en-US" sz="1800" spc="-1" strike="noStrike">
               <a:solidFill>
                 <a:srgbClr val="000000"/>
               </a:solidFill>
@@ -22694,29 +22385,6 @@
           </a:p>
         </p:txBody>
       </p:sp>
-      <p:pic>
-        <p:nvPicPr>
-          <p:cNvPr id="218" name="" descr=""/>
-          <p:cNvPicPr/>
-          <p:nvPr/>
-        </p:nvPicPr>
-        <p:blipFill>
-          <a:blip r:embed="rId2"/>
-          <a:stretch/>
-        </p:blipFill>
-        <p:spPr>
-          <a:xfrm>
-            <a:off x="1600200" y="3429000"/>
-            <a:ext cx="6170760" cy="3256560"/>
-          </a:xfrm>
-          <a:prstGeom prst="rect">
-            <a:avLst/>
-          </a:prstGeom>
-          <a:ln w="0">
-            <a:noFill/>
-          </a:ln>
-        </p:spPr>
-      </p:pic>
     </p:spTree>
   </p:cSld>
   <mc:AlternateContent>
@@ -22749,7 +22417,7 @@
       </p:grpSpPr>
       <p:pic>
         <p:nvPicPr>
-          <p:cNvPr id="219" name="Picture 1" descr=""/>
+          <p:cNvPr id="217" name="Picture 1" descr=""/>
           <p:cNvPicPr/>
           <p:nvPr/>
         </p:nvPicPr>
@@ -22760,7 +22428,7 @@
         <p:spPr>
           <a:xfrm>
             <a:off x="0" y="0"/>
-            <a:ext cx="9136080" cy="6837480"/>
+            <a:ext cx="9135720" cy="6837120"/>
           </a:xfrm>
           <a:prstGeom prst="rect">
             <a:avLst/>
@@ -22772,14 +22440,14 @@
       </p:pic>
       <p:sp>
         <p:nvSpPr>
-          <p:cNvPr id="220" name="CustomShape 1"/>
+          <p:cNvPr id="218" name="CustomShape 1"/>
           <p:cNvSpPr/>
           <p:nvPr/>
         </p:nvSpPr>
         <p:spPr>
           <a:xfrm>
-            <a:off x="3277800" y="431640"/>
-            <a:ext cx="2961360" cy="708480"/>
+            <a:off x="4369680" y="254160"/>
+            <a:ext cx="828000" cy="708120"/>
           </a:xfrm>
           <a:prstGeom prst="rect">
             <a:avLst/>
@@ -22813,7 +22481,7 @@
                 <a:latin typeface="Arial Bold"/>
                 <a:ea typeface="DejaVu Sans"/>
               </a:rPr>
-              <a:t>Initialization Overview</a:t>
+              <a:t>GRUB</a:t>
             </a:r>
             <a:endParaRPr b="0" lang="en-US" sz="2240" spc="-1" strike="noStrike">
               <a:solidFill>
@@ -22826,14 +22494,14 @@
       </p:sp>
       <p:sp>
         <p:nvSpPr>
-          <p:cNvPr id="221" name="CustomShape 2"/>
+          <p:cNvPr id="219" name=""/>
           <p:cNvSpPr/>
           <p:nvPr/>
         </p:nvSpPr>
         <p:spPr>
           <a:xfrm>
-            <a:off x="253080" y="651600"/>
-            <a:ext cx="8506800" cy="1443240"/>
+            <a:off x="130320" y="457200"/>
+            <a:ext cx="8554680" cy="3672360"/>
           </a:xfrm>
           <a:prstGeom prst="rect">
             <a:avLst/>
@@ -22850,7 +22518,7 @@
           <a:fontRef idx="minor"/>
         </p:style>
         <p:txBody>
-          <a:bodyPr wrap="none" lIns="0" rIns="0" tIns="0" bIns="0" anchor="t">
+          <a:bodyPr lIns="90000" rIns="90000" tIns="45000" bIns="45000" anchor="t">
             <a:noAutofit/>
           </a:bodyPr>
           <a:p>
@@ -22860,16 +22528,19 @@
               </a:lnSpc>
             </a:pPr>
             <a:r>
-              <a:rPr b="0" lang="en-US" sz="2230" spc="-1" strike="noStrike">
-                <a:solidFill>
-                  <a:srgbClr val="000000"/>
-                </a:solidFill>
-                <a:latin typeface="Arial"/>
-                <a:ea typeface="DejaVu Sans"/>
-              </a:rPr>
-              <a:t>When the operating system starts, the kernel runs /sbin/init. This can</a:t>
-            </a:r>
-            <a:endParaRPr b="0" lang="en-US" sz="2230" spc="-1" strike="noStrike">
+              <a:rPr b="0" lang="en-US" sz="1800" spc="-1" strike="noStrike">
+                <a:solidFill>
+                  <a:srgbClr val="000000"/>
+                </a:solidFill>
+                <a:latin typeface="Arial"/>
+                <a:ea typeface="DejaVu Sans"/>
+              </a:rPr>
+              <a:t>Grand Unified Bootloader, from the GNU project</a:t>
+            </a:r>
+            <a:br>
+              <a:rPr sz="1800"/>
+            </a:br>
+            <a:endParaRPr b="0" lang="en-US" sz="1800" spc="-1" strike="noStrike">
               <a:solidFill>
                 <a:srgbClr val="000000"/>
               </a:solidFill>
@@ -22883,89 +22554,32 @@
               </a:lnSpc>
             </a:pPr>
             <a:r>
-              <a:rPr b="0" lang="en-US" sz="2230" spc="-1" strike="noStrike">
-                <a:solidFill>
-                  <a:srgbClr val="000000"/>
-                </a:solidFill>
-                <a:latin typeface="Arial"/>
-                <a:ea typeface="DejaVu Sans"/>
-              </a:rPr>
-              <a:t>be either a script or a program, but typically it is a program that</a:t>
-            </a:r>
-            <a:endParaRPr b="0" lang="en-US" sz="2230" spc="-1" strike="noStrike">
-              <a:solidFill>
-                <a:srgbClr val="000000"/>
-              </a:solidFill>
-              <a:latin typeface="Arial"/>
-            </a:endParaRPr>
-          </a:p>
-          <a:p>
-            <a:pPr>
-              <a:lnSpc>
-                <a:spcPts val="1006"/>
-              </a:lnSpc>
-            </a:pPr>
-            <a:endParaRPr b="0" lang="en-US" sz="2230" spc="-1" strike="noStrike">
-              <a:solidFill>
-                <a:srgbClr val="000000"/>
-              </a:solidFill>
-              <a:latin typeface="Arial"/>
-            </a:endParaRPr>
-          </a:p>
-          <a:p>
-            <a:pPr>
-              <a:lnSpc>
-                <a:spcPts val="1006"/>
-              </a:lnSpc>
-            </a:pPr>
-            <a:r>
-              <a:rPr b="0" lang="en-US" sz="2230" spc="-1" strike="noStrike">
-                <a:solidFill>
-                  <a:srgbClr val="000000"/>
-                </a:solidFill>
-                <a:latin typeface="Arial"/>
-                <a:ea typeface="DejaVu Sans"/>
-              </a:rPr>
-              <a:t>processes the statements in /etc/initab.</a:t>
-            </a:r>
-            <a:endParaRPr b="0" lang="en-US" sz="2230" spc="-1" strike="noStrike">
-              <a:solidFill>
-                <a:srgbClr val="000000"/>
-              </a:solidFill>
-              <a:latin typeface="Arial"/>
-            </a:endParaRPr>
-          </a:p>
-        </p:txBody>
-      </p:sp>
-      <p:sp>
-        <p:nvSpPr>
-          <p:cNvPr id="222" name="CustomShape 3"/>
-          <p:cNvSpPr/>
-          <p:nvPr/>
-        </p:nvSpPr>
-        <p:spPr>
-          <a:xfrm>
-            <a:off x="274320" y="1698480"/>
-            <a:ext cx="8604360" cy="1465200"/>
-          </a:xfrm>
-          <a:prstGeom prst="rect">
-            <a:avLst/>
-          </a:prstGeom>
-          <a:noFill/>
-          <a:ln w="0">
-            <a:noFill/>
-          </a:ln>
-        </p:spPr>
-        <p:style>
-          <a:lnRef idx="0"/>
-          <a:fillRef idx="0"/>
-          <a:effectRef idx="0"/>
-          <a:fontRef idx="minor"/>
-        </p:style>
-        <p:txBody>
-          <a:bodyPr wrap="none" lIns="0" rIns="0" tIns="0" bIns="0" anchor="t">
-            <a:noAutofit/>
-          </a:bodyPr>
+              <a:rPr b="0" lang="en-US" sz="1800" spc="-1" strike="noStrike">
+                <a:solidFill>
+                  <a:srgbClr val="000000"/>
+                </a:solidFill>
+                <a:latin typeface="Arial"/>
+                <a:ea typeface="DejaVu Sans"/>
+              </a:rPr>
+              <a:t>▶ </a:t>
+            </a:r>
+            <a:r>
+              <a:rPr b="0" lang="en-US" sz="1800" spc="-1" strike="noStrike">
+                <a:solidFill>
+                  <a:srgbClr val="000000"/>
+                </a:solidFill>
+                <a:latin typeface="Arial"/>
+                <a:ea typeface="DejaVu Sans"/>
+              </a:rPr>
+              <a:t>De-facto standard in most Linux distributions for x86 platforms</a:t>
+            </a:r>
+            <a:endParaRPr b="0" lang="en-US" sz="1800" spc="-1" strike="noStrike">
+              <a:solidFill>
+                <a:srgbClr val="000000"/>
+              </a:solidFill>
+              <a:latin typeface="Arial"/>
+            </a:endParaRPr>
+          </a:p>
           <a:p>
             <a:pPr>
               <a:lnSpc>
@@ -22973,16 +22587,26 @@
               </a:lnSpc>
             </a:pPr>
             <a:r>
-              <a:rPr b="0" lang="en-US" sz="2230" spc="-1" strike="noStrike">
-                <a:solidFill>
-                  <a:srgbClr val="000000"/>
-                </a:solidFill>
-                <a:latin typeface="Arial"/>
-                <a:ea typeface="DejaVu Sans"/>
-              </a:rPr>
-              <a:t>The default inittab file tells init to run the commands in the file</a:t>
-            </a:r>
-            <a:endParaRPr b="0" lang="en-US" sz="2230" spc="-1" strike="noStrike">
+              <a:rPr b="0" lang="en-US" sz="1800" spc="-1" strike="noStrike">
+                <a:solidFill>
+                  <a:srgbClr val="000000"/>
+                </a:solidFill>
+                <a:latin typeface="Arial"/>
+                <a:ea typeface="DejaVu Sans"/>
+              </a:rPr>
+              <a:t>▶ </a:t>
+            </a:r>
+            <a:r>
+              <a:rPr b="0" lang="en-US" sz="1800" spc="-1" strike="noStrike">
+                <a:solidFill>
+                  <a:srgbClr val="000000"/>
+                </a:solidFill>
+                <a:latin typeface="Arial"/>
+                <a:ea typeface="DejaVu Sans"/>
+              </a:rPr>
+              <a:t>Supports x86 legacy and UEFI systems</a:t>
+            </a:r>
+            <a:endParaRPr b="0" lang="en-US" sz="1800" spc="-1" strike="noStrike">
               <a:solidFill>
                 <a:srgbClr val="000000"/>
               </a:solidFill>
@@ -22996,165 +22620,181 @@
               </a:lnSpc>
             </a:pPr>
             <a:r>
-              <a:rPr b="0" lang="en-US" sz="2230" spc="-1" strike="noStrike">
-                <a:solidFill>
-                  <a:srgbClr val="000000"/>
-                </a:solidFill>
-                <a:latin typeface="Arial"/>
-                <a:ea typeface="DejaVu Sans"/>
-              </a:rPr>
-              <a:t>/etc/rc.d/rcS. In addition, init spawns programs to present login</a:t>
-            </a:r>
-            <a:endParaRPr b="0" lang="en-US" sz="2230" spc="-1" strike="noStrike">
-              <a:solidFill>
-                <a:srgbClr val="000000"/>
-              </a:solidFill>
-              <a:latin typeface="Arial"/>
-            </a:endParaRPr>
-          </a:p>
-          <a:p>
-            <a:pPr>
-              <a:lnSpc>
-                <a:spcPts val="1023"/>
-              </a:lnSpc>
-            </a:pPr>
-            <a:endParaRPr b="0" lang="en-US" sz="2230" spc="-1" strike="noStrike">
-              <a:solidFill>
-                <a:srgbClr val="000000"/>
-              </a:solidFill>
-              <a:latin typeface="Arial"/>
-            </a:endParaRPr>
-          </a:p>
-          <a:p>
-            <a:pPr>
-              <a:lnSpc>
-                <a:spcPts val="1023"/>
-              </a:lnSpc>
-            </a:pPr>
-            <a:endParaRPr b="0" lang="en-US" sz="2230" spc="-1" strike="noStrike">
-              <a:solidFill>
-                <a:srgbClr val="000000"/>
-              </a:solidFill>
-              <a:latin typeface="Arial"/>
-            </a:endParaRPr>
-          </a:p>
-          <a:p>
-            <a:pPr>
-              <a:lnSpc>
-                <a:spcPts val="1023"/>
-              </a:lnSpc>
-            </a:pPr>
-            <a:r>
-              <a:rPr b="0" lang="en-US" sz="2230" spc="-1" strike="noStrike">
-                <a:solidFill>
-                  <a:srgbClr val="000000"/>
-                </a:solidFill>
-                <a:latin typeface="Arial"/>
-                <a:ea typeface="DejaVu Sans"/>
-              </a:rPr>
-              <a:t>prompts on two virtual terminals.</a:t>
-            </a:r>
-            <a:endParaRPr b="0" lang="en-US" sz="2230" spc="-1" strike="noStrike">
-              <a:solidFill>
-                <a:srgbClr val="000000"/>
-              </a:solidFill>
-              <a:latin typeface="Arial"/>
-            </a:endParaRPr>
-          </a:p>
-          <a:p>
-            <a:pPr>
-              <a:lnSpc>
-                <a:spcPts val="1023"/>
-              </a:lnSpc>
-            </a:pPr>
-            <a:endParaRPr b="0" lang="en-US" sz="2230" spc="-1" strike="noStrike">
-              <a:solidFill>
-                <a:srgbClr val="000000"/>
-              </a:solidFill>
-              <a:latin typeface="Arial"/>
-            </a:endParaRPr>
-          </a:p>
-          <a:p>
-            <a:pPr>
-              <a:lnSpc>
-                <a:spcPts val="1023"/>
-              </a:lnSpc>
-            </a:pPr>
-            <a:endParaRPr b="0" lang="en-US" sz="2230" spc="-1" strike="noStrike">
-              <a:solidFill>
-                <a:srgbClr val="000000"/>
-              </a:solidFill>
-              <a:latin typeface="Arial"/>
-            </a:endParaRPr>
-          </a:p>
-          <a:p>
-            <a:pPr>
-              <a:lnSpc>
-                <a:spcPts val="1023"/>
-              </a:lnSpc>
-            </a:pPr>
-            <a:endParaRPr b="0" lang="en-US" sz="2230" spc="-1" strike="noStrike">
-              <a:solidFill>
-                <a:srgbClr val="000000"/>
-              </a:solidFill>
-              <a:latin typeface="Arial"/>
-            </a:endParaRPr>
-          </a:p>
-          <a:p>
-            <a:pPr>
-              <a:lnSpc>
-                <a:spcPts val="1023"/>
-              </a:lnSpc>
-              <a:spcBef>
-                <a:spcPts val="1191"/>
-              </a:spcBef>
-              <a:spcAft>
-                <a:spcPts val="992"/>
-              </a:spcAft>
-            </a:pPr>
-            <a:r>
-              <a:rPr b="0" lang="en-IN" sz="2230" spc="-1" strike="noStrike">
-                <a:solidFill>
-                  <a:srgbClr val="000000"/>
-                </a:solidFill>
-                <a:latin typeface="Arial"/>
-                <a:ea typeface="DejaVu Sans"/>
-              </a:rPr>
-              <a:t>In Ubuntu: systemd is in use, but /etc/rc0.d still exists for</a:t>
-            </a:r>
-            <a:endParaRPr b="0" lang="en-US" sz="2230" spc="-1" strike="noStrike">
-              <a:solidFill>
-                <a:srgbClr val="000000"/>
-              </a:solidFill>
-              <a:latin typeface="Arial"/>
-            </a:endParaRPr>
-          </a:p>
-          <a:p>
-            <a:pPr>
-              <a:lnSpc>
-                <a:spcPts val="1023"/>
-              </a:lnSpc>
-              <a:spcBef>
-                <a:spcPts val="1191"/>
-              </a:spcBef>
-              <a:spcAft>
-                <a:spcPts val="992"/>
-              </a:spcAft>
-            </a:pPr>
-            <a:br>
-              <a:rPr sz="2230"/>
-            </a:br>
-            <a:r>
-              <a:rPr b="0" lang="en-IN" sz="2230" spc="-1" strike="noStrike">
-                <a:solidFill>
-                  <a:srgbClr val="000000"/>
-                </a:solidFill>
-                <a:latin typeface="Arial"/>
-                <a:ea typeface="DejaVu Sans"/>
-              </a:rPr>
-              <a:t>compatibility reasons.</a:t>
-            </a:r>
-            <a:endParaRPr b="0" lang="en-US" sz="2230" spc="-1" strike="noStrike">
+              <a:rPr b="0" lang="en-US" sz="1800" spc="-1" strike="noStrike">
+                <a:solidFill>
+                  <a:srgbClr val="000000"/>
+                </a:solidFill>
+                <a:latin typeface="Arial"/>
+                <a:ea typeface="DejaVu Sans"/>
+              </a:rPr>
+              <a:t>▶ </a:t>
+            </a:r>
+            <a:r>
+              <a:rPr b="0" lang="en-US" sz="1800" spc="-1" strike="noStrike">
+                <a:solidFill>
+                  <a:srgbClr val="000000"/>
+                </a:solidFill>
+                <a:latin typeface="Arial"/>
+                <a:ea typeface="DejaVu Sans"/>
+              </a:rPr>
+              <a:t>Can read many filesystem formats to load the kernel image, modules and configuration</a:t>
+            </a:r>
+            <a:endParaRPr b="0" lang="en-US" sz="1800" spc="-1" strike="noStrike">
+              <a:solidFill>
+                <a:srgbClr val="000000"/>
+              </a:solidFill>
+              <a:latin typeface="Arial"/>
+            </a:endParaRPr>
+          </a:p>
+          <a:p>
+            <a:pPr>
+              <a:lnSpc>
+                <a:spcPct val="100000"/>
+              </a:lnSpc>
+            </a:pPr>
+            <a:r>
+              <a:rPr b="0" lang="en-US" sz="1800" spc="-1" strike="noStrike">
+                <a:solidFill>
+                  <a:srgbClr val="000000"/>
+                </a:solidFill>
+                <a:latin typeface="Arial"/>
+                <a:ea typeface="DejaVu Sans"/>
+              </a:rPr>
+              <a:t>▶ </a:t>
+            </a:r>
+            <a:r>
+              <a:rPr b="0" lang="en-US" sz="1800" spc="-1" strike="noStrike">
+                <a:solidFill>
+                  <a:srgbClr val="000000"/>
+                </a:solidFill>
+                <a:latin typeface="Arial"/>
+                <a:ea typeface="DejaVu Sans"/>
+              </a:rPr>
+              <a:t>Provides a menu and powerful shell with various commands</a:t>
+            </a:r>
+            <a:endParaRPr b="0" lang="en-US" sz="1800" spc="-1" strike="noStrike">
+              <a:solidFill>
+                <a:srgbClr val="000000"/>
+              </a:solidFill>
+              <a:latin typeface="Arial"/>
+            </a:endParaRPr>
+          </a:p>
+          <a:p>
+            <a:pPr>
+              <a:lnSpc>
+                <a:spcPct val="100000"/>
+              </a:lnSpc>
+            </a:pPr>
+            <a:r>
+              <a:rPr b="0" lang="en-US" sz="1800" spc="-1" strike="noStrike">
+                <a:solidFill>
+                  <a:srgbClr val="000000"/>
+                </a:solidFill>
+                <a:latin typeface="Arial"/>
+                <a:ea typeface="DejaVu Sans"/>
+              </a:rPr>
+              <a:t>▶ </a:t>
+            </a:r>
+            <a:r>
+              <a:rPr b="0" lang="en-US" sz="1800" spc="-1" strike="noStrike">
+                <a:solidFill>
+                  <a:srgbClr val="000000"/>
+                </a:solidFill>
+                <a:latin typeface="Arial"/>
+                <a:ea typeface="DejaVu Sans"/>
+              </a:rPr>
+              <a:t>Can load kernel images over the network</a:t>
+            </a:r>
+            <a:endParaRPr b="0" lang="en-US" sz="1800" spc="-1" strike="noStrike">
+              <a:solidFill>
+                <a:srgbClr val="000000"/>
+              </a:solidFill>
+              <a:latin typeface="Arial"/>
+            </a:endParaRPr>
+          </a:p>
+          <a:p>
+            <a:pPr>
+              <a:lnSpc>
+                <a:spcPct val="100000"/>
+              </a:lnSpc>
+            </a:pPr>
+            <a:r>
+              <a:rPr b="0" lang="en-US" sz="1800" spc="-1" strike="noStrike">
+                <a:solidFill>
+                  <a:srgbClr val="000000"/>
+                </a:solidFill>
+                <a:latin typeface="Arial"/>
+                <a:ea typeface="DejaVu Sans"/>
+              </a:rPr>
+              <a:t>▶ </a:t>
+            </a:r>
+            <a:r>
+              <a:rPr b="0" lang="en-US" sz="1800" spc="-1" strike="noStrike">
+                <a:solidFill>
+                  <a:srgbClr val="000000"/>
+                </a:solidFill>
+                <a:latin typeface="Arial"/>
+                <a:ea typeface="DejaVu Sans"/>
+              </a:rPr>
+              <a:t>Also supports ARM, ARM64, RISC-V, PowerPC, but less popular than other</a:t>
+            </a:r>
+            <a:endParaRPr b="0" lang="en-US" sz="1800" spc="-1" strike="noStrike">
+              <a:solidFill>
+                <a:srgbClr val="000000"/>
+              </a:solidFill>
+              <a:latin typeface="Arial"/>
+            </a:endParaRPr>
+          </a:p>
+          <a:p>
+            <a:pPr>
+              <a:lnSpc>
+                <a:spcPct val="100000"/>
+              </a:lnSpc>
+            </a:pPr>
+            <a:r>
+              <a:rPr b="0" lang="en-US" sz="1800" spc="-1" strike="noStrike">
+                <a:solidFill>
+                  <a:srgbClr val="000000"/>
+                </a:solidFill>
+                <a:latin typeface="Arial"/>
+                <a:ea typeface="DejaVu Sans"/>
+              </a:rPr>
+              <a:t>bootloaders on those platforms</a:t>
+            </a:r>
+            <a:endParaRPr b="0" lang="en-US" sz="1800" spc="-1" strike="noStrike">
+              <a:solidFill>
+                <a:srgbClr val="000000"/>
+              </a:solidFill>
+              <a:latin typeface="Arial"/>
+            </a:endParaRPr>
+          </a:p>
+          <a:p>
+            <a:pPr>
+              <a:lnSpc>
+                <a:spcPct val="100000"/>
+              </a:lnSpc>
+            </a:pPr>
+            <a:r>
+              <a:rPr b="0" lang="en-US" sz="1800" spc="-1" strike="noStrike">
+                <a:solidFill>
+                  <a:srgbClr val="000000"/>
+                </a:solidFill>
+                <a:latin typeface="Arial"/>
+                <a:ea typeface="DejaVu Sans"/>
+              </a:rPr>
+              <a:t>▶ </a:t>
+            </a:r>
+            <a:r>
+              <a:rPr b="0" lang="en-US" sz="1800" spc="-1" strike="noStrike">
+                <a:solidFill>
+                  <a:srgbClr val="000000"/>
+                </a:solidFill>
+                <a:latin typeface="Arial"/>
+                <a:ea typeface="DejaVu Sans"/>
+              </a:rPr>
+              <a:t>https://www.gnu.org/software/grub/</a:t>
+            </a:r>
+            <a:endParaRPr b="0" lang="en-US" sz="1800" spc="-1" strike="noStrike">
               <a:solidFill>
                 <a:srgbClr val="000000"/>
               </a:solidFill>
@@ -23165,7 +22805,7 @@
       </p:sp>
       <p:pic>
         <p:nvPicPr>
-          <p:cNvPr id="223" name="" descr=""/>
+          <p:cNvPr id="220" name="" descr=""/>
           <p:cNvPicPr/>
           <p:nvPr/>
         </p:nvPicPr>
@@ -23175,8 +22815,8 @@
         </p:blipFill>
         <p:spPr>
           <a:xfrm>
-            <a:off x="228600" y="4148640"/>
-            <a:ext cx="8913960" cy="1996920"/>
+            <a:off x="2968200" y="3537000"/>
+            <a:ext cx="6170400" cy="3256200"/>
           </a:xfrm>
           <a:prstGeom prst="rect">
             <a:avLst/>
@@ -23216,16 +22856,39 @@
           <a:chExt cx="0" cy="0"/>
         </a:xfrm>
       </p:grpSpPr>
+      <p:pic>
+        <p:nvPicPr>
+          <p:cNvPr id="221" name="Picture 1" descr=""/>
+          <p:cNvPicPr/>
+          <p:nvPr/>
+        </p:nvPicPr>
+        <p:blipFill>
+          <a:blip r:embed="rId1"/>
+          <a:stretch/>
+        </p:blipFill>
+        <p:spPr>
+          <a:xfrm>
+            <a:off x="0" y="0"/>
+            <a:ext cx="9135720" cy="6837120"/>
+          </a:xfrm>
+          <a:prstGeom prst="rect">
+            <a:avLst/>
+          </a:prstGeom>
+          <a:ln w="0">
+            <a:noFill/>
+          </a:ln>
+        </p:spPr>
+      </p:pic>
       <p:sp>
         <p:nvSpPr>
-          <p:cNvPr id="224" name=""/>
+          <p:cNvPr id="222" name="CustomShape 1"/>
           <p:cNvSpPr/>
           <p:nvPr/>
         </p:nvSpPr>
         <p:spPr>
           <a:xfrm>
-            <a:off x="505080" y="457200"/>
-            <a:ext cx="5437080" cy="600840"/>
+            <a:off x="3277800" y="431640"/>
+            <a:ext cx="2961000" cy="708120"/>
           </a:xfrm>
           <a:prstGeom prst="rect">
             <a:avLst/>
@@ -23242,26 +22905,26 @@
           <a:fontRef idx="minor"/>
         </p:style>
         <p:txBody>
-          <a:bodyPr lIns="90000" rIns="90000" tIns="45000" bIns="45000" anchor="t">
+          <a:bodyPr wrap="none" lIns="0" rIns="0" tIns="0" bIns="0" anchor="t">
             <a:noAutofit/>
           </a:bodyPr>
           <a:p>
             <a:pPr>
               <a:lnSpc>
-                <a:spcPct val="100000"/>
-              </a:lnSpc>
-            </a:pPr>
-            <a:r>
-              <a:rPr b="1" lang="en-US" sz="1800" spc="-1" strike="noStrike">
-                <a:solidFill>
-                  <a:srgbClr val="000000"/>
-                </a:solidFill>
-                <a:latin typeface="Arial"/>
-                <a:ea typeface="Noto Sans CJK SC"/>
-              </a:rPr>
-              <a:t>Systemd-boot : Simple UEFI boot manager</a:t>
-            </a:r>
-            <a:endParaRPr b="0" lang="en-US" sz="1800" spc="-1" strike="noStrike">
+                <a:spcPts val="975"/>
+              </a:lnSpc>
+            </a:pPr>
+            <a:r>
+              <a:rPr b="1" lang="en-US" sz="2240" spc="-1" strike="noStrike">
+                <a:solidFill>
+                  <a:srgbClr val="000000"/>
+                </a:solidFill>
+                <a:latin typeface="Arial Bold"/>
+                <a:ea typeface="DejaVu Sans"/>
+              </a:rPr>
+              <a:t>Initialization Overview</a:t>
+            </a:r>
+            <a:endParaRPr b="0" lang="en-US" sz="2240" spc="-1" strike="noStrike">
               <a:solidFill>
                 <a:srgbClr val="000000"/>
               </a:solidFill>
@@ -23272,14 +22935,14 @@
       </p:sp>
       <p:sp>
         <p:nvSpPr>
-          <p:cNvPr id="225" name=""/>
+          <p:cNvPr id="223" name="CustomShape 2"/>
           <p:cNvSpPr/>
           <p:nvPr/>
         </p:nvSpPr>
         <p:spPr>
           <a:xfrm>
-            <a:off x="411480" y="1057320"/>
-            <a:ext cx="8502480" cy="5173560"/>
+            <a:off x="253080" y="651600"/>
+            <a:ext cx="8506440" cy="1442880"/>
           </a:xfrm>
           <a:prstGeom prst="rect">
             <a:avLst/>
@@ -23296,7 +22959,7 @@
           <a:fontRef idx="minor"/>
         </p:style>
         <p:txBody>
-          <a:bodyPr lIns="90000" rIns="90000" tIns="45000" bIns="45000" anchor="t">
+          <a:bodyPr wrap="none" lIns="0" rIns="0" tIns="0" bIns="0" anchor="t">
             <a:noAutofit/>
           </a:bodyPr>
           <a:p>
@@ -23305,7 +22968,17 @@
                 <a:spcPct val="100000"/>
               </a:lnSpc>
             </a:pPr>
-            <a:endParaRPr b="0" lang="en-US" sz="1800" spc="-1" strike="noStrike">
+            <a:r>
+              <a:rPr b="0" lang="en-US" sz="2230" spc="-1" strike="noStrike">
+                <a:solidFill>
+                  <a:srgbClr val="000000"/>
+                </a:solidFill>
+                <a:latin typeface="Arial"/>
+                <a:ea typeface="DejaVu Sans"/>
+              </a:rPr>
+              <a:t>When the operating system starts, the kernel runs /sbin/init. This can</a:t>
+            </a:r>
+            <a:endParaRPr b="0" lang="en-US" sz="2230" spc="-1" strike="noStrike">
               <a:solidFill>
                 <a:srgbClr val="000000"/>
               </a:solidFill>
@@ -23319,39 +22992,106 @@
               </a:lnSpc>
             </a:pPr>
             <a:r>
-              <a:rPr b="0" lang="en-US" sz="1800" spc="-1" strike="noStrike">
-                <a:solidFill>
-                  <a:srgbClr val="000000"/>
-                </a:solidFill>
-                <a:latin typeface="Arial"/>
-                <a:ea typeface="DejaVu Sans"/>
-              </a:rPr>
-              <a:t>▶ </a:t>
-            </a:r>
-            <a:r>
-              <a:rPr b="0" lang="en-US" sz="1800" spc="-1" strike="noStrike">
-                <a:solidFill>
-                  <a:srgbClr val="000000"/>
-                </a:solidFill>
-                <a:latin typeface="Arial"/>
-                <a:ea typeface="DejaVu Sans"/>
-              </a:rPr>
-              <a:t>Useful alternative to GRUB for UEFI systems: simpler than GRUB</a:t>
-            </a:r>
-            <a:endParaRPr b="0" lang="en-US" sz="1800" spc="-1" strike="noStrike">
-              <a:solidFill>
-                <a:srgbClr val="000000"/>
-              </a:solidFill>
-              <a:latin typeface="Arial"/>
-            </a:endParaRPr>
-          </a:p>
+              <a:rPr b="0" lang="en-US" sz="2230" spc="-1" strike="noStrike">
+                <a:solidFill>
+                  <a:srgbClr val="000000"/>
+                </a:solidFill>
+                <a:latin typeface="Arial"/>
+                <a:ea typeface="DejaVu Sans"/>
+              </a:rPr>
+              <a:t>be either a script or a program, but typically it is a program that</a:t>
+            </a:r>
+            <a:endParaRPr b="0" lang="en-US" sz="2230" spc="-1" strike="noStrike">
+              <a:solidFill>
+                <a:srgbClr val="000000"/>
+              </a:solidFill>
+              <a:latin typeface="Arial"/>
+            </a:endParaRPr>
+          </a:p>
+          <a:p>
+            <a:pPr>
+              <a:lnSpc>
+                <a:spcPts val="1006"/>
+              </a:lnSpc>
+            </a:pPr>
+            <a:endParaRPr b="0" lang="en-US" sz="2230" spc="-1" strike="noStrike">
+              <a:solidFill>
+                <a:srgbClr val="000000"/>
+              </a:solidFill>
+              <a:latin typeface="Arial"/>
+            </a:endParaRPr>
+          </a:p>
+          <a:p>
+            <a:pPr>
+              <a:lnSpc>
+                <a:spcPts val="1006"/>
+              </a:lnSpc>
+            </a:pPr>
+            <a:r>
+              <a:rPr b="0" lang="en-US" sz="2230" spc="-1" strike="noStrike">
+                <a:solidFill>
+                  <a:srgbClr val="000000"/>
+                </a:solidFill>
+                <a:latin typeface="Arial"/>
+                <a:ea typeface="DejaVu Sans"/>
+              </a:rPr>
+              <a:t>processes the statements in /etc/initab.</a:t>
+            </a:r>
+            <a:endParaRPr b="0" lang="en-US" sz="2230" spc="-1" strike="noStrike">
+              <a:solidFill>
+                <a:srgbClr val="000000"/>
+              </a:solidFill>
+              <a:latin typeface="Arial"/>
+            </a:endParaRPr>
+          </a:p>
+        </p:txBody>
+      </p:sp>
+      <p:sp>
+        <p:nvSpPr>
+          <p:cNvPr id="224" name="CustomShape 3"/>
+          <p:cNvSpPr/>
+          <p:nvPr/>
+        </p:nvSpPr>
+        <p:spPr>
+          <a:xfrm>
+            <a:off x="274320" y="1698480"/>
+            <a:ext cx="8604000" cy="1464840"/>
+          </a:xfrm>
+          <a:prstGeom prst="rect">
+            <a:avLst/>
+          </a:prstGeom>
+          <a:noFill/>
+          <a:ln w="0">
+            <a:noFill/>
+          </a:ln>
+        </p:spPr>
+        <p:style>
+          <a:lnRef idx="0"/>
+          <a:fillRef idx="0"/>
+          <a:effectRef idx="0"/>
+          <a:fontRef idx="minor"/>
+        </p:style>
+        <p:txBody>
+          <a:bodyPr wrap="none" lIns="0" rIns="0" tIns="0" bIns="0" anchor="t">
+            <a:noAutofit/>
+          </a:bodyPr>
           <a:p>
             <a:pPr>
               <a:lnSpc>
                 <a:spcPct val="100000"/>
               </a:lnSpc>
             </a:pPr>
-            <a:endParaRPr b="0" lang="en-US" sz="1800" spc="-1" strike="noStrike">
+            <a:r>
+              <a:rPr b="0" lang="en-US" sz="2230" spc="-1" strike="noStrike">
+                <a:solidFill>
+                  <a:srgbClr val="000000"/>
+                </a:solidFill>
+                <a:latin typeface="Arial"/>
+                <a:ea typeface="DejaVu Sans"/>
+              </a:rPr>
+              <a:t>The default inittab file tells init to run the commands in the file</a:t>
+            </a:r>
+            <a:endParaRPr b="0" lang="en-US" sz="2230" spc="-1" strike="noStrike">
               <a:solidFill>
                 <a:srgbClr val="000000"/>
               </a:solidFill>
@@ -23365,111 +23105,114 @@
               </a:lnSpc>
             </a:pPr>
             <a:r>
-              <a:rPr b="0" lang="en-US" sz="1800" spc="-1" strike="noStrike">
-                <a:solidFill>
-                  <a:srgbClr val="000000"/>
-                </a:solidFill>
-                <a:latin typeface="Arial"/>
-                <a:ea typeface="DejaVu Sans"/>
-              </a:rPr>
-              <a:t>▶ </a:t>
-            </a:r>
-            <a:r>
-              <a:rPr b="0" lang="en-US" sz="1800" spc="-1" strike="noStrike">
-                <a:solidFill>
-                  <a:srgbClr val="000000"/>
-                </a:solidFill>
-                <a:latin typeface="Arial"/>
-                <a:ea typeface="DejaVu Sans"/>
-              </a:rPr>
-              <a:t>Configured using files stored in the EFI System Partition</a:t>
-            </a:r>
-            <a:br>
-              <a:rPr sz="1800"/>
-            </a:br>
-            <a:br>
-              <a:rPr sz="1800"/>
-            </a:br>
-            <a:r>
-              <a:rPr b="0" lang="en-US" sz="1800" spc="-1" strike="noStrike">
-                <a:solidFill>
-                  <a:srgbClr val="000000"/>
-                </a:solidFill>
-                <a:latin typeface="Arial"/>
-                <a:ea typeface="DejaVu Sans"/>
-              </a:rPr>
-              <a:t>▶ Part of the systemd project, even though obviously distinct from systemd itself</a:t>
-            </a:r>
-            <a:endParaRPr b="0" lang="en-US" sz="1800" spc="-1" strike="noStrike">
-              <a:solidFill>
-                <a:srgbClr val="000000"/>
-              </a:solidFill>
-              <a:latin typeface="Arial"/>
-            </a:endParaRPr>
-          </a:p>
-          <a:p>
-            <a:pPr>
-              <a:lnSpc>
-                <a:spcPct val="100000"/>
-              </a:lnSpc>
-            </a:pPr>
-            <a:endParaRPr b="0" lang="en-US" sz="1800" spc="-1" strike="noStrike">
-              <a:solidFill>
-                <a:srgbClr val="000000"/>
-              </a:solidFill>
-              <a:latin typeface="Arial"/>
-            </a:endParaRPr>
-          </a:p>
-          <a:p>
-            <a:pPr>
-              <a:lnSpc>
-                <a:spcPct val="100000"/>
-              </a:lnSpc>
-            </a:pPr>
-            <a:r>
-              <a:rPr b="0" lang="en-US" sz="1800" spc="-1" strike="noStrike">
-                <a:solidFill>
-                  <a:srgbClr val="000000"/>
-                </a:solidFill>
-                <a:latin typeface="Arial"/>
-                <a:ea typeface="DejaVu Sans"/>
-              </a:rPr>
-              <a:t>▶ </a:t>
-            </a:r>
-            <a:r>
-              <a:rPr b="0" lang="en-US" sz="1800" spc="-1" strike="noStrike">
-                <a:solidFill>
-                  <a:srgbClr val="000000"/>
-                </a:solidFill>
-                <a:latin typeface="Arial"/>
-                <a:ea typeface="DejaVu Sans"/>
-              </a:rPr>
-              <a:t>systemd-boot is a UEFI boot manager which executes configured EFI images.</a:t>
-            </a:r>
-            <a:endParaRPr b="0" lang="en-US" sz="1800" spc="-1" strike="noStrike">
-              <a:solidFill>
-                <a:srgbClr val="000000"/>
-              </a:solidFill>
-              <a:latin typeface="Arial"/>
-            </a:endParaRPr>
-          </a:p>
-          <a:p>
-            <a:pPr>
-              <a:lnSpc>
-                <a:spcPct val="100000"/>
-              </a:lnSpc>
-            </a:pPr>
-            <a:endParaRPr b="0" lang="en-US" sz="1800" spc="-1" strike="noStrike">
-              <a:solidFill>
-                <a:srgbClr val="000000"/>
-              </a:solidFill>
-              <a:latin typeface="Arial"/>
-            </a:endParaRPr>
-          </a:p>
-          <a:p>
-            <a:pPr>
-              <a:lnSpc>
-                <a:spcPct val="100000"/>
+              <a:rPr b="0" lang="en-US" sz="2230" spc="-1" strike="noStrike">
+                <a:solidFill>
+                  <a:srgbClr val="000000"/>
+                </a:solidFill>
+                <a:latin typeface="Arial"/>
+                <a:ea typeface="DejaVu Sans"/>
+              </a:rPr>
+              <a:t>/etc/rc.d/rcS. In addition, init spawns programs to present login</a:t>
+            </a:r>
+            <a:endParaRPr b="0" lang="en-US" sz="2230" spc="-1" strike="noStrike">
+              <a:solidFill>
+                <a:srgbClr val="000000"/>
+              </a:solidFill>
+              <a:latin typeface="Arial"/>
+            </a:endParaRPr>
+          </a:p>
+          <a:p>
+            <a:pPr>
+              <a:lnSpc>
+                <a:spcPts val="1023"/>
+              </a:lnSpc>
+            </a:pPr>
+            <a:endParaRPr b="0" lang="en-US" sz="2230" spc="-1" strike="noStrike">
+              <a:solidFill>
+                <a:srgbClr val="000000"/>
+              </a:solidFill>
+              <a:latin typeface="Arial"/>
+            </a:endParaRPr>
+          </a:p>
+          <a:p>
+            <a:pPr>
+              <a:lnSpc>
+                <a:spcPts val="1023"/>
+              </a:lnSpc>
+            </a:pPr>
+            <a:endParaRPr b="0" lang="en-US" sz="2230" spc="-1" strike="noStrike">
+              <a:solidFill>
+                <a:srgbClr val="000000"/>
+              </a:solidFill>
+              <a:latin typeface="Arial"/>
+            </a:endParaRPr>
+          </a:p>
+          <a:p>
+            <a:pPr>
+              <a:lnSpc>
+                <a:spcPts val="1023"/>
+              </a:lnSpc>
+            </a:pPr>
+            <a:r>
+              <a:rPr b="0" lang="en-US" sz="2230" spc="-1" strike="noStrike">
+                <a:solidFill>
+                  <a:srgbClr val="000000"/>
+                </a:solidFill>
+                <a:latin typeface="Arial"/>
+                <a:ea typeface="DejaVu Sans"/>
+              </a:rPr>
+              <a:t>prompts on two virtual terminals.</a:t>
+            </a:r>
+            <a:endParaRPr b="0" lang="en-US" sz="2230" spc="-1" strike="noStrike">
+              <a:solidFill>
+                <a:srgbClr val="000000"/>
+              </a:solidFill>
+              <a:latin typeface="Arial"/>
+            </a:endParaRPr>
+          </a:p>
+          <a:p>
+            <a:pPr>
+              <a:lnSpc>
+                <a:spcPts val="1023"/>
+              </a:lnSpc>
+            </a:pPr>
+            <a:endParaRPr b="0" lang="en-US" sz="2230" spc="-1" strike="noStrike">
+              <a:solidFill>
+                <a:srgbClr val="000000"/>
+              </a:solidFill>
+              <a:latin typeface="Arial"/>
+            </a:endParaRPr>
+          </a:p>
+          <a:p>
+            <a:pPr>
+              <a:lnSpc>
+                <a:spcPts val="1023"/>
+              </a:lnSpc>
+            </a:pPr>
+            <a:endParaRPr b="0" lang="en-US" sz="2230" spc="-1" strike="noStrike">
+              <a:solidFill>
+                <a:srgbClr val="000000"/>
+              </a:solidFill>
+              <a:latin typeface="Arial"/>
+            </a:endParaRPr>
+          </a:p>
+          <a:p>
+            <a:pPr>
+              <a:lnSpc>
+                <a:spcPts val="1023"/>
+              </a:lnSpc>
+            </a:pPr>
+            <a:endParaRPr b="0" lang="en-US" sz="2230" spc="-1" strike="noStrike">
+              <a:solidFill>
+                <a:srgbClr val="000000"/>
+              </a:solidFill>
+              <a:latin typeface="Arial"/>
+            </a:endParaRPr>
+          </a:p>
+          <a:p>
+            <a:pPr>
+              <a:lnSpc>
+                <a:spcPts val="1023"/>
               </a:lnSpc>
               <a:spcBef>
                 <a:spcPts val="1191"/>
@@ -23479,59 +23222,26 @@
               </a:spcAft>
             </a:pPr>
             <a:r>
-              <a:rPr b="0" lang="en-US" sz="1800" spc="-1" strike="noStrike">
-                <a:solidFill>
-                  <a:srgbClr val="000000"/>
-                </a:solidFill>
-                <a:latin typeface="Arial"/>
-                <a:ea typeface="DejaVu Sans"/>
-              </a:rPr>
-              <a:t>▶ </a:t>
-            </a:r>
-            <a:r>
-              <a:rPr b="0" lang="en-US" sz="1800" spc="-1" strike="noStrike">
-                <a:solidFill>
-                  <a:srgbClr val="000000"/>
-                </a:solidFill>
-                <a:latin typeface="Arial"/>
-                <a:ea typeface="DejaVu Sans"/>
-              </a:rPr>
-              <a:t>systemd-boot operates on the EFI System Partition (ESP) only. Configuration file fragments, kernels, initrds, other EFI images need to reside on the ESP. Linux kernels need to be built with CONFIG_EFI_STUB to be able to be directly executed as an EFI image.  </a:t>
-            </a:r>
-            <a:endParaRPr b="0" lang="en-US" sz="1800" spc="-1" strike="noStrike">
-              <a:solidFill>
-                <a:srgbClr val="000000"/>
-              </a:solidFill>
-              <a:latin typeface="Arial"/>
-            </a:endParaRPr>
-          </a:p>
-          <a:p>
-            <a:pPr>
-              <a:lnSpc>
-                <a:spcPct val="100000"/>
-              </a:lnSpc>
-            </a:pPr>
-            <a:r>
-              <a:rPr b="1" lang="en-US" sz="1800" spc="-1" strike="noStrike">
-                <a:solidFill>
-                  <a:srgbClr val="000000"/>
-                </a:solidFill>
-                <a:latin typeface="Arial"/>
-                <a:ea typeface="DejaVu Sans"/>
-              </a:rPr>
-              <a:t>https://www.freedesktop.org/wiki/Software/systemd/systemd-boot/</a:t>
-            </a:r>
-            <a:endParaRPr b="0" lang="en-US" sz="1800" spc="-1" strike="noStrike">
-              <a:solidFill>
-                <a:srgbClr val="000000"/>
-              </a:solidFill>
-              <a:latin typeface="Arial"/>
-            </a:endParaRPr>
-          </a:p>
-          <a:p>
-            <a:pPr>
-              <a:lnSpc>
-                <a:spcPct val="100000"/>
+              <a:rPr b="0" lang="en-IN" sz="2230" spc="-1" strike="noStrike">
+                <a:solidFill>
+                  <a:srgbClr val="000000"/>
+                </a:solidFill>
+                <a:latin typeface="Arial"/>
+                <a:ea typeface="DejaVu Sans"/>
+              </a:rPr>
+              <a:t>In Ubuntu: systemd is in use, but /etc/rc0.d still exists for</a:t>
+            </a:r>
+            <a:endParaRPr b="0" lang="en-US" sz="2230" spc="-1" strike="noStrike">
+              <a:solidFill>
+                <a:srgbClr val="000000"/>
+              </a:solidFill>
+              <a:latin typeface="Arial"/>
+            </a:endParaRPr>
+          </a:p>
+          <a:p>
+            <a:pPr>
+              <a:lnSpc>
+                <a:spcPts val="1023"/>
               </a:lnSpc>
               <a:spcBef>
                 <a:spcPts val="1191"/>
@@ -23541,9 +23251,19 @@
               </a:spcAft>
             </a:pPr>
             <a:br>
-              <a:rPr sz="1000"/>
+              <a:rPr sz="2230"/>
             </a:br>
-            <a:endParaRPr b="0" lang="en-US" sz="1000" spc="-1" strike="noStrike">
+            <a:r>
+              <a:rPr b="0" lang="en-IN" sz="2230" spc="-1" strike="noStrike">
+                <a:solidFill>
+                  <a:srgbClr val="000000"/>
+                </a:solidFill>
+                <a:latin typeface="Arial"/>
+                <a:ea typeface="DejaVu Sans"/>
+              </a:rPr>
+              <a:t>compatibility reasons.</a:t>
+            </a:r>
+            <a:endParaRPr b="0" lang="en-US" sz="2230" spc="-1" strike="noStrike">
               <a:solidFill>
                 <a:srgbClr val="000000"/>
               </a:solidFill>
@@ -23552,6 +23272,29 @@
           </a:p>
         </p:txBody>
       </p:sp>
+      <p:pic>
+        <p:nvPicPr>
+          <p:cNvPr id="225" name="" descr=""/>
+          <p:cNvPicPr/>
+          <p:nvPr/>
+        </p:nvPicPr>
+        <p:blipFill>
+          <a:blip r:embed="rId2"/>
+          <a:stretch/>
+        </p:blipFill>
+        <p:spPr>
+          <a:xfrm>
+            <a:off x="228600" y="4148640"/>
+            <a:ext cx="8913600" cy="1996560"/>
+          </a:xfrm>
+          <a:prstGeom prst="rect">
+            <a:avLst/>
+          </a:prstGeom>
+          <a:ln w="0">
+            <a:noFill/>
+          </a:ln>
+        </p:spPr>
+      </p:pic>
     </p:spTree>
   </p:cSld>
   <mc:AlternateContent>
@@ -23582,39 +23325,16 @@
           <a:chExt cx="0" cy="0"/>
         </a:xfrm>
       </p:grpSpPr>
-      <p:pic>
-        <p:nvPicPr>
-          <p:cNvPr id="226" name="Picture 1" descr=""/>
-          <p:cNvPicPr/>
-          <p:nvPr/>
-        </p:nvPicPr>
-        <p:blipFill>
-          <a:blip r:embed="rId1"/>
-          <a:stretch/>
-        </p:blipFill>
-        <p:spPr>
-          <a:xfrm>
-            <a:off x="146160" y="68760"/>
-            <a:ext cx="8539200" cy="1758600"/>
-          </a:xfrm>
-          <a:prstGeom prst="rect">
-            <a:avLst/>
-          </a:prstGeom>
-          <a:ln w="0">
-            <a:noFill/>
-          </a:ln>
-        </p:spPr>
-      </p:pic>
       <p:sp>
         <p:nvSpPr>
-          <p:cNvPr id="227" name="CustomShape 1"/>
+          <p:cNvPr id="226" name=""/>
           <p:cNvSpPr/>
           <p:nvPr/>
         </p:nvSpPr>
         <p:spPr>
           <a:xfrm>
-            <a:off x="331920" y="266760"/>
-            <a:ext cx="7781400" cy="1833480"/>
+            <a:off x="505080" y="457200"/>
+            <a:ext cx="5436720" cy="600480"/>
           </a:xfrm>
           <a:prstGeom prst="rect">
             <a:avLst/>
@@ -23631,9 +23351,230 @@
           <a:fontRef idx="minor"/>
         </p:style>
         <p:txBody>
-          <a:bodyPr wrap="none" lIns="0" rIns="0" tIns="0" bIns="0" anchor="t">
+          <a:bodyPr lIns="90000" rIns="90000" tIns="45000" bIns="45000" anchor="t">
             <a:noAutofit/>
           </a:bodyPr>
+          <a:p>
+            <a:pPr>
+              <a:lnSpc>
+                <a:spcPct val="100000"/>
+              </a:lnSpc>
+            </a:pPr>
+            <a:r>
+              <a:rPr b="1" lang="en-US" sz="1800" spc="-1" strike="noStrike">
+                <a:solidFill>
+                  <a:srgbClr val="000000"/>
+                </a:solidFill>
+                <a:latin typeface="Arial"/>
+                <a:ea typeface="Noto Sans CJK SC"/>
+              </a:rPr>
+              <a:t>Systemd-boot : Simple UEFI boot manager</a:t>
+            </a:r>
+            <a:endParaRPr b="0" lang="en-US" sz="1800" spc="-1" strike="noStrike">
+              <a:solidFill>
+                <a:srgbClr val="000000"/>
+              </a:solidFill>
+              <a:latin typeface="Arial"/>
+            </a:endParaRPr>
+          </a:p>
+        </p:txBody>
+      </p:sp>
+      <p:sp>
+        <p:nvSpPr>
+          <p:cNvPr id="227" name=""/>
+          <p:cNvSpPr/>
+          <p:nvPr/>
+        </p:nvSpPr>
+        <p:spPr>
+          <a:xfrm>
+            <a:off x="411480" y="1057320"/>
+            <a:ext cx="8502120" cy="5173200"/>
+          </a:xfrm>
+          <a:prstGeom prst="rect">
+            <a:avLst/>
+          </a:prstGeom>
+          <a:noFill/>
+          <a:ln w="0">
+            <a:noFill/>
+          </a:ln>
+        </p:spPr>
+        <p:style>
+          <a:lnRef idx="0"/>
+          <a:fillRef idx="0"/>
+          <a:effectRef idx="0"/>
+          <a:fontRef idx="minor"/>
+        </p:style>
+        <p:txBody>
+          <a:bodyPr lIns="90000" rIns="90000" tIns="45000" bIns="45000" anchor="t">
+            <a:noAutofit/>
+          </a:bodyPr>
+          <a:p>
+            <a:pPr>
+              <a:lnSpc>
+                <a:spcPct val="100000"/>
+              </a:lnSpc>
+            </a:pPr>
+            <a:endParaRPr b="0" lang="en-US" sz="1800" spc="-1" strike="noStrike">
+              <a:solidFill>
+                <a:srgbClr val="000000"/>
+              </a:solidFill>
+              <a:latin typeface="Arial"/>
+            </a:endParaRPr>
+          </a:p>
+          <a:p>
+            <a:pPr>
+              <a:lnSpc>
+                <a:spcPct val="100000"/>
+              </a:lnSpc>
+            </a:pPr>
+            <a:r>
+              <a:rPr b="0" lang="en-US" sz="1800" spc="-1" strike="noStrike">
+                <a:solidFill>
+                  <a:srgbClr val="000000"/>
+                </a:solidFill>
+                <a:latin typeface="Arial"/>
+                <a:ea typeface="DejaVu Sans"/>
+              </a:rPr>
+              <a:t>▶ </a:t>
+            </a:r>
+            <a:r>
+              <a:rPr b="0" lang="en-US" sz="1800" spc="-1" strike="noStrike">
+                <a:solidFill>
+                  <a:srgbClr val="000000"/>
+                </a:solidFill>
+                <a:latin typeface="Arial"/>
+                <a:ea typeface="DejaVu Sans"/>
+              </a:rPr>
+              <a:t>Useful alternative to GRUB for UEFI systems: simpler than GRUB</a:t>
+            </a:r>
+            <a:endParaRPr b="0" lang="en-US" sz="1800" spc="-1" strike="noStrike">
+              <a:solidFill>
+                <a:srgbClr val="000000"/>
+              </a:solidFill>
+              <a:latin typeface="Arial"/>
+            </a:endParaRPr>
+          </a:p>
+          <a:p>
+            <a:pPr>
+              <a:lnSpc>
+                <a:spcPct val="100000"/>
+              </a:lnSpc>
+            </a:pPr>
+            <a:endParaRPr b="0" lang="en-US" sz="1800" spc="-1" strike="noStrike">
+              <a:solidFill>
+                <a:srgbClr val="000000"/>
+              </a:solidFill>
+              <a:latin typeface="Arial"/>
+            </a:endParaRPr>
+          </a:p>
+          <a:p>
+            <a:pPr>
+              <a:lnSpc>
+                <a:spcPct val="100000"/>
+              </a:lnSpc>
+            </a:pPr>
+            <a:r>
+              <a:rPr b="0" lang="en-US" sz="1800" spc="-1" strike="noStrike">
+                <a:solidFill>
+                  <a:srgbClr val="000000"/>
+                </a:solidFill>
+                <a:latin typeface="Arial"/>
+                <a:ea typeface="DejaVu Sans"/>
+              </a:rPr>
+              <a:t>▶ </a:t>
+            </a:r>
+            <a:r>
+              <a:rPr b="0" lang="en-US" sz="1800" spc="-1" strike="noStrike">
+                <a:solidFill>
+                  <a:srgbClr val="000000"/>
+                </a:solidFill>
+                <a:latin typeface="Arial"/>
+                <a:ea typeface="DejaVu Sans"/>
+              </a:rPr>
+              <a:t>Configured using files stored in the EFI System Partition</a:t>
+            </a:r>
+            <a:br>
+              <a:rPr sz="1800"/>
+            </a:br>
+            <a:br>
+              <a:rPr sz="1800"/>
+            </a:br>
+            <a:r>
+              <a:rPr b="0" lang="en-US" sz="1800" spc="-1" strike="noStrike">
+                <a:solidFill>
+                  <a:srgbClr val="000000"/>
+                </a:solidFill>
+                <a:latin typeface="Arial"/>
+                <a:ea typeface="DejaVu Sans"/>
+              </a:rPr>
+              <a:t>▶ Part of the systemd project, even though obviously distinct from systemd itself</a:t>
+            </a:r>
+            <a:endParaRPr b="0" lang="en-US" sz="1800" spc="-1" strike="noStrike">
+              <a:solidFill>
+                <a:srgbClr val="000000"/>
+              </a:solidFill>
+              <a:latin typeface="Arial"/>
+            </a:endParaRPr>
+          </a:p>
+          <a:p>
+            <a:pPr>
+              <a:lnSpc>
+                <a:spcPct val="100000"/>
+              </a:lnSpc>
+            </a:pPr>
+            <a:endParaRPr b="0" lang="en-US" sz="1800" spc="-1" strike="noStrike">
+              <a:solidFill>
+                <a:srgbClr val="000000"/>
+              </a:solidFill>
+              <a:latin typeface="Arial"/>
+            </a:endParaRPr>
+          </a:p>
+          <a:p>
+            <a:pPr>
+              <a:lnSpc>
+                <a:spcPct val="100000"/>
+              </a:lnSpc>
+            </a:pPr>
+            <a:r>
+              <a:rPr b="0" lang="en-US" sz="1800" spc="-1" strike="noStrike">
+                <a:solidFill>
+                  <a:srgbClr val="000000"/>
+                </a:solidFill>
+                <a:latin typeface="Arial"/>
+                <a:ea typeface="DejaVu Sans"/>
+              </a:rPr>
+              <a:t>▶ </a:t>
+            </a:r>
+            <a:r>
+              <a:rPr b="0" lang="en-US" sz="1800" spc="-1" strike="noStrike">
+                <a:solidFill>
+                  <a:srgbClr val="000000"/>
+                </a:solidFill>
+                <a:latin typeface="Arial"/>
+                <a:ea typeface="DejaVu Sans"/>
+              </a:rPr>
+              <a:t>systemd-boot is a UEFI boot manager which executes configured EFI images.</a:t>
+            </a:r>
+            <a:endParaRPr b="0" lang="en-US" sz="1800" spc="-1" strike="noStrike">
+              <a:solidFill>
+                <a:srgbClr val="000000"/>
+              </a:solidFill>
+              <a:latin typeface="Arial"/>
+            </a:endParaRPr>
+          </a:p>
+          <a:p>
+            <a:pPr>
+              <a:lnSpc>
+                <a:spcPct val="100000"/>
+              </a:lnSpc>
+            </a:pPr>
+            <a:endParaRPr b="0" lang="en-US" sz="1800" spc="-1" strike="noStrike">
+              <a:solidFill>
+                <a:srgbClr val="000000"/>
+              </a:solidFill>
+              <a:latin typeface="Arial"/>
+            </a:endParaRPr>
+          </a:p>
           <a:p>
             <a:pPr>
               <a:lnSpc>
@@ -23647,144 +23588,71 @@
               </a:spcAft>
             </a:pPr>
             <a:r>
-              <a:rPr b="1" lang="en-US" sz="2240" spc="-1" strike="noStrike">
-                <a:solidFill>
-                  <a:srgbClr val="000000"/>
-                </a:solidFill>
-                <a:latin typeface="Arial Bold"/>
-                <a:ea typeface="DejaVu Sans"/>
-              </a:rPr>
-              <a:t>Init Runlevels</a:t>
-            </a:r>
-            <a:r>
-              <a:rPr b="0" lang="en-US" sz="2230" spc="-1" strike="noStrike">
-                <a:solidFill>
-                  <a:srgbClr val="000000"/>
-                </a:solidFill>
-                <a:latin typeface="Arial"/>
-                <a:ea typeface="DejaVu Sans"/>
-              </a:rPr>
-              <a:t>: </a:t>
-            </a:r>
-            <a:r>
-              <a:rPr b="1" lang="en-US" sz="2230" spc="-1" strike="noStrike">
-                <a:solidFill>
-                  <a:srgbClr val="000000"/>
-                </a:solidFill>
-                <a:latin typeface="Arial"/>
-                <a:ea typeface="DejaVu Sans"/>
-              </a:rPr>
-              <a:t>/etc/rc0.d (SysVinit)</a:t>
-            </a:r>
+              <a:rPr b="0" lang="en-US" sz="1800" spc="-1" strike="noStrike">
+                <a:solidFill>
+                  <a:srgbClr val="000000"/>
+                </a:solidFill>
+                <a:latin typeface="Arial"/>
+                <a:ea typeface="DejaVu Sans"/>
+              </a:rPr>
+              <a:t>▶ </a:t>
+            </a:r>
+            <a:r>
+              <a:rPr b="0" lang="en-US" sz="1800" spc="-1" strike="noStrike">
+                <a:solidFill>
+                  <a:srgbClr val="000000"/>
+                </a:solidFill>
+                <a:latin typeface="Arial"/>
+                <a:ea typeface="DejaVu Sans"/>
+              </a:rPr>
+              <a:t>systemd-boot operates on the EFI System Partition (ESP) only. Configuration file fragments, kernels, initrds, other EFI images need to reside on the ESP. Linux kernels need to be built with CONFIG_EFI_STUB to be able to be directly executed as an EFI image.  </a:t>
+            </a:r>
+            <a:endParaRPr b="0" lang="en-US" sz="1800" spc="-1" strike="noStrike">
+              <a:solidFill>
+                <a:srgbClr val="000000"/>
+              </a:solidFill>
+              <a:latin typeface="Arial"/>
+            </a:endParaRPr>
+          </a:p>
+          <a:p>
+            <a:pPr>
+              <a:lnSpc>
+                <a:spcPct val="100000"/>
+              </a:lnSpc>
+            </a:pPr>
+            <a:r>
+              <a:rPr b="1" lang="en-US" sz="1800" spc="-1" strike="noStrike">
+                <a:solidFill>
+                  <a:srgbClr val="000000"/>
+                </a:solidFill>
+                <a:latin typeface="Arial"/>
+                <a:ea typeface="DejaVu Sans"/>
+              </a:rPr>
+              <a:t>https://www.freedesktop.org/wiki/Software/systemd/systemd-boot/</a:t>
+            </a:r>
+            <a:endParaRPr b="0" lang="en-US" sz="1800" spc="-1" strike="noStrike">
+              <a:solidFill>
+                <a:srgbClr val="000000"/>
+              </a:solidFill>
+              <a:latin typeface="Arial"/>
+            </a:endParaRPr>
+          </a:p>
+          <a:p>
+            <a:pPr>
+              <a:lnSpc>
+                <a:spcPct val="100000"/>
+              </a:lnSpc>
+              <a:spcBef>
+                <a:spcPts val="1191"/>
+              </a:spcBef>
+              <a:spcAft>
+                <a:spcPts val="992"/>
+              </a:spcAft>
+            </a:pPr>
             <a:br>
-              <a:rPr sz="2230"/>
+              <a:rPr sz="1000"/>
             </a:br>
-            <a:r>
-              <a:rPr b="0" lang="en-US" sz="2230" spc="-1" strike="noStrike">
-                <a:solidFill>
-                  <a:srgbClr val="000000"/>
-                </a:solidFill>
-                <a:latin typeface="Arial"/>
-                <a:ea typeface="DejaVu Sans"/>
-              </a:rPr>
-              <a:t>The idea behind operating different services at</a:t>
-            </a:r>
-            <a:endParaRPr b="0" lang="en-US" sz="2230" spc="-1" strike="noStrike">
-              <a:solidFill>
-                <a:srgbClr val="000000"/>
-              </a:solidFill>
-              <a:latin typeface="Arial"/>
-            </a:endParaRPr>
-          </a:p>
-          <a:p>
-            <a:pPr>
-              <a:lnSpc>
-                <a:spcPct val="100000"/>
-              </a:lnSpc>
-            </a:pPr>
-            <a:r>
-              <a:rPr b="0" lang="en-US" sz="2230" spc="-1" strike="noStrike">
-                <a:solidFill>
-                  <a:srgbClr val="000000"/>
-                </a:solidFill>
-                <a:latin typeface="Arial"/>
-                <a:ea typeface="DejaVu Sans"/>
-              </a:rPr>
-              <a:t>different run levels essentially revolves around the fact that</a:t>
-            </a:r>
-            <a:endParaRPr b="0" lang="en-US" sz="2230" spc="-1" strike="noStrike">
-              <a:solidFill>
-                <a:srgbClr val="000000"/>
-              </a:solidFill>
-              <a:latin typeface="Arial"/>
-            </a:endParaRPr>
-          </a:p>
-          <a:p>
-            <a:pPr>
-              <a:lnSpc>
-                <a:spcPct val="100000"/>
-              </a:lnSpc>
-            </a:pPr>
-            <a:r>
-              <a:rPr b="0" lang="en-US" sz="2230" spc="-1" strike="noStrike">
-                <a:solidFill>
-                  <a:srgbClr val="000000"/>
-                </a:solidFill>
-                <a:latin typeface="Arial"/>
-                <a:ea typeface="DejaVu Sans"/>
-              </a:rPr>
-              <a:t>different systems can be used in a different ways. The following</a:t>
-            </a:r>
-            <a:endParaRPr b="0" lang="en-US" sz="2230" spc="-1" strike="noStrike">
-              <a:solidFill>
-                <a:srgbClr val="000000"/>
-              </a:solidFill>
-              <a:latin typeface="Arial"/>
-            </a:endParaRPr>
-          </a:p>
-          <a:p>
-            <a:pPr>
-              <a:lnSpc>
-                <a:spcPts val="1023"/>
-              </a:lnSpc>
-            </a:pPr>
-            <a:endParaRPr b="0" lang="en-US" sz="2230" spc="-1" strike="noStrike">
-              <a:solidFill>
-                <a:srgbClr val="000000"/>
-              </a:solidFill>
-              <a:latin typeface="Arial"/>
-            </a:endParaRPr>
-          </a:p>
-          <a:p>
-            <a:pPr>
-              <a:lnSpc>
-                <a:spcPts val="1023"/>
-              </a:lnSpc>
-            </a:pPr>
-            <a:endParaRPr b="0" lang="en-US" sz="2230" spc="-1" strike="noStrike">
-              <a:solidFill>
-                <a:srgbClr val="000000"/>
-              </a:solidFill>
-              <a:latin typeface="Arial"/>
-            </a:endParaRPr>
-          </a:p>
-          <a:p>
-            <a:pPr>
-              <a:lnSpc>
-                <a:spcPts val="1023"/>
-              </a:lnSpc>
-            </a:pPr>
-            <a:r>
-              <a:rPr b="0" lang="en-US" sz="2230" spc="-1" strike="noStrike">
-                <a:solidFill>
-                  <a:srgbClr val="000000"/>
-                </a:solidFill>
-                <a:latin typeface="Arial"/>
-                <a:ea typeface="DejaVu Sans"/>
-              </a:rPr>
-              <a:t>runlevels are defined in Red Hat Linux :</a:t>
-            </a:r>
-            <a:endParaRPr b="0" lang="en-US" sz="2230" spc="-1" strike="noStrike">
+            <a:endParaRPr b="0" lang="en-US" sz="1000" spc="-1" strike="noStrike">
               <a:solidFill>
                 <a:srgbClr val="000000"/>
               </a:solidFill>
@@ -23793,29 +23661,6 @@
           </a:p>
         </p:txBody>
       </p:sp>
-      <p:pic>
-        <p:nvPicPr>
-          <p:cNvPr id="228" name="" descr=""/>
-          <p:cNvPicPr/>
-          <p:nvPr/>
-        </p:nvPicPr>
-        <p:blipFill>
-          <a:blip r:embed="rId2"/>
-          <a:stretch/>
-        </p:blipFill>
-        <p:spPr>
-          <a:xfrm>
-            <a:off x="1143000" y="1855800"/>
-            <a:ext cx="5996160" cy="4314960"/>
-          </a:xfrm>
-          <a:prstGeom prst="rect">
-            <a:avLst/>
-          </a:prstGeom>
-          <a:ln w="0">
-            <a:noFill/>
-          </a:ln>
-        </p:spPr>
-      </p:pic>
     </p:spTree>
   </p:cSld>
   <mc:AlternateContent>
@@ -23855,7 +23700,7 @@
         <p:spPr>
           <a:xfrm>
             <a:off x="60840" y="298080"/>
-            <a:ext cx="7709760" cy="2900520"/>
+            <a:ext cx="7709400" cy="2900160"/>
           </a:xfrm>
           <a:prstGeom prst="rect">
             <a:avLst/>
@@ -24189,6 +24034,270 @@
           </a:p>
         </p:txBody>
       </p:sp>
+    </p:spTree>
+  </p:cSld>
+  <mc:AlternateContent>
+    <mc:Choice Requires="p14">
+      <p:transition spd="slow" p14:dur="2000"/>
+    </mc:Choice>
+    <mc:Fallback>
+      <p:transition spd="slow"/>
+    </mc:Fallback>
+  </mc:AlternateContent>
+</p:sld>
+</file>
+
+<file path=ppt/slides/slide30.xml><?xml version="1.0" encoding="utf-8"?>
+<p:sld xmlns:a="http://schemas.openxmlformats.org/drawingml/2006/main" xmlns:p="http://schemas.openxmlformats.org/presentationml/2006/main" xmlns:r="http://schemas.openxmlformats.org/officeDocument/2006/relationships" xmlns:p14="http://schemas.microsoft.com/office/powerpoint/2010/main" xmlns:p15="http://schemas.microsoft.com/office/powerpoint/2012/main" xmlns:mc="http://schemas.openxmlformats.org/markup-compatibility/2006">
+  <p:cSld>
+    <p:spTree>
+      <p:nvGrpSpPr>
+        <p:cNvPr id="1" name=""/>
+        <p:cNvGrpSpPr/>
+        <p:nvPr/>
+      </p:nvGrpSpPr>
+      <p:grpSpPr>
+        <a:xfrm>
+          <a:off x="0" y="0"/>
+          <a:ext cx="0" cy="0"/>
+          <a:chOff x="0" y="0"/>
+          <a:chExt cx="0" cy="0"/>
+        </a:xfrm>
+      </p:grpSpPr>
+      <p:pic>
+        <p:nvPicPr>
+          <p:cNvPr id="228" name="Picture 1" descr=""/>
+          <p:cNvPicPr/>
+          <p:nvPr/>
+        </p:nvPicPr>
+        <p:blipFill>
+          <a:blip r:embed="rId1"/>
+          <a:stretch/>
+        </p:blipFill>
+        <p:spPr>
+          <a:xfrm>
+            <a:off x="146160" y="68760"/>
+            <a:ext cx="8538840" cy="1758240"/>
+          </a:xfrm>
+          <a:prstGeom prst="rect">
+            <a:avLst/>
+          </a:prstGeom>
+          <a:ln w="0">
+            <a:noFill/>
+          </a:ln>
+        </p:spPr>
+      </p:pic>
+      <p:sp>
+        <p:nvSpPr>
+          <p:cNvPr id="229" name="CustomShape 1"/>
+          <p:cNvSpPr/>
+          <p:nvPr/>
+        </p:nvSpPr>
+        <p:spPr>
+          <a:xfrm>
+            <a:off x="331920" y="266760"/>
+            <a:ext cx="7781040" cy="1833120"/>
+          </a:xfrm>
+          <a:prstGeom prst="rect">
+            <a:avLst/>
+          </a:prstGeom>
+          <a:noFill/>
+          <a:ln w="0">
+            <a:noFill/>
+          </a:ln>
+        </p:spPr>
+        <p:style>
+          <a:lnRef idx="0"/>
+          <a:fillRef idx="0"/>
+          <a:effectRef idx="0"/>
+          <a:fontRef idx="minor"/>
+        </p:style>
+        <p:txBody>
+          <a:bodyPr wrap="none" lIns="0" rIns="0" tIns="0" bIns="0" anchor="t">
+            <a:noAutofit/>
+          </a:bodyPr>
+          <a:p>
+            <a:pPr>
+              <a:lnSpc>
+                <a:spcPct val="100000"/>
+              </a:lnSpc>
+              <a:spcBef>
+                <a:spcPts val="1191"/>
+              </a:spcBef>
+              <a:spcAft>
+                <a:spcPts val="992"/>
+              </a:spcAft>
+            </a:pPr>
+            <a:r>
+              <a:rPr b="1" lang="en-US" sz="2240" spc="-1" strike="noStrike">
+                <a:solidFill>
+                  <a:srgbClr val="000000"/>
+                </a:solidFill>
+                <a:latin typeface="Arial Bold"/>
+                <a:ea typeface="DejaVu Sans"/>
+              </a:rPr>
+              <a:t>Init Runlevels</a:t>
+            </a:r>
+            <a:r>
+              <a:rPr b="0" lang="en-US" sz="2230" spc="-1" strike="noStrike">
+                <a:solidFill>
+                  <a:srgbClr val="000000"/>
+                </a:solidFill>
+                <a:latin typeface="Arial"/>
+                <a:ea typeface="DejaVu Sans"/>
+              </a:rPr>
+              <a:t>: </a:t>
+            </a:r>
+            <a:r>
+              <a:rPr b="1" lang="en-US" sz="2230" spc="-1" strike="noStrike">
+                <a:solidFill>
+                  <a:srgbClr val="000000"/>
+                </a:solidFill>
+                <a:latin typeface="Arial"/>
+                <a:ea typeface="DejaVu Sans"/>
+              </a:rPr>
+              <a:t>/etc/rc0.d (SysVinit)</a:t>
+            </a:r>
+            <a:br>
+              <a:rPr sz="2230"/>
+            </a:br>
+            <a:r>
+              <a:rPr b="0" lang="en-US" sz="2230" spc="-1" strike="noStrike">
+                <a:solidFill>
+                  <a:srgbClr val="000000"/>
+                </a:solidFill>
+                <a:latin typeface="Arial"/>
+                <a:ea typeface="DejaVu Sans"/>
+              </a:rPr>
+              <a:t>The idea behind operating different services at</a:t>
+            </a:r>
+            <a:endParaRPr b="0" lang="en-US" sz="2230" spc="-1" strike="noStrike">
+              <a:solidFill>
+                <a:srgbClr val="000000"/>
+              </a:solidFill>
+              <a:latin typeface="Arial"/>
+            </a:endParaRPr>
+          </a:p>
+          <a:p>
+            <a:pPr>
+              <a:lnSpc>
+                <a:spcPct val="100000"/>
+              </a:lnSpc>
+            </a:pPr>
+            <a:r>
+              <a:rPr b="0" lang="en-US" sz="2230" spc="-1" strike="noStrike">
+                <a:solidFill>
+                  <a:srgbClr val="000000"/>
+                </a:solidFill>
+                <a:latin typeface="Arial"/>
+                <a:ea typeface="DejaVu Sans"/>
+              </a:rPr>
+              <a:t>different run levels essentially revolves around the fact that</a:t>
+            </a:r>
+            <a:endParaRPr b="0" lang="en-US" sz="2230" spc="-1" strike="noStrike">
+              <a:solidFill>
+                <a:srgbClr val="000000"/>
+              </a:solidFill>
+              <a:latin typeface="Arial"/>
+            </a:endParaRPr>
+          </a:p>
+          <a:p>
+            <a:pPr>
+              <a:lnSpc>
+                <a:spcPct val="100000"/>
+              </a:lnSpc>
+            </a:pPr>
+            <a:r>
+              <a:rPr b="0" lang="en-US" sz="2230" spc="-1" strike="noStrike">
+                <a:solidFill>
+                  <a:srgbClr val="000000"/>
+                </a:solidFill>
+                <a:latin typeface="Arial"/>
+                <a:ea typeface="DejaVu Sans"/>
+              </a:rPr>
+              <a:t>different systems can be used in a different ways. The following</a:t>
+            </a:r>
+            <a:endParaRPr b="0" lang="en-US" sz="2230" spc="-1" strike="noStrike">
+              <a:solidFill>
+                <a:srgbClr val="000000"/>
+              </a:solidFill>
+              <a:latin typeface="Arial"/>
+            </a:endParaRPr>
+          </a:p>
+          <a:p>
+            <a:pPr>
+              <a:lnSpc>
+                <a:spcPts val="1023"/>
+              </a:lnSpc>
+            </a:pPr>
+            <a:endParaRPr b="0" lang="en-US" sz="2230" spc="-1" strike="noStrike">
+              <a:solidFill>
+                <a:srgbClr val="000000"/>
+              </a:solidFill>
+              <a:latin typeface="Arial"/>
+            </a:endParaRPr>
+          </a:p>
+          <a:p>
+            <a:pPr>
+              <a:lnSpc>
+                <a:spcPts val="1023"/>
+              </a:lnSpc>
+            </a:pPr>
+            <a:endParaRPr b="0" lang="en-US" sz="2230" spc="-1" strike="noStrike">
+              <a:solidFill>
+                <a:srgbClr val="000000"/>
+              </a:solidFill>
+              <a:latin typeface="Arial"/>
+            </a:endParaRPr>
+          </a:p>
+          <a:p>
+            <a:pPr>
+              <a:lnSpc>
+                <a:spcPts val="1023"/>
+              </a:lnSpc>
+            </a:pPr>
+            <a:r>
+              <a:rPr b="0" lang="en-US" sz="2230" spc="-1" strike="noStrike">
+                <a:solidFill>
+                  <a:srgbClr val="000000"/>
+                </a:solidFill>
+                <a:latin typeface="Arial"/>
+                <a:ea typeface="DejaVu Sans"/>
+              </a:rPr>
+              <a:t>runlevels are defined in Red Hat Linux :</a:t>
+            </a:r>
+            <a:endParaRPr b="0" lang="en-US" sz="2230" spc="-1" strike="noStrike">
+              <a:solidFill>
+                <a:srgbClr val="000000"/>
+              </a:solidFill>
+              <a:latin typeface="Arial"/>
+            </a:endParaRPr>
+          </a:p>
+        </p:txBody>
+      </p:sp>
+      <p:pic>
+        <p:nvPicPr>
+          <p:cNvPr id="230" name="" descr=""/>
+          <p:cNvPicPr/>
+          <p:nvPr/>
+        </p:nvPicPr>
+        <p:blipFill>
+          <a:blip r:embed="rId2"/>
+          <a:stretch/>
+        </p:blipFill>
+        <p:spPr>
+          <a:xfrm>
+            <a:off x="1143000" y="1855800"/>
+            <a:ext cx="5995800" cy="4314600"/>
+          </a:xfrm>
+          <a:prstGeom prst="rect">
+            <a:avLst/>
+          </a:prstGeom>
+          <a:ln w="0">
+            <a:noFill/>
+          </a:ln>
+        </p:spPr>
+      </p:pic>
     </p:spTree>
   </p:cSld>
   <mc:AlternateContent>
@@ -24228,7 +24337,7 @@
         <p:spPr>
           <a:xfrm>
             <a:off x="467640" y="72000"/>
-            <a:ext cx="8201160" cy="1454400"/>
+            <a:ext cx="8200800" cy="1454040"/>
           </a:xfrm>
           <a:prstGeom prst="rect">
             <a:avLst/>
@@ -24744,7 +24853,7 @@
         <p:spPr>
           <a:xfrm>
             <a:off x="183600" y="147600"/>
-            <a:ext cx="8958240" cy="2391840"/>
+            <a:ext cx="8957880" cy="2391480"/>
           </a:xfrm>
           <a:prstGeom prst="rect">
             <a:avLst/>
@@ -25002,7 +25111,7 @@
         <p:spPr>
           <a:xfrm>
             <a:off x="192600" y="2658600"/>
-            <a:ext cx="8685000" cy="2903760"/>
+            <a:ext cx="8684640" cy="2903400"/>
           </a:xfrm>
           <a:prstGeom prst="rect">
             <a:avLst/>
@@ -25362,8 +25471,8 @@
         </p:blipFill>
         <p:spPr>
           <a:xfrm>
-            <a:off x="1371600" y="-1209240"/>
-            <a:ext cx="7112160" cy="5322240"/>
+            <a:off x="1371600" y="228600"/>
+            <a:ext cx="7111800" cy="3920040"/>
           </a:xfrm>
           <a:prstGeom prst="rect">
             <a:avLst/>
@@ -25382,7 +25491,7 @@
         <p:spPr>
           <a:xfrm>
             <a:off x="2541960" y="648000"/>
-            <a:ext cx="2493720" cy="708480"/>
+            <a:ext cx="2493360" cy="708120"/>
           </a:xfrm>
           <a:prstGeom prst="rect">
             <a:avLst/>
@@ -25436,7 +25545,7 @@
         <p:spPr>
           <a:xfrm>
             <a:off x="204120" y="1008000"/>
-            <a:ext cx="8790120" cy="1813680"/>
+            <a:ext cx="8789760" cy="1813320"/>
           </a:xfrm>
           <a:prstGeom prst="rect">
             <a:avLst/>
@@ -25605,7 +25714,7 @@
         <p:spPr>
           <a:xfrm>
             <a:off x="224280" y="2869920"/>
-            <a:ext cx="7774920" cy="708480"/>
+            <a:ext cx="7774560" cy="708120"/>
           </a:xfrm>
           <a:prstGeom prst="rect">
             <a:avLst/>
@@ -25659,7 +25768,7 @@
         <p:spPr>
           <a:xfrm>
             <a:off x="225720" y="3009600"/>
-            <a:ext cx="9033840" cy="1809720"/>
+            <a:ext cx="9033480" cy="1809360"/>
           </a:xfrm>
           <a:prstGeom prst="rect">
             <a:avLst/>
@@ -25798,7 +25907,7 @@
         <p:spPr>
           <a:xfrm>
             <a:off x="216000" y="4343400"/>
-            <a:ext cx="8697600" cy="1096920"/>
+            <a:ext cx="8697240" cy="1096560"/>
           </a:xfrm>
           <a:prstGeom prst="rect">
             <a:avLst/>
@@ -25944,7 +26053,7 @@
         <p:spPr>
           <a:xfrm>
             <a:off x="108000" y="5297760"/>
-            <a:ext cx="8898120" cy="852480"/>
+            <a:ext cx="8897760" cy="852120"/>
           </a:xfrm>
           <a:prstGeom prst="rect">
             <a:avLst/>
@@ -26052,7 +26161,7 @@
         <p:spPr>
           <a:xfrm>
             <a:off x="0" y="-76320"/>
-            <a:ext cx="9136080" cy="6837480"/>
+            <a:ext cx="9135720" cy="6837120"/>
           </a:xfrm>
           <a:prstGeom prst="rect">
             <a:avLst/>
@@ -26071,7 +26180,7 @@
         <p:spPr>
           <a:xfrm>
             <a:off x="271080" y="266760"/>
-            <a:ext cx="8642520" cy="906840"/>
+            <a:ext cx="8642160" cy="906480"/>
           </a:xfrm>
           <a:prstGeom prst="rect">
             <a:avLst/>
@@ -26597,7 +26706,7 @@
         <p:spPr>
           <a:xfrm>
             <a:off x="252360" y="1371600"/>
-            <a:ext cx="7778520" cy="1211760"/>
+            <a:ext cx="7778160" cy="1211400"/>
           </a:xfrm>
           <a:prstGeom prst="rect">
             <a:avLst/>
@@ -26710,7 +26819,7 @@
         <p:spPr>
           <a:xfrm>
             <a:off x="267120" y="2309040"/>
-            <a:ext cx="8228880" cy="3346200"/>
+            <a:ext cx="8228520" cy="3345840"/>
           </a:xfrm>
           <a:prstGeom prst="rect">
             <a:avLst/>
@@ -27011,7 +27120,7 @@
         <p:spPr>
           <a:xfrm>
             <a:off x="288000" y="187560"/>
-            <a:ext cx="7917120" cy="1821600"/>
+            <a:ext cx="7916760" cy="1821240"/>
           </a:xfrm>
           <a:prstGeom prst="rect">
             <a:avLst/>
@@ -27330,7 +27439,7 @@
         <p:spPr>
           <a:xfrm>
             <a:off x="288000" y="1924200"/>
-            <a:ext cx="4111560" cy="588960"/>
+            <a:ext cx="4111200" cy="588600"/>
           </a:xfrm>
           <a:prstGeom prst="rect">
             <a:avLst/>
@@ -27384,7 +27493,7 @@
         <p:spPr>
           <a:xfrm>
             <a:off x="312120" y="2083680"/>
-            <a:ext cx="7023600" cy="588960"/>
+            <a:ext cx="7023240" cy="588600"/>
           </a:xfrm>
           <a:prstGeom prst="rect">
             <a:avLst/>
@@ -27500,7 +27609,7 @@
         <p:spPr>
           <a:xfrm>
             <a:off x="288000" y="2480040"/>
-            <a:ext cx="8063640" cy="3346200"/>
+            <a:ext cx="8063280" cy="3345840"/>
           </a:xfrm>
           <a:prstGeom prst="rect">
             <a:avLst/>
@@ -27837,7 +27946,7 @@
         <p:spPr>
           <a:xfrm>
             <a:off x="331560" y="5496480"/>
-            <a:ext cx="8353440" cy="1211760"/>
+            <a:ext cx="8353080" cy="1211400"/>
           </a:xfrm>
           <a:prstGeom prst="rect">
             <a:avLst/>
@@ -28062,7 +28171,7 @@
         <p:spPr>
           <a:xfrm>
             <a:off x="432000" y="360000"/>
-            <a:ext cx="8710200" cy="1875240"/>
+            <a:ext cx="8709840" cy="1874880"/>
           </a:xfrm>
           <a:prstGeom prst="rect">
             <a:avLst/>

</xml_diff>

<commit_message>
Add user space content day 3
Signed-off-by: Rama <embedded.training.rama@gmail.com>
</commit_message>
<xml_diff>
--- a/2_Linux_kernel_config.pptx
+++ b/2_Linux_kernel_config.pptx
@@ -57,6 +57,7 @@
     <p:sldId id="282" r:id="rId52"/>
     <p:sldId id="283" r:id="rId53"/>
     <p:sldId id="284" r:id="rId54"/>
+    <p:sldId id="285" r:id="rId55"/>
   </p:sldIdLst>
   <p:sldSz cx="9144000" cy="6858000"/>
   <p:notesSz cx="7559675" cy="10691813"/>
@@ -3007,7 +3008,16 @@
                 </a:solidFill>
                 <a:latin typeface="Arial"/>
               </a:rPr>
-              <a:t>Click to edit the title text format</a:t>
+              <a:t>Click to edit the </a:t>
+            </a:r>
+            <a:r>
+              <a:rPr b="0" lang="en-US" sz="1800" spc="-1" strike="noStrike">
+                <a:solidFill>
+                  <a:srgbClr val="000000"/>
+                </a:solidFill>
+                <a:latin typeface="Arial"/>
+              </a:rPr>
+              <a:t>title text format</a:t>
             </a:r>
             <a:endParaRPr b="0" lang="en-US" sz="1800" spc="-1" strike="noStrike">
               <a:solidFill>
@@ -11229,52 +11239,7 @@
                 </a:solidFill>
                 <a:latin typeface="Arial"/>
               </a:rPr>
-              <a:t>Click </a:t>
-            </a:r>
-            <a:r>
-              <a:rPr b="0" lang="en-US" sz="1800" spc="-1" strike="noStrike">
-                <a:solidFill>
-                  <a:srgbClr val="000000"/>
-                </a:solidFill>
-                <a:latin typeface="Arial"/>
-              </a:rPr>
-              <a:t>to edit </a:t>
-            </a:r>
-            <a:r>
-              <a:rPr b="0" lang="en-US" sz="1800" spc="-1" strike="noStrike">
-                <a:solidFill>
-                  <a:srgbClr val="000000"/>
-                </a:solidFill>
-                <a:latin typeface="Arial"/>
-              </a:rPr>
-              <a:t>the </a:t>
-            </a:r>
-            <a:r>
-              <a:rPr b="0" lang="en-US" sz="1800" spc="-1" strike="noStrike">
-                <a:solidFill>
-                  <a:srgbClr val="000000"/>
-                </a:solidFill>
-                <a:latin typeface="Arial"/>
-              </a:rPr>
-              <a:t>title </a:t>
-            </a:r>
-            <a:r>
-              <a:rPr b="0" lang="en-US" sz="1800" spc="-1" strike="noStrike">
-                <a:solidFill>
-                  <a:srgbClr val="000000"/>
-                </a:solidFill>
-                <a:latin typeface="Arial"/>
-              </a:rPr>
-              <a:t>text </a:t>
-            </a:r>
-            <a:r>
-              <a:rPr b="0" lang="en-US" sz="1800" spc="-1" strike="noStrike">
-                <a:solidFill>
-                  <a:srgbClr val="000000"/>
-                </a:solidFill>
-                <a:latin typeface="Arial"/>
-              </a:rPr>
-              <a:t>format</a:t>
+              <a:t>Click to edit the title text format</a:t>
             </a:r>
             <a:endParaRPr b="0" lang="en-US" sz="1800" spc="-1" strike="noStrike">
               <a:solidFill>
@@ -13792,7 +13757,7 @@
         <p:spPr>
           <a:xfrm>
             <a:off x="3600" y="-1634040"/>
-            <a:ext cx="9141840" cy="6093720"/>
+            <a:ext cx="9141480" cy="6093360"/>
           </a:xfrm>
           <a:prstGeom prst="rect">
             <a:avLst/>
@@ -13845,7 +13810,7 @@
         <p:spPr>
           <a:xfrm>
             <a:off x="0" y="0"/>
-            <a:ext cx="9136080" cy="6837480"/>
+            <a:ext cx="9135720" cy="6837120"/>
           </a:xfrm>
           <a:prstGeom prst="rect">
             <a:avLst/>
@@ -13864,7 +13829,7 @@
         <p:spPr>
           <a:xfrm>
             <a:off x="3271320" y="285840"/>
-            <a:ext cx="2804760" cy="708480"/>
+            <a:ext cx="2804400" cy="708120"/>
           </a:xfrm>
           <a:prstGeom prst="rect">
             <a:avLst/>
@@ -13918,7 +13883,7 @@
         <p:spPr>
           <a:xfrm>
             <a:off x="208080" y="582120"/>
-            <a:ext cx="8283240" cy="1478160"/>
+            <a:ext cx="8282880" cy="1477800"/>
           </a:xfrm>
           <a:prstGeom prst="rect">
             <a:avLst/>
@@ -14008,7 +13973,7 @@
         <p:spPr>
           <a:xfrm>
             <a:off x="231480" y="1739880"/>
-            <a:ext cx="8682120" cy="1478160"/>
+            <a:ext cx="8681760" cy="1477800"/>
           </a:xfrm>
           <a:prstGeom prst="rect">
             <a:avLst/>
@@ -14088,7 +14053,7 @@
         <p:spPr>
           <a:xfrm>
             <a:off x="251640" y="2514600"/>
-            <a:ext cx="8705160" cy="4062240"/>
+            <a:ext cx="8704800" cy="4061880"/>
           </a:xfrm>
           <a:prstGeom prst="rect">
             <a:avLst/>
@@ -14351,6 +14316,42 @@
           <a:p>
             <a:pPr>
               <a:lnSpc>
+                <a:spcPct val="100000"/>
+              </a:lnSpc>
+            </a:pPr>
+            <a:endParaRPr b="0" lang="en-US" sz="1800" spc="-1" strike="noStrike">
+              <a:solidFill>
+                <a:srgbClr val="000000"/>
+              </a:solidFill>
+              <a:latin typeface="Arial"/>
+            </a:endParaRPr>
+          </a:p>
+          <a:p>
+            <a:pPr>
+              <a:lnSpc>
+                <a:spcPct val="100000"/>
+              </a:lnSpc>
+            </a:pPr>
+            <a:r>
+              <a:rPr b="1" lang="en-US" sz="1800" spc="-1" strike="noStrike">
+                <a:solidFill>
+                  <a:srgbClr val="000000"/>
+                </a:solidFill>
+                <a:latin typeface="Calibri"/>
+                <a:ea typeface="DejaVu Sans"/>
+              </a:rPr>
+              <a:t>make olddefconfig</a:t>
+            </a:r>
+            <a:endParaRPr b="0" lang="en-US" sz="1800" spc="-1" strike="noStrike">
+              <a:solidFill>
+                <a:srgbClr val="000000"/>
+              </a:solidFill>
+              <a:latin typeface="Arial"/>
+            </a:endParaRPr>
+          </a:p>
+          <a:p>
+            <a:pPr>
+              <a:lnSpc>
                 <a:spcPts val="1375"/>
               </a:lnSpc>
             </a:pPr>
@@ -14372,7 +14373,7 @@
         <p:spPr>
           <a:xfrm>
             <a:off x="1727280" y="3479760"/>
-            <a:ext cx="91800" cy="500040"/>
+            <a:ext cx="91440" cy="499680"/>
           </a:xfrm>
           <a:prstGeom prst="rect">
             <a:avLst/>
@@ -14426,7 +14427,7 @@
         <p:spPr>
           <a:xfrm>
             <a:off x="32040" y="4508280"/>
-            <a:ext cx="360" cy="709200"/>
+            <a:ext cx="360" cy="708840"/>
           </a:xfrm>
           <a:prstGeom prst="rect">
             <a:avLst/>
@@ -14517,7 +14518,7 @@
         <p:spPr>
           <a:xfrm>
             <a:off x="0" y="0"/>
-            <a:ext cx="9136080" cy="6837480"/>
+            <a:ext cx="9135720" cy="6837120"/>
           </a:xfrm>
           <a:prstGeom prst="rect">
             <a:avLst/>
@@ -14536,7 +14537,7 @@
         <p:spPr>
           <a:xfrm>
             <a:off x="2966400" y="524880"/>
-            <a:ext cx="3088440" cy="708480"/>
+            <a:ext cx="3088080" cy="708120"/>
           </a:xfrm>
           <a:prstGeom prst="rect">
             <a:avLst/>
@@ -14590,7 +14591,7 @@
         <p:spPr>
           <a:xfrm>
             <a:off x="226080" y="1191600"/>
-            <a:ext cx="8687520" cy="708480"/>
+            <a:ext cx="8687160" cy="708120"/>
           </a:xfrm>
           <a:prstGeom prst="rect">
             <a:avLst/>
@@ -14644,7 +14645,7 @@
         <p:spPr>
           <a:xfrm>
             <a:off x="934200" y="1866960"/>
-            <a:ext cx="5713200" cy="708480"/>
+            <a:ext cx="5712840" cy="708120"/>
           </a:xfrm>
           <a:prstGeom prst="rect">
             <a:avLst/>
@@ -14698,7 +14699,7 @@
         <p:spPr>
           <a:xfrm>
             <a:off x="413280" y="2127240"/>
-            <a:ext cx="8500320" cy="1478160"/>
+            <a:ext cx="8499960" cy="1477800"/>
           </a:xfrm>
           <a:prstGeom prst="rect">
             <a:avLst/>
@@ -14788,7 +14789,7 @@
         <p:spPr>
           <a:xfrm>
             <a:off x="1804680" y="2865960"/>
-            <a:ext cx="5340240" cy="1478160"/>
+            <a:ext cx="5339880" cy="1477800"/>
           </a:xfrm>
           <a:prstGeom prst="rect">
             <a:avLst/>
@@ -14888,7 +14889,7 @@
         <p:spPr>
           <a:xfrm>
             <a:off x="2562120" y="4186800"/>
-            <a:ext cx="1881360" cy="708480"/>
+            <a:ext cx="1881000" cy="708120"/>
           </a:xfrm>
           <a:prstGeom prst="rect">
             <a:avLst/>
@@ -14942,7 +14943,7 @@
         <p:spPr>
           <a:xfrm>
             <a:off x="3203280" y="4813200"/>
-            <a:ext cx="3504240" cy="708480"/>
+            <a:ext cx="3503880" cy="708120"/>
           </a:xfrm>
           <a:prstGeom prst="rect">
             <a:avLst/>
@@ -14996,7 +14997,7 @@
         <p:spPr>
           <a:xfrm>
             <a:off x="3199320" y="5200560"/>
-            <a:ext cx="3799800" cy="708480"/>
+            <a:ext cx="3799440" cy="708120"/>
           </a:xfrm>
           <a:prstGeom prst="rect">
             <a:avLst/>
@@ -15080,7 +15081,7 @@
         <p:spPr>
           <a:xfrm>
             <a:off x="0" y="0"/>
-            <a:ext cx="9065520" cy="6010920"/>
+            <a:ext cx="9065160" cy="6010560"/>
           </a:xfrm>
           <a:prstGeom prst="rect">
             <a:avLst/>
@@ -15772,7 +15773,7 @@
         <p:spPr>
           <a:xfrm>
             <a:off x="3717000" y="355680"/>
-            <a:ext cx="2082960" cy="708480"/>
+            <a:ext cx="2082600" cy="708120"/>
           </a:xfrm>
           <a:prstGeom prst="rect">
             <a:avLst/>
@@ -15826,7 +15827,7 @@
         <p:spPr>
           <a:xfrm>
             <a:off x="72000" y="792000"/>
-            <a:ext cx="8852040" cy="924480"/>
+            <a:ext cx="8851680" cy="924120"/>
           </a:xfrm>
           <a:prstGeom prst="rect">
             <a:avLst/>
@@ -15900,7 +15901,7 @@
         <p:spPr>
           <a:xfrm>
             <a:off x="444240" y="1447920"/>
-            <a:ext cx="8628120" cy="1443240"/>
+            <a:ext cx="8627760" cy="1442880"/>
           </a:xfrm>
           <a:prstGeom prst="rect">
             <a:avLst/>
@@ -15957,7 +15958,7 @@
         <p:spPr>
           <a:xfrm>
             <a:off x="264960" y="555120"/>
-            <a:ext cx="8659080" cy="3256920"/>
+            <a:ext cx="8658720" cy="3256560"/>
           </a:xfrm>
           <a:prstGeom prst="rect">
             <a:avLst/>
@@ -16002,7 +16003,7 @@
         <p:spPr>
           <a:xfrm>
             <a:off x="667800" y="3276720"/>
-            <a:ext cx="8181360" cy="1069200"/>
+            <a:ext cx="8181000" cy="1068840"/>
           </a:xfrm>
           <a:prstGeom prst="rect">
             <a:avLst/>
@@ -16047,7 +16048,7 @@
         <p:spPr>
           <a:xfrm>
             <a:off x="47880" y="2239560"/>
-            <a:ext cx="812160" cy="708480"/>
+            <a:ext cx="811800" cy="708120"/>
           </a:xfrm>
           <a:prstGeom prst="rect">
             <a:avLst/>
@@ -16101,7 +16102,7 @@
         <p:spPr>
           <a:xfrm>
             <a:off x="216000" y="2466000"/>
-            <a:ext cx="8636040" cy="1096920"/>
+            <a:ext cx="8635680" cy="1096560"/>
           </a:xfrm>
           <a:prstGeom prst="rect">
             <a:avLst/>
@@ -16191,7 +16192,7 @@
         <p:spPr>
           <a:xfrm>
             <a:off x="216000" y="4803480"/>
-            <a:ext cx="7986240" cy="340560"/>
+            <a:ext cx="7985880" cy="340200"/>
           </a:xfrm>
           <a:prstGeom prst="rect">
             <a:avLst/>
@@ -16225,6 +16226,19 @@
                 <a:latin typeface="Arial"/>
                 <a:ea typeface="DejaVu Sans"/>
               </a:rPr>
+              <a:t>make olddefconfig</a:t>
+            </a:r>
+            <a:br>
+              <a:rPr sz="1800"/>
+            </a:br>
+            <a:r>
+              <a:rPr b="1" lang="en-IN" sz="1800" spc="-1" strike="noStrike">
+                <a:solidFill>
+                  <a:srgbClr val="000000"/>
+                </a:solidFill>
+                <a:latin typeface="Arial"/>
+                <a:ea typeface="DejaVu Sans"/>
+              </a:rPr>
               <a:t>make -jn , make modules, make modules_install, make install</a:t>
             </a:r>
             <a:endParaRPr b="0" lang="en-US" sz="1800" spc="-1" strike="noStrike">
@@ -16245,7 +16259,7 @@
         <p:spPr>
           <a:xfrm>
             <a:off x="0" y="936000"/>
-            <a:ext cx="8888040" cy="1348200"/>
+            <a:ext cx="8887680" cy="1347840"/>
           </a:xfrm>
           <a:prstGeom prst="rect">
             <a:avLst/>
@@ -16299,7 +16313,7 @@
         <p:spPr>
           <a:xfrm>
             <a:off x="93240" y="3133440"/>
-            <a:ext cx="8902800" cy="1347840"/>
+            <a:ext cx="8902440" cy="1347480"/>
           </a:xfrm>
           <a:prstGeom prst="rect">
             <a:avLst/>
@@ -16353,7 +16367,7 @@
         <p:spPr>
           <a:xfrm>
             <a:off x="264960" y="5365800"/>
-            <a:ext cx="7697880" cy="856440"/>
+            <a:ext cx="7697520" cy="856080"/>
           </a:xfrm>
           <a:prstGeom prst="rect">
             <a:avLst/>
@@ -16503,7 +16517,7 @@
         <p:spPr>
           <a:xfrm>
             <a:off x="333360" y="2514600"/>
-            <a:ext cx="8580600" cy="1493640"/>
+            <a:ext cx="8580240" cy="1493280"/>
           </a:xfrm>
           <a:prstGeom prst="rect">
             <a:avLst/>
@@ -16616,7 +16630,7 @@
         <p:spPr>
           <a:xfrm>
             <a:off x="389880" y="324000"/>
-            <a:ext cx="3026160" cy="710280"/>
+            <a:ext cx="3025800" cy="709920"/>
           </a:xfrm>
           <a:prstGeom prst="rect">
             <a:avLst/>
@@ -16670,7 +16684,7 @@
         <p:spPr>
           <a:xfrm>
             <a:off x="432000" y="756000"/>
-            <a:ext cx="7827120" cy="708480"/>
+            <a:ext cx="7826760" cy="708120"/>
           </a:xfrm>
           <a:prstGeom prst="rect">
             <a:avLst/>
@@ -16724,7 +16738,7 @@
         <p:spPr>
           <a:xfrm>
             <a:off x="4591440" y="1612440"/>
-            <a:ext cx="906120" cy="708480"/>
+            <a:ext cx="905760" cy="708120"/>
           </a:xfrm>
           <a:prstGeom prst="rect">
             <a:avLst/>
@@ -16778,7 +16792,7 @@
         <p:spPr>
           <a:xfrm>
             <a:off x="394200" y="1896120"/>
-            <a:ext cx="8508600" cy="1096920"/>
+            <a:ext cx="8508240" cy="1096560"/>
           </a:xfrm>
           <a:prstGeom prst="rect">
             <a:avLst/>
@@ -16868,7 +16882,7 @@
         <p:spPr>
           <a:xfrm>
             <a:off x="374760" y="3748680"/>
-            <a:ext cx="1851120" cy="708480"/>
+            <a:ext cx="1850760" cy="708120"/>
           </a:xfrm>
           <a:prstGeom prst="rect">
             <a:avLst/>
@@ -16922,7 +16936,7 @@
         <p:spPr>
           <a:xfrm>
             <a:off x="392040" y="3867120"/>
-            <a:ext cx="8100000" cy="1096920"/>
+            <a:ext cx="8099640" cy="1096560"/>
           </a:xfrm>
           <a:prstGeom prst="rect">
             <a:avLst/>
@@ -17025,7 +17039,7 @@
         <p:spPr>
           <a:xfrm>
             <a:off x="367200" y="5429520"/>
-            <a:ext cx="4530240" cy="708480"/>
+            <a:ext cx="4529880" cy="708120"/>
           </a:xfrm>
           <a:prstGeom prst="rect">
             <a:avLst/>
@@ -17089,7 +17103,7 @@
         <p:spPr>
           <a:xfrm>
             <a:off x="381600" y="5041800"/>
-            <a:ext cx="8136000" cy="1059840"/>
+            <a:ext cx="8135640" cy="1059480"/>
           </a:xfrm>
           <a:prstGeom prst="rect">
             <a:avLst/>
@@ -17166,7 +17180,7 @@
         <p:spPr>
           <a:xfrm>
             <a:off x="382680" y="1254240"/>
-            <a:ext cx="6381360" cy="708480"/>
+            <a:ext cx="6381000" cy="708120"/>
           </a:xfrm>
           <a:prstGeom prst="rect">
             <a:avLst/>
@@ -17299,7 +17313,7 @@
         <p:spPr>
           <a:xfrm>
             <a:off x="120600" y="313200"/>
-            <a:ext cx="8634240" cy="1108440"/>
+            <a:ext cx="8633880" cy="1108080"/>
           </a:xfrm>
           <a:prstGeom prst="rect">
             <a:avLst/>
@@ -18282,7 +18296,7 @@
         <p:spPr>
           <a:xfrm>
             <a:off x="0" y="0"/>
-            <a:ext cx="9136080" cy="6837480"/>
+            <a:ext cx="9135720" cy="6837120"/>
           </a:xfrm>
           <a:prstGeom prst="rect">
             <a:avLst/>
@@ -18301,7 +18315,7 @@
         <p:spPr>
           <a:xfrm>
             <a:off x="4573800" y="203040"/>
-            <a:ext cx="3049200" cy="708480"/>
+            <a:ext cx="3048840" cy="708120"/>
           </a:xfrm>
           <a:prstGeom prst="rect">
             <a:avLst/>
@@ -18355,7 +18369,7 @@
         <p:spPr>
           <a:xfrm>
             <a:off x="3956040" y="901800"/>
-            <a:ext cx="1668240" cy="588960"/>
+            <a:ext cx="1667880" cy="588600"/>
           </a:xfrm>
           <a:prstGeom prst="rect">
             <a:avLst/>
@@ -18409,7 +18423,7 @@
         <p:spPr>
           <a:xfrm>
             <a:off x="4280400" y="1498680"/>
-            <a:ext cx="1539720" cy="588960"/>
+            <a:ext cx="1539360" cy="588600"/>
           </a:xfrm>
           <a:prstGeom prst="rect">
             <a:avLst/>
@@ -18463,7 +18477,7 @@
         <p:spPr>
           <a:xfrm>
             <a:off x="4412880" y="2565360"/>
-            <a:ext cx="1885320" cy="588960"/>
+            <a:ext cx="1884960" cy="588600"/>
           </a:xfrm>
           <a:prstGeom prst="rect">
             <a:avLst/>
@@ -18517,7 +18531,7 @@
         <p:spPr>
           <a:xfrm>
             <a:off x="4641480" y="3632040"/>
-            <a:ext cx="1885320" cy="588960"/>
+            <a:ext cx="1884960" cy="588600"/>
           </a:xfrm>
           <a:prstGeom prst="rect">
             <a:avLst/>
@@ -18571,7 +18585,7 @@
         <p:spPr>
           <a:xfrm>
             <a:off x="5636880" y="4699080"/>
-            <a:ext cx="669240" cy="588960"/>
+            <a:ext cx="668880" cy="588600"/>
           </a:xfrm>
           <a:prstGeom prst="rect">
             <a:avLst/>
@@ -18625,7 +18639,7 @@
         <p:spPr>
           <a:xfrm>
             <a:off x="5932080" y="5765760"/>
-            <a:ext cx="307440" cy="588960"/>
+            <a:ext cx="307080" cy="588600"/>
           </a:xfrm>
           <a:prstGeom prst="rect">
             <a:avLst/>
@@ -18679,7 +18693,7 @@
         <p:spPr>
           <a:xfrm>
             <a:off x="7000920" y="1498680"/>
-            <a:ext cx="1877760" cy="588960"/>
+            <a:ext cx="1877400" cy="588600"/>
           </a:xfrm>
           <a:prstGeom prst="rect">
             <a:avLst/>
@@ -18733,7 +18747,7 @@
         <p:spPr>
           <a:xfrm>
             <a:off x="6908400" y="2565360"/>
-            <a:ext cx="2075400" cy="588960"/>
+            <a:ext cx="2075040" cy="588600"/>
           </a:xfrm>
           <a:prstGeom prst="rect">
             <a:avLst/>
@@ -18787,7 +18801,7 @@
         <p:spPr>
           <a:xfrm>
             <a:off x="7141320" y="3632040"/>
-            <a:ext cx="1686240" cy="588960"/>
+            <a:ext cx="1685880" cy="588600"/>
           </a:xfrm>
           <a:prstGeom prst="rect">
             <a:avLst/>
@@ -18841,7 +18855,7 @@
         <p:spPr>
           <a:xfrm>
             <a:off x="7707240" y="4699080"/>
-            <a:ext cx="554400" cy="588960"/>
+            <a:ext cx="554040" cy="588600"/>
           </a:xfrm>
           <a:prstGeom prst="rect">
             <a:avLst/>
@@ -18895,7 +18909,7 @@
         <p:spPr>
           <a:xfrm>
             <a:off x="7455960" y="5765760"/>
-            <a:ext cx="1208520" cy="588960"/>
+            <a:ext cx="1208160" cy="588600"/>
           </a:xfrm>
           <a:prstGeom prst="rect">
             <a:avLst/>
@@ -18949,7 +18963,7 @@
         <p:spPr>
           <a:xfrm>
             <a:off x="5283000" y="5892840"/>
-            <a:ext cx="1021320" cy="580320"/>
+            <a:ext cx="1020960" cy="579960"/>
           </a:xfrm>
           <a:prstGeom prst="rect">
             <a:avLst/>
@@ -19037,7 +19051,7 @@
         <p:spPr>
           <a:xfrm>
             <a:off x="4066200" y="2995200"/>
-            <a:ext cx="5256360" cy="3980160"/>
+            <a:ext cx="5256000" cy="3979800"/>
           </a:xfrm>
           <a:prstGeom prst="rect">
             <a:avLst/>
@@ -19056,7 +19070,7 @@
         <p:spPr>
           <a:xfrm>
             <a:off x="2225880" y="275040"/>
-            <a:ext cx="2840400" cy="708480"/>
+            <a:ext cx="2840040" cy="708120"/>
           </a:xfrm>
           <a:prstGeom prst="rect">
             <a:avLst/>
@@ -19110,7 +19124,7 @@
         <p:spPr>
           <a:xfrm>
             <a:off x="0" y="450720"/>
-            <a:ext cx="9142560" cy="3133440"/>
+            <a:ext cx="9142200" cy="3133080"/>
           </a:xfrm>
           <a:prstGeom prst="rect">
             <a:avLst/>
@@ -19524,7 +19538,7 @@
         <p:spPr>
           <a:xfrm>
             <a:off x="65520" y="75600"/>
-            <a:ext cx="9161640" cy="2136960"/>
+            <a:ext cx="9161280" cy="2136600"/>
           </a:xfrm>
           <a:prstGeom prst="rect">
             <a:avLst/>
@@ -19760,7 +19774,7 @@
         <p:spPr>
           <a:xfrm>
             <a:off x="2286000" y="1828800"/>
-            <a:ext cx="5103720" cy="4654800"/>
+            <a:ext cx="5103360" cy="4654440"/>
           </a:xfrm>
           <a:prstGeom prst="rect">
             <a:avLst/>
@@ -19809,7 +19823,7 @@
         <p:spPr>
           <a:xfrm>
             <a:off x="228600" y="457200"/>
-            <a:ext cx="6856560" cy="600840"/>
+            <a:ext cx="6856200" cy="600480"/>
           </a:xfrm>
           <a:prstGeom prst="rect">
             <a:avLst/>
@@ -19867,7 +19881,7 @@
         <p:spPr>
           <a:xfrm>
             <a:off x="460800" y="1143000"/>
-            <a:ext cx="7995960" cy="4629960"/>
+            <a:ext cx="7995600" cy="4629600"/>
           </a:xfrm>
           <a:prstGeom prst="rect">
             <a:avLst/>
@@ -19920,7 +19934,7 @@
         <p:spPr>
           <a:xfrm>
             <a:off x="0" y="0"/>
-            <a:ext cx="9136080" cy="6837480"/>
+            <a:ext cx="9135720" cy="6837120"/>
           </a:xfrm>
           <a:prstGeom prst="rect">
             <a:avLst/>
@@ -19939,7 +19953,7 @@
         <p:spPr>
           <a:xfrm>
             <a:off x="2285640" y="658440"/>
-            <a:ext cx="5022000" cy="708480"/>
+            <a:ext cx="5021640" cy="708120"/>
           </a:xfrm>
           <a:prstGeom prst="rect">
             <a:avLst/>
@@ -19993,7 +20007,7 @@
         <p:spPr>
           <a:xfrm>
             <a:off x="1398600" y="1384200"/>
-            <a:ext cx="7012080" cy="708480"/>
+            <a:ext cx="7011720" cy="708120"/>
           </a:xfrm>
           <a:prstGeom prst="rect">
             <a:avLst/>
@@ -20047,7 +20061,7 @@
         <p:spPr>
           <a:xfrm>
             <a:off x="3040920" y="2034360"/>
-            <a:ext cx="2143080" cy="708480"/>
+            <a:ext cx="2142720" cy="708120"/>
           </a:xfrm>
           <a:prstGeom prst="rect">
             <a:avLst/>
@@ -20111,7 +20125,7 @@
         <p:spPr>
           <a:xfrm>
             <a:off x="3005280" y="2601360"/>
-            <a:ext cx="2430360" cy="708480"/>
+            <a:ext cx="2430000" cy="708120"/>
           </a:xfrm>
           <a:prstGeom prst="rect">
             <a:avLst/>
@@ -20175,7 +20189,7 @@
         <p:spPr>
           <a:xfrm>
             <a:off x="3029760" y="3168720"/>
-            <a:ext cx="2237400" cy="708480"/>
+            <a:ext cx="2237040" cy="708120"/>
           </a:xfrm>
           <a:prstGeom prst="rect">
             <a:avLst/>
@@ -20239,7 +20253,7 @@
         <p:spPr>
           <a:xfrm>
             <a:off x="2969640" y="3664080"/>
-            <a:ext cx="2573640" cy="708480"/>
+            <a:ext cx="2573280" cy="708120"/>
           </a:xfrm>
           <a:prstGeom prst="rect">
             <a:avLst/>
@@ -20333,7 +20347,7 @@
         <p:spPr>
           <a:xfrm>
             <a:off x="0" y="457200"/>
-            <a:ext cx="8913960" cy="3672360"/>
+            <a:ext cx="8913600" cy="3672000"/>
           </a:xfrm>
           <a:prstGeom prst="rect">
             <a:avLst/>
@@ -20843,7 +20857,7 @@
         <p:spPr>
           <a:xfrm>
             <a:off x="38520" y="73800"/>
-            <a:ext cx="2102040" cy="600840"/>
+            <a:ext cx="2101680" cy="600480"/>
           </a:xfrm>
           <a:prstGeom prst="rect">
             <a:avLst/>
@@ -20927,7 +20941,7 @@
         <p:spPr>
           <a:xfrm>
             <a:off x="228600" y="228600"/>
-            <a:ext cx="5713560" cy="600840"/>
+            <a:ext cx="5713200" cy="600480"/>
           </a:xfrm>
           <a:prstGeom prst="rect">
             <a:avLst/>
@@ -20985,7 +20999,7 @@
         <p:spPr>
           <a:xfrm>
             <a:off x="685800" y="1600200"/>
-            <a:ext cx="7927920" cy="3875760"/>
+            <a:ext cx="7927560" cy="3875400"/>
           </a:xfrm>
           <a:prstGeom prst="rect">
             <a:avLst/>
@@ -21038,7 +21052,7 @@
         <p:spPr>
           <a:xfrm>
             <a:off x="20880" y="727920"/>
-            <a:ext cx="9136440" cy="5414040"/>
+            <a:ext cx="9136080" cy="5413680"/>
           </a:xfrm>
           <a:prstGeom prst="rect">
             <a:avLst/>
@@ -21087,7 +21101,7 @@
         <p:spPr>
           <a:xfrm>
             <a:off x="72000" y="144000"/>
-            <a:ext cx="8994240" cy="4179960"/>
+            <a:ext cx="8993880" cy="4179600"/>
           </a:xfrm>
           <a:prstGeom prst="rect">
             <a:avLst/>
@@ -21493,7 +21507,7 @@
         <p:spPr>
           <a:xfrm>
             <a:off x="-90720" y="94680"/>
-            <a:ext cx="9083520" cy="6226200"/>
+            <a:ext cx="9083160" cy="6225840"/>
           </a:xfrm>
           <a:prstGeom prst="rect">
             <a:avLst/>
@@ -21913,7 +21927,7 @@
         <p:spPr>
           <a:xfrm>
             <a:off x="145080" y="72000"/>
-            <a:ext cx="8992800" cy="6226200"/>
+            <a:ext cx="8992440" cy="6225840"/>
           </a:xfrm>
           <a:prstGeom prst="rect">
             <a:avLst/>
@@ -22308,7 +22322,7 @@
       </p:grpSpPr>
       <p:pic>
         <p:nvPicPr>
-          <p:cNvPr id="215" name="Picture 1" descr=""/>
+          <p:cNvPr id="215" name="" descr=""/>
           <p:cNvPicPr/>
           <p:nvPr/>
         </p:nvPicPr>
@@ -22318,8 +22332,8 @@
         </p:blipFill>
         <p:spPr>
           <a:xfrm>
-            <a:off x="0" y="0"/>
-            <a:ext cx="9136080" cy="6837480"/>
+            <a:off x="2860200" y="51840"/>
+            <a:ext cx="5715000" cy="6666120"/>
           </a:xfrm>
           <a:prstGeom prst="rect">
             <a:avLst/>
@@ -22331,14 +22345,14 @@
       </p:pic>
       <p:sp>
         <p:nvSpPr>
-          <p:cNvPr id="216" name="CustomShape 1"/>
-          <p:cNvSpPr/>
+          <p:cNvPr id="216" name=""/>
+          <p:cNvSpPr txBox="1"/>
           <p:nvPr/>
         </p:nvSpPr>
         <p:spPr>
           <a:xfrm>
-            <a:off x="4369680" y="254160"/>
-            <a:ext cx="828360" cy="708480"/>
+            <a:off x="228600" y="228600"/>
+            <a:ext cx="2286000" cy="685800"/>
           </a:xfrm>
           <a:prstGeom prst="rect">
             <a:avLst/>
@@ -22348,344 +22362,21 @@
             <a:noFill/>
           </a:ln>
         </p:spPr>
-        <p:style>
-          <a:lnRef idx="0"/>
-          <a:fillRef idx="0"/>
-          <a:effectRef idx="0"/>
-          <a:fontRef idx="minor"/>
-        </p:style>
-        <p:txBody>
-          <a:bodyPr wrap="none" lIns="0" rIns="0" tIns="0" bIns="0" anchor="t">
-            <a:noAutofit/>
-          </a:bodyPr>
-          <a:p>
-            <a:pPr>
-              <a:lnSpc>
-                <a:spcPts val="975"/>
-              </a:lnSpc>
-            </a:pPr>
-            <a:r>
-              <a:rPr b="1" lang="en-US" sz="2240" spc="-1" strike="noStrike">
-                <a:solidFill>
-                  <a:srgbClr val="000000"/>
-                </a:solidFill>
-                <a:latin typeface="Arial Bold"/>
-                <a:ea typeface="DejaVu Sans"/>
-              </a:rPr>
-              <a:t>GRUB</a:t>
-            </a:r>
-            <a:endParaRPr b="0" lang="en-US" sz="2240" spc="-1" strike="noStrike">
-              <a:solidFill>
-                <a:srgbClr val="000000"/>
-              </a:solidFill>
-              <a:latin typeface="Arial"/>
-            </a:endParaRPr>
-          </a:p>
-        </p:txBody>
-      </p:sp>
-      <p:sp>
-        <p:nvSpPr>
-          <p:cNvPr id="217" name=""/>
-          <p:cNvSpPr/>
-          <p:nvPr/>
-        </p:nvSpPr>
-        <p:spPr>
-          <a:xfrm>
-            <a:off x="130320" y="457200"/>
-            <a:ext cx="8555040" cy="3672720"/>
-          </a:xfrm>
-          <a:prstGeom prst="rect">
-            <a:avLst/>
-          </a:prstGeom>
-          <a:noFill/>
-          <a:ln w="0">
-            <a:noFill/>
-          </a:ln>
-        </p:spPr>
-        <p:style>
-          <a:lnRef idx="0"/>
-          <a:fillRef idx="0"/>
-          <a:effectRef idx="0"/>
-          <a:fontRef idx="minor"/>
-        </p:style>
         <p:txBody>
           <a:bodyPr lIns="90000" rIns="90000" tIns="45000" bIns="45000" anchor="t">
             <a:noAutofit/>
           </a:bodyPr>
           <a:p>
-            <a:pPr>
-              <a:lnSpc>
-                <a:spcPct val="100000"/>
-              </a:lnSpc>
-            </a:pPr>
-            <a:r>
-              <a:rPr b="0" lang="en-US" sz="1800" spc="-1" strike="noStrike">
-                <a:solidFill>
-                  <a:srgbClr val="000000"/>
-                </a:solidFill>
-                <a:latin typeface="Arial"/>
-                <a:ea typeface="DejaVu Sans"/>
-              </a:rPr>
-              <a:t>Grand Unified Bootloader, from the GNU project</a:t>
-            </a:r>
-            <a:br>
-              <a:rPr sz="1800"/>
-            </a:br>
-            <a:endParaRPr b="0" lang="en-US" sz="1800" spc="-1" strike="noStrike">
-              <a:solidFill>
-                <a:srgbClr val="000000"/>
-              </a:solidFill>
-              <a:latin typeface="Arial"/>
-            </a:endParaRPr>
-          </a:p>
-          <a:p>
-            <a:pPr>
-              <a:lnSpc>
-                <a:spcPct val="100000"/>
-              </a:lnSpc>
-            </a:pPr>
-            <a:r>
-              <a:rPr b="0" lang="en-US" sz="1800" spc="-1" strike="noStrike">
-                <a:solidFill>
-                  <a:srgbClr val="000000"/>
-                </a:solidFill>
-                <a:latin typeface="Arial"/>
-                <a:ea typeface="DejaVu Sans"/>
-              </a:rPr>
-              <a:t>▶ </a:t>
-            </a:r>
-            <a:r>
-              <a:rPr b="0" lang="en-US" sz="1800" spc="-1" strike="noStrike">
-                <a:solidFill>
-                  <a:srgbClr val="000000"/>
-                </a:solidFill>
-                <a:latin typeface="Arial"/>
-                <a:ea typeface="DejaVu Sans"/>
-              </a:rPr>
-              <a:t>De-facto standard in most Linux distributions for x86 platforms</a:t>
-            </a:r>
-            <a:endParaRPr b="0" lang="en-US" sz="1800" spc="-1" strike="noStrike">
-              <a:solidFill>
-                <a:srgbClr val="000000"/>
-              </a:solidFill>
-              <a:latin typeface="Arial"/>
-            </a:endParaRPr>
-          </a:p>
-          <a:p>
-            <a:pPr>
-              <a:lnSpc>
-                <a:spcPct val="100000"/>
-              </a:lnSpc>
-            </a:pPr>
-            <a:r>
-              <a:rPr b="0" lang="en-US" sz="1800" spc="-1" strike="noStrike">
-                <a:solidFill>
-                  <a:srgbClr val="000000"/>
-                </a:solidFill>
-                <a:latin typeface="Arial"/>
-                <a:ea typeface="DejaVu Sans"/>
-              </a:rPr>
-              <a:t>▶ </a:t>
-            </a:r>
-            <a:r>
-              <a:rPr b="0" lang="en-US" sz="1800" spc="-1" strike="noStrike">
-                <a:solidFill>
-                  <a:srgbClr val="000000"/>
-                </a:solidFill>
-                <a:latin typeface="Arial"/>
-                <a:ea typeface="DejaVu Sans"/>
-              </a:rPr>
-              <a:t>Supports x86 legacy and UEFI systems</a:t>
-            </a:r>
-            <a:endParaRPr b="0" lang="en-US" sz="1800" spc="-1" strike="noStrike">
-              <a:solidFill>
-                <a:srgbClr val="000000"/>
-              </a:solidFill>
-              <a:latin typeface="Arial"/>
-            </a:endParaRPr>
-          </a:p>
-          <a:p>
-            <a:pPr>
-              <a:lnSpc>
-                <a:spcPct val="100000"/>
-              </a:lnSpc>
-            </a:pPr>
-            <a:r>
-              <a:rPr b="0" lang="en-US" sz="1800" spc="-1" strike="noStrike">
-                <a:solidFill>
-                  <a:srgbClr val="000000"/>
-                </a:solidFill>
-                <a:latin typeface="Arial"/>
-                <a:ea typeface="DejaVu Sans"/>
-              </a:rPr>
-              <a:t>▶ </a:t>
-            </a:r>
-            <a:r>
-              <a:rPr b="0" lang="en-US" sz="1800" spc="-1" strike="noStrike">
-                <a:solidFill>
-                  <a:srgbClr val="000000"/>
-                </a:solidFill>
-                <a:latin typeface="Arial"/>
-                <a:ea typeface="DejaVu Sans"/>
-              </a:rPr>
-              <a:t>Can read many filesystem formats to load the kernel image, modules and configuration</a:t>
-            </a:r>
-            <a:endParaRPr b="0" lang="en-US" sz="1800" spc="-1" strike="noStrike">
-              <a:solidFill>
-                <a:srgbClr val="000000"/>
-              </a:solidFill>
-              <a:latin typeface="Arial"/>
-            </a:endParaRPr>
-          </a:p>
-          <a:p>
-            <a:pPr>
-              <a:lnSpc>
-                <a:spcPct val="100000"/>
-              </a:lnSpc>
-            </a:pPr>
-            <a:r>
-              <a:rPr b="0" lang="en-US" sz="1800" spc="-1" strike="noStrike">
-                <a:solidFill>
-                  <a:srgbClr val="000000"/>
-                </a:solidFill>
-                <a:latin typeface="Arial"/>
-                <a:ea typeface="DejaVu Sans"/>
-              </a:rPr>
-              <a:t>▶ </a:t>
-            </a:r>
-            <a:r>
-              <a:rPr b="0" lang="en-US" sz="1800" spc="-1" strike="noStrike">
-                <a:solidFill>
-                  <a:srgbClr val="000000"/>
-                </a:solidFill>
-                <a:latin typeface="Arial"/>
-                <a:ea typeface="DejaVu Sans"/>
-              </a:rPr>
-              <a:t>Provides a menu and powerful shell with various commands</a:t>
-            </a:r>
-            <a:endParaRPr b="0" lang="en-US" sz="1800" spc="-1" strike="noStrike">
-              <a:solidFill>
-                <a:srgbClr val="000000"/>
-              </a:solidFill>
-              <a:latin typeface="Arial"/>
-            </a:endParaRPr>
-          </a:p>
-          <a:p>
-            <a:pPr>
-              <a:lnSpc>
-                <a:spcPct val="100000"/>
-              </a:lnSpc>
-            </a:pPr>
-            <a:r>
-              <a:rPr b="0" lang="en-US" sz="1800" spc="-1" strike="noStrike">
-                <a:solidFill>
-                  <a:srgbClr val="000000"/>
-                </a:solidFill>
-                <a:latin typeface="Arial"/>
-                <a:ea typeface="DejaVu Sans"/>
-              </a:rPr>
-              <a:t>▶ </a:t>
-            </a:r>
-            <a:r>
-              <a:rPr b="0" lang="en-US" sz="1800" spc="-1" strike="noStrike">
-                <a:solidFill>
-                  <a:srgbClr val="000000"/>
-                </a:solidFill>
-                <a:latin typeface="Arial"/>
-                <a:ea typeface="DejaVu Sans"/>
-              </a:rPr>
-              <a:t>Can load kernel images over the network</a:t>
-            </a:r>
-            <a:endParaRPr b="0" lang="en-US" sz="1800" spc="-1" strike="noStrike">
-              <a:solidFill>
-                <a:srgbClr val="000000"/>
-              </a:solidFill>
-              <a:latin typeface="Arial"/>
-            </a:endParaRPr>
-          </a:p>
-          <a:p>
-            <a:pPr>
-              <a:lnSpc>
-                <a:spcPct val="100000"/>
-              </a:lnSpc>
-            </a:pPr>
-            <a:r>
-              <a:rPr b="0" lang="en-US" sz="1800" spc="-1" strike="noStrike">
-                <a:solidFill>
-                  <a:srgbClr val="000000"/>
-                </a:solidFill>
-                <a:latin typeface="Arial"/>
-                <a:ea typeface="DejaVu Sans"/>
-              </a:rPr>
-              <a:t>▶ </a:t>
-            </a:r>
-            <a:r>
-              <a:rPr b="0" lang="en-US" sz="1800" spc="-1" strike="noStrike">
-                <a:solidFill>
-                  <a:srgbClr val="000000"/>
-                </a:solidFill>
-                <a:latin typeface="Arial"/>
-                <a:ea typeface="DejaVu Sans"/>
-              </a:rPr>
-              <a:t>Also supports ARM, ARM64, RISC-V, PowerPC, but less popular than other</a:t>
-            </a:r>
-            <a:endParaRPr b="0" lang="en-US" sz="1800" spc="-1" strike="noStrike">
-              <a:solidFill>
-                <a:srgbClr val="000000"/>
-              </a:solidFill>
-              <a:latin typeface="Arial"/>
-            </a:endParaRPr>
-          </a:p>
-          <a:p>
-            <a:pPr>
-              <a:lnSpc>
-                <a:spcPct val="100000"/>
-              </a:lnSpc>
-            </a:pPr>
-            <a:r>
-              <a:rPr b="0" lang="en-US" sz="1800" spc="-1" strike="noStrike">
-                <a:solidFill>
-                  <a:srgbClr val="000000"/>
-                </a:solidFill>
-                <a:latin typeface="Arial"/>
-                <a:ea typeface="DejaVu Sans"/>
-              </a:rPr>
-              <a:t>bootloaders on those platforms</a:t>
-            </a:r>
-            <a:endParaRPr b="0" lang="en-US" sz="1800" spc="-1" strike="noStrike">
-              <a:solidFill>
-                <a:srgbClr val="000000"/>
-              </a:solidFill>
-              <a:latin typeface="Arial"/>
-            </a:endParaRPr>
-          </a:p>
-          <a:p>
-            <a:pPr>
-              <a:lnSpc>
-                <a:spcPct val="100000"/>
-              </a:lnSpc>
-            </a:pPr>
-            <a:r>
-              <a:rPr b="0" lang="en-US" sz="1800" spc="-1" strike="noStrike">
-                <a:solidFill>
-                  <a:srgbClr val="000000"/>
-                </a:solidFill>
-                <a:latin typeface="Arial"/>
-                <a:ea typeface="DejaVu Sans"/>
-              </a:rPr>
-              <a:t>▶ </a:t>
-            </a:r>
-            <a:r>
-              <a:rPr b="0" lang="en-US" sz="1800" spc="-1" strike="noStrike">
-                <a:solidFill>
-                  <a:srgbClr val="000000"/>
-                </a:solidFill>
-                <a:latin typeface="Arial"/>
-                <a:ea typeface="DejaVu Sans"/>
-              </a:rPr>
-              <a:t>https://www.gnu.org/software/grub/</a:t>
-            </a:r>
-            <a:endParaRPr b="0" lang="en-US" sz="1800" spc="-1" strike="noStrike">
+            <a:r>
+              <a:rPr b="1" lang="en-US" sz="1800" spc="-1" strike="noStrike">
+                <a:solidFill>
+                  <a:srgbClr val="000000"/>
+                </a:solidFill>
+                <a:latin typeface="Arial"/>
+              </a:rPr>
+              <a:t>X86 Boot Process</a:t>
+            </a:r>
+            <a:endParaRPr b="1" lang="en-US" sz="1800" spc="-1" strike="noStrike">
               <a:solidFill>
                 <a:srgbClr val="000000"/>
               </a:solidFill>
@@ -22694,29 +22385,6 @@
           </a:p>
         </p:txBody>
       </p:sp>
-      <p:pic>
-        <p:nvPicPr>
-          <p:cNvPr id="218" name="" descr=""/>
-          <p:cNvPicPr/>
-          <p:nvPr/>
-        </p:nvPicPr>
-        <p:blipFill>
-          <a:blip r:embed="rId2"/>
-          <a:stretch/>
-        </p:blipFill>
-        <p:spPr>
-          <a:xfrm>
-            <a:off x="1600200" y="3429000"/>
-            <a:ext cx="6170760" cy="3256560"/>
-          </a:xfrm>
-          <a:prstGeom prst="rect">
-            <a:avLst/>
-          </a:prstGeom>
-          <a:ln w="0">
-            <a:noFill/>
-          </a:ln>
-        </p:spPr>
-      </p:pic>
     </p:spTree>
   </p:cSld>
   <mc:AlternateContent>
@@ -22749,7 +22417,7 @@
       </p:grpSpPr>
       <p:pic>
         <p:nvPicPr>
-          <p:cNvPr id="219" name="Picture 1" descr=""/>
+          <p:cNvPr id="217" name="Picture 1" descr=""/>
           <p:cNvPicPr/>
           <p:nvPr/>
         </p:nvPicPr>
@@ -22760,7 +22428,7 @@
         <p:spPr>
           <a:xfrm>
             <a:off x="0" y="0"/>
-            <a:ext cx="9136080" cy="6837480"/>
+            <a:ext cx="9135720" cy="6837120"/>
           </a:xfrm>
           <a:prstGeom prst="rect">
             <a:avLst/>
@@ -22772,14 +22440,14 @@
       </p:pic>
       <p:sp>
         <p:nvSpPr>
-          <p:cNvPr id="220" name="CustomShape 1"/>
+          <p:cNvPr id="218" name="CustomShape 1"/>
           <p:cNvSpPr/>
           <p:nvPr/>
         </p:nvSpPr>
         <p:spPr>
           <a:xfrm>
-            <a:off x="3277800" y="431640"/>
-            <a:ext cx="2961360" cy="708480"/>
+            <a:off x="4369680" y="254160"/>
+            <a:ext cx="828000" cy="708120"/>
           </a:xfrm>
           <a:prstGeom prst="rect">
             <a:avLst/>
@@ -22813,7 +22481,7 @@
                 <a:latin typeface="Arial Bold"/>
                 <a:ea typeface="DejaVu Sans"/>
               </a:rPr>
-              <a:t>Initialization Overview</a:t>
+              <a:t>GRUB</a:t>
             </a:r>
             <a:endParaRPr b="0" lang="en-US" sz="2240" spc="-1" strike="noStrike">
               <a:solidFill>
@@ -22826,14 +22494,14 @@
       </p:sp>
       <p:sp>
         <p:nvSpPr>
-          <p:cNvPr id="221" name="CustomShape 2"/>
+          <p:cNvPr id="219" name=""/>
           <p:cNvSpPr/>
           <p:nvPr/>
         </p:nvSpPr>
         <p:spPr>
           <a:xfrm>
-            <a:off x="253080" y="651600"/>
-            <a:ext cx="8506800" cy="1443240"/>
+            <a:off x="130320" y="457200"/>
+            <a:ext cx="8554680" cy="3672360"/>
           </a:xfrm>
           <a:prstGeom prst="rect">
             <a:avLst/>
@@ -22850,7 +22518,7 @@
           <a:fontRef idx="minor"/>
         </p:style>
         <p:txBody>
-          <a:bodyPr wrap="none" lIns="0" rIns="0" tIns="0" bIns="0" anchor="t">
+          <a:bodyPr lIns="90000" rIns="90000" tIns="45000" bIns="45000" anchor="t">
             <a:noAutofit/>
           </a:bodyPr>
           <a:p>
@@ -22860,16 +22528,19 @@
               </a:lnSpc>
             </a:pPr>
             <a:r>
-              <a:rPr b="0" lang="en-US" sz="2230" spc="-1" strike="noStrike">
-                <a:solidFill>
-                  <a:srgbClr val="000000"/>
-                </a:solidFill>
-                <a:latin typeface="Arial"/>
-                <a:ea typeface="DejaVu Sans"/>
-              </a:rPr>
-              <a:t>When the operating system starts, the kernel runs /sbin/init. This can</a:t>
-            </a:r>
-            <a:endParaRPr b="0" lang="en-US" sz="2230" spc="-1" strike="noStrike">
+              <a:rPr b="0" lang="en-US" sz="1800" spc="-1" strike="noStrike">
+                <a:solidFill>
+                  <a:srgbClr val="000000"/>
+                </a:solidFill>
+                <a:latin typeface="Arial"/>
+                <a:ea typeface="DejaVu Sans"/>
+              </a:rPr>
+              <a:t>Grand Unified Bootloader, from the GNU project</a:t>
+            </a:r>
+            <a:br>
+              <a:rPr sz="1800"/>
+            </a:br>
+            <a:endParaRPr b="0" lang="en-US" sz="1800" spc="-1" strike="noStrike">
               <a:solidFill>
                 <a:srgbClr val="000000"/>
               </a:solidFill>
@@ -22883,89 +22554,32 @@
               </a:lnSpc>
             </a:pPr>
             <a:r>
-              <a:rPr b="0" lang="en-US" sz="2230" spc="-1" strike="noStrike">
-                <a:solidFill>
-                  <a:srgbClr val="000000"/>
-                </a:solidFill>
-                <a:latin typeface="Arial"/>
-                <a:ea typeface="DejaVu Sans"/>
-              </a:rPr>
-              <a:t>be either a script or a program, but typically it is a program that</a:t>
-            </a:r>
-            <a:endParaRPr b="0" lang="en-US" sz="2230" spc="-1" strike="noStrike">
-              <a:solidFill>
-                <a:srgbClr val="000000"/>
-              </a:solidFill>
-              <a:latin typeface="Arial"/>
-            </a:endParaRPr>
-          </a:p>
-          <a:p>
-            <a:pPr>
-              <a:lnSpc>
-                <a:spcPts val="1006"/>
-              </a:lnSpc>
-            </a:pPr>
-            <a:endParaRPr b="0" lang="en-US" sz="2230" spc="-1" strike="noStrike">
-              <a:solidFill>
-                <a:srgbClr val="000000"/>
-              </a:solidFill>
-              <a:latin typeface="Arial"/>
-            </a:endParaRPr>
-          </a:p>
-          <a:p>
-            <a:pPr>
-              <a:lnSpc>
-                <a:spcPts val="1006"/>
-              </a:lnSpc>
-            </a:pPr>
-            <a:r>
-              <a:rPr b="0" lang="en-US" sz="2230" spc="-1" strike="noStrike">
-                <a:solidFill>
-                  <a:srgbClr val="000000"/>
-                </a:solidFill>
-                <a:latin typeface="Arial"/>
-                <a:ea typeface="DejaVu Sans"/>
-              </a:rPr>
-              <a:t>processes the statements in /etc/initab.</a:t>
-            </a:r>
-            <a:endParaRPr b="0" lang="en-US" sz="2230" spc="-1" strike="noStrike">
-              <a:solidFill>
-                <a:srgbClr val="000000"/>
-              </a:solidFill>
-              <a:latin typeface="Arial"/>
-            </a:endParaRPr>
-          </a:p>
-        </p:txBody>
-      </p:sp>
-      <p:sp>
-        <p:nvSpPr>
-          <p:cNvPr id="222" name="CustomShape 3"/>
-          <p:cNvSpPr/>
-          <p:nvPr/>
-        </p:nvSpPr>
-        <p:spPr>
-          <a:xfrm>
-            <a:off x="274320" y="1698480"/>
-            <a:ext cx="8604360" cy="1465200"/>
-          </a:xfrm>
-          <a:prstGeom prst="rect">
-            <a:avLst/>
-          </a:prstGeom>
-          <a:noFill/>
-          <a:ln w="0">
-            <a:noFill/>
-          </a:ln>
-        </p:spPr>
-        <p:style>
-          <a:lnRef idx="0"/>
-          <a:fillRef idx="0"/>
-          <a:effectRef idx="0"/>
-          <a:fontRef idx="minor"/>
-        </p:style>
-        <p:txBody>
-          <a:bodyPr wrap="none" lIns="0" rIns="0" tIns="0" bIns="0" anchor="t">
-            <a:noAutofit/>
-          </a:bodyPr>
+              <a:rPr b="0" lang="en-US" sz="1800" spc="-1" strike="noStrike">
+                <a:solidFill>
+                  <a:srgbClr val="000000"/>
+                </a:solidFill>
+                <a:latin typeface="Arial"/>
+                <a:ea typeface="DejaVu Sans"/>
+              </a:rPr>
+              <a:t>▶ </a:t>
+            </a:r>
+            <a:r>
+              <a:rPr b="0" lang="en-US" sz="1800" spc="-1" strike="noStrike">
+                <a:solidFill>
+                  <a:srgbClr val="000000"/>
+                </a:solidFill>
+                <a:latin typeface="Arial"/>
+                <a:ea typeface="DejaVu Sans"/>
+              </a:rPr>
+              <a:t>De-facto standard in most Linux distributions for x86 platforms</a:t>
+            </a:r>
+            <a:endParaRPr b="0" lang="en-US" sz="1800" spc="-1" strike="noStrike">
+              <a:solidFill>
+                <a:srgbClr val="000000"/>
+              </a:solidFill>
+              <a:latin typeface="Arial"/>
+            </a:endParaRPr>
+          </a:p>
           <a:p>
             <a:pPr>
               <a:lnSpc>
@@ -22973,16 +22587,26 @@
               </a:lnSpc>
             </a:pPr>
             <a:r>
-              <a:rPr b="0" lang="en-US" sz="2230" spc="-1" strike="noStrike">
-                <a:solidFill>
-                  <a:srgbClr val="000000"/>
-                </a:solidFill>
-                <a:latin typeface="Arial"/>
-                <a:ea typeface="DejaVu Sans"/>
-              </a:rPr>
-              <a:t>The default inittab file tells init to run the commands in the file</a:t>
-            </a:r>
-            <a:endParaRPr b="0" lang="en-US" sz="2230" spc="-1" strike="noStrike">
+              <a:rPr b="0" lang="en-US" sz="1800" spc="-1" strike="noStrike">
+                <a:solidFill>
+                  <a:srgbClr val="000000"/>
+                </a:solidFill>
+                <a:latin typeface="Arial"/>
+                <a:ea typeface="DejaVu Sans"/>
+              </a:rPr>
+              <a:t>▶ </a:t>
+            </a:r>
+            <a:r>
+              <a:rPr b="0" lang="en-US" sz="1800" spc="-1" strike="noStrike">
+                <a:solidFill>
+                  <a:srgbClr val="000000"/>
+                </a:solidFill>
+                <a:latin typeface="Arial"/>
+                <a:ea typeface="DejaVu Sans"/>
+              </a:rPr>
+              <a:t>Supports x86 legacy and UEFI systems</a:t>
+            </a:r>
+            <a:endParaRPr b="0" lang="en-US" sz="1800" spc="-1" strike="noStrike">
               <a:solidFill>
                 <a:srgbClr val="000000"/>
               </a:solidFill>
@@ -22996,165 +22620,181 @@
               </a:lnSpc>
             </a:pPr>
             <a:r>
-              <a:rPr b="0" lang="en-US" sz="2230" spc="-1" strike="noStrike">
-                <a:solidFill>
-                  <a:srgbClr val="000000"/>
-                </a:solidFill>
-                <a:latin typeface="Arial"/>
-                <a:ea typeface="DejaVu Sans"/>
-              </a:rPr>
-              <a:t>/etc/rc.d/rcS. In addition, init spawns programs to present login</a:t>
-            </a:r>
-            <a:endParaRPr b="0" lang="en-US" sz="2230" spc="-1" strike="noStrike">
-              <a:solidFill>
-                <a:srgbClr val="000000"/>
-              </a:solidFill>
-              <a:latin typeface="Arial"/>
-            </a:endParaRPr>
-          </a:p>
-          <a:p>
-            <a:pPr>
-              <a:lnSpc>
-                <a:spcPts val="1023"/>
-              </a:lnSpc>
-            </a:pPr>
-            <a:endParaRPr b="0" lang="en-US" sz="2230" spc="-1" strike="noStrike">
-              <a:solidFill>
-                <a:srgbClr val="000000"/>
-              </a:solidFill>
-              <a:latin typeface="Arial"/>
-            </a:endParaRPr>
-          </a:p>
-          <a:p>
-            <a:pPr>
-              <a:lnSpc>
-                <a:spcPts val="1023"/>
-              </a:lnSpc>
-            </a:pPr>
-            <a:endParaRPr b="0" lang="en-US" sz="2230" spc="-1" strike="noStrike">
-              <a:solidFill>
-                <a:srgbClr val="000000"/>
-              </a:solidFill>
-              <a:latin typeface="Arial"/>
-            </a:endParaRPr>
-          </a:p>
-          <a:p>
-            <a:pPr>
-              <a:lnSpc>
-                <a:spcPts val="1023"/>
-              </a:lnSpc>
-            </a:pPr>
-            <a:r>
-              <a:rPr b="0" lang="en-US" sz="2230" spc="-1" strike="noStrike">
-                <a:solidFill>
-                  <a:srgbClr val="000000"/>
-                </a:solidFill>
-                <a:latin typeface="Arial"/>
-                <a:ea typeface="DejaVu Sans"/>
-              </a:rPr>
-              <a:t>prompts on two virtual terminals.</a:t>
-            </a:r>
-            <a:endParaRPr b="0" lang="en-US" sz="2230" spc="-1" strike="noStrike">
-              <a:solidFill>
-                <a:srgbClr val="000000"/>
-              </a:solidFill>
-              <a:latin typeface="Arial"/>
-            </a:endParaRPr>
-          </a:p>
-          <a:p>
-            <a:pPr>
-              <a:lnSpc>
-                <a:spcPts val="1023"/>
-              </a:lnSpc>
-            </a:pPr>
-            <a:endParaRPr b="0" lang="en-US" sz="2230" spc="-1" strike="noStrike">
-              <a:solidFill>
-                <a:srgbClr val="000000"/>
-              </a:solidFill>
-              <a:latin typeface="Arial"/>
-            </a:endParaRPr>
-          </a:p>
-          <a:p>
-            <a:pPr>
-              <a:lnSpc>
-                <a:spcPts val="1023"/>
-              </a:lnSpc>
-            </a:pPr>
-            <a:endParaRPr b="0" lang="en-US" sz="2230" spc="-1" strike="noStrike">
-              <a:solidFill>
-                <a:srgbClr val="000000"/>
-              </a:solidFill>
-              <a:latin typeface="Arial"/>
-            </a:endParaRPr>
-          </a:p>
-          <a:p>
-            <a:pPr>
-              <a:lnSpc>
-                <a:spcPts val="1023"/>
-              </a:lnSpc>
-            </a:pPr>
-            <a:endParaRPr b="0" lang="en-US" sz="2230" spc="-1" strike="noStrike">
-              <a:solidFill>
-                <a:srgbClr val="000000"/>
-              </a:solidFill>
-              <a:latin typeface="Arial"/>
-            </a:endParaRPr>
-          </a:p>
-          <a:p>
-            <a:pPr>
-              <a:lnSpc>
-                <a:spcPts val="1023"/>
-              </a:lnSpc>
-              <a:spcBef>
-                <a:spcPts val="1191"/>
-              </a:spcBef>
-              <a:spcAft>
-                <a:spcPts val="992"/>
-              </a:spcAft>
-            </a:pPr>
-            <a:r>
-              <a:rPr b="0" lang="en-IN" sz="2230" spc="-1" strike="noStrike">
-                <a:solidFill>
-                  <a:srgbClr val="000000"/>
-                </a:solidFill>
-                <a:latin typeface="Arial"/>
-                <a:ea typeface="DejaVu Sans"/>
-              </a:rPr>
-              <a:t>In Ubuntu: systemd is in use, but /etc/rc0.d still exists for</a:t>
-            </a:r>
-            <a:endParaRPr b="0" lang="en-US" sz="2230" spc="-1" strike="noStrike">
-              <a:solidFill>
-                <a:srgbClr val="000000"/>
-              </a:solidFill>
-              <a:latin typeface="Arial"/>
-            </a:endParaRPr>
-          </a:p>
-          <a:p>
-            <a:pPr>
-              <a:lnSpc>
-                <a:spcPts val="1023"/>
-              </a:lnSpc>
-              <a:spcBef>
-                <a:spcPts val="1191"/>
-              </a:spcBef>
-              <a:spcAft>
-                <a:spcPts val="992"/>
-              </a:spcAft>
-            </a:pPr>
-            <a:br>
-              <a:rPr sz="2230"/>
-            </a:br>
-            <a:r>
-              <a:rPr b="0" lang="en-IN" sz="2230" spc="-1" strike="noStrike">
-                <a:solidFill>
-                  <a:srgbClr val="000000"/>
-                </a:solidFill>
-                <a:latin typeface="Arial"/>
-                <a:ea typeface="DejaVu Sans"/>
-              </a:rPr>
-              <a:t>compatibility reasons.</a:t>
-            </a:r>
-            <a:endParaRPr b="0" lang="en-US" sz="2230" spc="-1" strike="noStrike">
+              <a:rPr b="0" lang="en-US" sz="1800" spc="-1" strike="noStrike">
+                <a:solidFill>
+                  <a:srgbClr val="000000"/>
+                </a:solidFill>
+                <a:latin typeface="Arial"/>
+                <a:ea typeface="DejaVu Sans"/>
+              </a:rPr>
+              <a:t>▶ </a:t>
+            </a:r>
+            <a:r>
+              <a:rPr b="0" lang="en-US" sz="1800" spc="-1" strike="noStrike">
+                <a:solidFill>
+                  <a:srgbClr val="000000"/>
+                </a:solidFill>
+                <a:latin typeface="Arial"/>
+                <a:ea typeface="DejaVu Sans"/>
+              </a:rPr>
+              <a:t>Can read many filesystem formats to load the kernel image, modules and configuration</a:t>
+            </a:r>
+            <a:endParaRPr b="0" lang="en-US" sz="1800" spc="-1" strike="noStrike">
+              <a:solidFill>
+                <a:srgbClr val="000000"/>
+              </a:solidFill>
+              <a:latin typeface="Arial"/>
+            </a:endParaRPr>
+          </a:p>
+          <a:p>
+            <a:pPr>
+              <a:lnSpc>
+                <a:spcPct val="100000"/>
+              </a:lnSpc>
+            </a:pPr>
+            <a:r>
+              <a:rPr b="0" lang="en-US" sz="1800" spc="-1" strike="noStrike">
+                <a:solidFill>
+                  <a:srgbClr val="000000"/>
+                </a:solidFill>
+                <a:latin typeface="Arial"/>
+                <a:ea typeface="DejaVu Sans"/>
+              </a:rPr>
+              <a:t>▶ </a:t>
+            </a:r>
+            <a:r>
+              <a:rPr b="0" lang="en-US" sz="1800" spc="-1" strike="noStrike">
+                <a:solidFill>
+                  <a:srgbClr val="000000"/>
+                </a:solidFill>
+                <a:latin typeface="Arial"/>
+                <a:ea typeface="DejaVu Sans"/>
+              </a:rPr>
+              <a:t>Provides a menu and powerful shell with various commands</a:t>
+            </a:r>
+            <a:endParaRPr b="0" lang="en-US" sz="1800" spc="-1" strike="noStrike">
+              <a:solidFill>
+                <a:srgbClr val="000000"/>
+              </a:solidFill>
+              <a:latin typeface="Arial"/>
+            </a:endParaRPr>
+          </a:p>
+          <a:p>
+            <a:pPr>
+              <a:lnSpc>
+                <a:spcPct val="100000"/>
+              </a:lnSpc>
+            </a:pPr>
+            <a:r>
+              <a:rPr b="0" lang="en-US" sz="1800" spc="-1" strike="noStrike">
+                <a:solidFill>
+                  <a:srgbClr val="000000"/>
+                </a:solidFill>
+                <a:latin typeface="Arial"/>
+                <a:ea typeface="DejaVu Sans"/>
+              </a:rPr>
+              <a:t>▶ </a:t>
+            </a:r>
+            <a:r>
+              <a:rPr b="0" lang="en-US" sz="1800" spc="-1" strike="noStrike">
+                <a:solidFill>
+                  <a:srgbClr val="000000"/>
+                </a:solidFill>
+                <a:latin typeface="Arial"/>
+                <a:ea typeface="DejaVu Sans"/>
+              </a:rPr>
+              <a:t>Can load kernel images over the network</a:t>
+            </a:r>
+            <a:endParaRPr b="0" lang="en-US" sz="1800" spc="-1" strike="noStrike">
+              <a:solidFill>
+                <a:srgbClr val="000000"/>
+              </a:solidFill>
+              <a:latin typeface="Arial"/>
+            </a:endParaRPr>
+          </a:p>
+          <a:p>
+            <a:pPr>
+              <a:lnSpc>
+                <a:spcPct val="100000"/>
+              </a:lnSpc>
+            </a:pPr>
+            <a:r>
+              <a:rPr b="0" lang="en-US" sz="1800" spc="-1" strike="noStrike">
+                <a:solidFill>
+                  <a:srgbClr val="000000"/>
+                </a:solidFill>
+                <a:latin typeface="Arial"/>
+                <a:ea typeface="DejaVu Sans"/>
+              </a:rPr>
+              <a:t>▶ </a:t>
+            </a:r>
+            <a:r>
+              <a:rPr b="0" lang="en-US" sz="1800" spc="-1" strike="noStrike">
+                <a:solidFill>
+                  <a:srgbClr val="000000"/>
+                </a:solidFill>
+                <a:latin typeface="Arial"/>
+                <a:ea typeface="DejaVu Sans"/>
+              </a:rPr>
+              <a:t>Also supports ARM, ARM64, RISC-V, PowerPC, but less popular than other</a:t>
+            </a:r>
+            <a:endParaRPr b="0" lang="en-US" sz="1800" spc="-1" strike="noStrike">
+              <a:solidFill>
+                <a:srgbClr val="000000"/>
+              </a:solidFill>
+              <a:latin typeface="Arial"/>
+            </a:endParaRPr>
+          </a:p>
+          <a:p>
+            <a:pPr>
+              <a:lnSpc>
+                <a:spcPct val="100000"/>
+              </a:lnSpc>
+            </a:pPr>
+            <a:r>
+              <a:rPr b="0" lang="en-US" sz="1800" spc="-1" strike="noStrike">
+                <a:solidFill>
+                  <a:srgbClr val="000000"/>
+                </a:solidFill>
+                <a:latin typeface="Arial"/>
+                <a:ea typeface="DejaVu Sans"/>
+              </a:rPr>
+              <a:t>bootloaders on those platforms</a:t>
+            </a:r>
+            <a:endParaRPr b="0" lang="en-US" sz="1800" spc="-1" strike="noStrike">
+              <a:solidFill>
+                <a:srgbClr val="000000"/>
+              </a:solidFill>
+              <a:latin typeface="Arial"/>
+            </a:endParaRPr>
+          </a:p>
+          <a:p>
+            <a:pPr>
+              <a:lnSpc>
+                <a:spcPct val="100000"/>
+              </a:lnSpc>
+            </a:pPr>
+            <a:r>
+              <a:rPr b="0" lang="en-US" sz="1800" spc="-1" strike="noStrike">
+                <a:solidFill>
+                  <a:srgbClr val="000000"/>
+                </a:solidFill>
+                <a:latin typeface="Arial"/>
+                <a:ea typeface="DejaVu Sans"/>
+              </a:rPr>
+              <a:t>▶ </a:t>
+            </a:r>
+            <a:r>
+              <a:rPr b="0" lang="en-US" sz="1800" spc="-1" strike="noStrike">
+                <a:solidFill>
+                  <a:srgbClr val="000000"/>
+                </a:solidFill>
+                <a:latin typeface="Arial"/>
+                <a:ea typeface="DejaVu Sans"/>
+              </a:rPr>
+              <a:t>https://www.gnu.org/software/grub/</a:t>
+            </a:r>
+            <a:endParaRPr b="0" lang="en-US" sz="1800" spc="-1" strike="noStrike">
               <a:solidFill>
                 <a:srgbClr val="000000"/>
               </a:solidFill>
@@ -23165,7 +22805,7 @@
       </p:sp>
       <p:pic>
         <p:nvPicPr>
-          <p:cNvPr id="223" name="" descr=""/>
+          <p:cNvPr id="220" name="" descr=""/>
           <p:cNvPicPr/>
           <p:nvPr/>
         </p:nvPicPr>
@@ -23175,8 +22815,8 @@
         </p:blipFill>
         <p:spPr>
           <a:xfrm>
-            <a:off x="228600" y="4148640"/>
-            <a:ext cx="8913960" cy="1996920"/>
+            <a:off x="2968200" y="3537000"/>
+            <a:ext cx="6170400" cy="3256200"/>
           </a:xfrm>
           <a:prstGeom prst="rect">
             <a:avLst/>
@@ -23216,16 +22856,39 @@
           <a:chExt cx="0" cy="0"/>
         </a:xfrm>
       </p:grpSpPr>
+      <p:pic>
+        <p:nvPicPr>
+          <p:cNvPr id="221" name="Picture 1" descr=""/>
+          <p:cNvPicPr/>
+          <p:nvPr/>
+        </p:nvPicPr>
+        <p:blipFill>
+          <a:blip r:embed="rId1"/>
+          <a:stretch/>
+        </p:blipFill>
+        <p:spPr>
+          <a:xfrm>
+            <a:off x="0" y="0"/>
+            <a:ext cx="9135720" cy="6837120"/>
+          </a:xfrm>
+          <a:prstGeom prst="rect">
+            <a:avLst/>
+          </a:prstGeom>
+          <a:ln w="0">
+            <a:noFill/>
+          </a:ln>
+        </p:spPr>
+      </p:pic>
       <p:sp>
         <p:nvSpPr>
-          <p:cNvPr id="224" name=""/>
+          <p:cNvPr id="222" name="CustomShape 1"/>
           <p:cNvSpPr/>
           <p:nvPr/>
         </p:nvSpPr>
         <p:spPr>
           <a:xfrm>
-            <a:off x="505080" y="457200"/>
-            <a:ext cx="5437080" cy="600840"/>
+            <a:off x="3277800" y="431640"/>
+            <a:ext cx="2961000" cy="708120"/>
           </a:xfrm>
           <a:prstGeom prst="rect">
             <a:avLst/>
@@ -23242,26 +22905,26 @@
           <a:fontRef idx="minor"/>
         </p:style>
         <p:txBody>
-          <a:bodyPr lIns="90000" rIns="90000" tIns="45000" bIns="45000" anchor="t">
+          <a:bodyPr wrap="none" lIns="0" rIns="0" tIns="0" bIns="0" anchor="t">
             <a:noAutofit/>
           </a:bodyPr>
           <a:p>
             <a:pPr>
               <a:lnSpc>
-                <a:spcPct val="100000"/>
-              </a:lnSpc>
-            </a:pPr>
-            <a:r>
-              <a:rPr b="1" lang="en-US" sz="1800" spc="-1" strike="noStrike">
-                <a:solidFill>
-                  <a:srgbClr val="000000"/>
-                </a:solidFill>
-                <a:latin typeface="Arial"/>
-                <a:ea typeface="Noto Sans CJK SC"/>
-              </a:rPr>
-              <a:t>Systemd-boot : Simple UEFI boot manager</a:t>
-            </a:r>
-            <a:endParaRPr b="0" lang="en-US" sz="1800" spc="-1" strike="noStrike">
+                <a:spcPts val="975"/>
+              </a:lnSpc>
+            </a:pPr>
+            <a:r>
+              <a:rPr b="1" lang="en-US" sz="2240" spc="-1" strike="noStrike">
+                <a:solidFill>
+                  <a:srgbClr val="000000"/>
+                </a:solidFill>
+                <a:latin typeface="Arial Bold"/>
+                <a:ea typeface="DejaVu Sans"/>
+              </a:rPr>
+              <a:t>Initialization Overview</a:t>
+            </a:r>
+            <a:endParaRPr b="0" lang="en-US" sz="2240" spc="-1" strike="noStrike">
               <a:solidFill>
                 <a:srgbClr val="000000"/>
               </a:solidFill>
@@ -23272,14 +22935,14 @@
       </p:sp>
       <p:sp>
         <p:nvSpPr>
-          <p:cNvPr id="225" name=""/>
+          <p:cNvPr id="223" name="CustomShape 2"/>
           <p:cNvSpPr/>
           <p:nvPr/>
         </p:nvSpPr>
         <p:spPr>
           <a:xfrm>
-            <a:off x="411480" y="1057320"/>
-            <a:ext cx="8502480" cy="5173560"/>
+            <a:off x="253080" y="651600"/>
+            <a:ext cx="8506440" cy="1442880"/>
           </a:xfrm>
           <a:prstGeom prst="rect">
             <a:avLst/>
@@ -23296,7 +22959,7 @@
           <a:fontRef idx="minor"/>
         </p:style>
         <p:txBody>
-          <a:bodyPr lIns="90000" rIns="90000" tIns="45000" bIns="45000" anchor="t">
+          <a:bodyPr wrap="none" lIns="0" rIns="0" tIns="0" bIns="0" anchor="t">
             <a:noAutofit/>
           </a:bodyPr>
           <a:p>
@@ -23305,7 +22968,17 @@
                 <a:spcPct val="100000"/>
               </a:lnSpc>
             </a:pPr>
-            <a:endParaRPr b="0" lang="en-US" sz="1800" spc="-1" strike="noStrike">
+            <a:r>
+              <a:rPr b="0" lang="en-US" sz="2230" spc="-1" strike="noStrike">
+                <a:solidFill>
+                  <a:srgbClr val="000000"/>
+                </a:solidFill>
+                <a:latin typeface="Arial"/>
+                <a:ea typeface="DejaVu Sans"/>
+              </a:rPr>
+              <a:t>When the operating system starts, the kernel runs /sbin/init. This can</a:t>
+            </a:r>
+            <a:endParaRPr b="0" lang="en-US" sz="2230" spc="-1" strike="noStrike">
               <a:solidFill>
                 <a:srgbClr val="000000"/>
               </a:solidFill>
@@ -23319,39 +22992,106 @@
               </a:lnSpc>
             </a:pPr>
             <a:r>
-              <a:rPr b="0" lang="en-US" sz="1800" spc="-1" strike="noStrike">
-                <a:solidFill>
-                  <a:srgbClr val="000000"/>
-                </a:solidFill>
-                <a:latin typeface="Arial"/>
-                <a:ea typeface="DejaVu Sans"/>
-              </a:rPr>
-              <a:t>▶ </a:t>
-            </a:r>
-            <a:r>
-              <a:rPr b="0" lang="en-US" sz="1800" spc="-1" strike="noStrike">
-                <a:solidFill>
-                  <a:srgbClr val="000000"/>
-                </a:solidFill>
-                <a:latin typeface="Arial"/>
-                <a:ea typeface="DejaVu Sans"/>
-              </a:rPr>
-              <a:t>Useful alternative to GRUB for UEFI systems: simpler than GRUB</a:t>
-            </a:r>
-            <a:endParaRPr b="0" lang="en-US" sz="1800" spc="-1" strike="noStrike">
-              <a:solidFill>
-                <a:srgbClr val="000000"/>
-              </a:solidFill>
-              <a:latin typeface="Arial"/>
-            </a:endParaRPr>
-          </a:p>
+              <a:rPr b="0" lang="en-US" sz="2230" spc="-1" strike="noStrike">
+                <a:solidFill>
+                  <a:srgbClr val="000000"/>
+                </a:solidFill>
+                <a:latin typeface="Arial"/>
+                <a:ea typeface="DejaVu Sans"/>
+              </a:rPr>
+              <a:t>be either a script or a program, but typically it is a program that</a:t>
+            </a:r>
+            <a:endParaRPr b="0" lang="en-US" sz="2230" spc="-1" strike="noStrike">
+              <a:solidFill>
+                <a:srgbClr val="000000"/>
+              </a:solidFill>
+              <a:latin typeface="Arial"/>
+            </a:endParaRPr>
+          </a:p>
+          <a:p>
+            <a:pPr>
+              <a:lnSpc>
+                <a:spcPts val="1006"/>
+              </a:lnSpc>
+            </a:pPr>
+            <a:endParaRPr b="0" lang="en-US" sz="2230" spc="-1" strike="noStrike">
+              <a:solidFill>
+                <a:srgbClr val="000000"/>
+              </a:solidFill>
+              <a:latin typeface="Arial"/>
+            </a:endParaRPr>
+          </a:p>
+          <a:p>
+            <a:pPr>
+              <a:lnSpc>
+                <a:spcPts val="1006"/>
+              </a:lnSpc>
+            </a:pPr>
+            <a:r>
+              <a:rPr b="0" lang="en-US" sz="2230" spc="-1" strike="noStrike">
+                <a:solidFill>
+                  <a:srgbClr val="000000"/>
+                </a:solidFill>
+                <a:latin typeface="Arial"/>
+                <a:ea typeface="DejaVu Sans"/>
+              </a:rPr>
+              <a:t>processes the statements in /etc/initab.</a:t>
+            </a:r>
+            <a:endParaRPr b="0" lang="en-US" sz="2230" spc="-1" strike="noStrike">
+              <a:solidFill>
+                <a:srgbClr val="000000"/>
+              </a:solidFill>
+              <a:latin typeface="Arial"/>
+            </a:endParaRPr>
+          </a:p>
+        </p:txBody>
+      </p:sp>
+      <p:sp>
+        <p:nvSpPr>
+          <p:cNvPr id="224" name="CustomShape 3"/>
+          <p:cNvSpPr/>
+          <p:nvPr/>
+        </p:nvSpPr>
+        <p:spPr>
+          <a:xfrm>
+            <a:off x="274320" y="1698480"/>
+            <a:ext cx="8604000" cy="1464840"/>
+          </a:xfrm>
+          <a:prstGeom prst="rect">
+            <a:avLst/>
+          </a:prstGeom>
+          <a:noFill/>
+          <a:ln w="0">
+            <a:noFill/>
+          </a:ln>
+        </p:spPr>
+        <p:style>
+          <a:lnRef idx="0"/>
+          <a:fillRef idx="0"/>
+          <a:effectRef idx="0"/>
+          <a:fontRef idx="minor"/>
+        </p:style>
+        <p:txBody>
+          <a:bodyPr wrap="none" lIns="0" rIns="0" tIns="0" bIns="0" anchor="t">
+            <a:noAutofit/>
+          </a:bodyPr>
           <a:p>
             <a:pPr>
               <a:lnSpc>
                 <a:spcPct val="100000"/>
               </a:lnSpc>
             </a:pPr>
-            <a:endParaRPr b="0" lang="en-US" sz="1800" spc="-1" strike="noStrike">
+            <a:r>
+              <a:rPr b="0" lang="en-US" sz="2230" spc="-1" strike="noStrike">
+                <a:solidFill>
+                  <a:srgbClr val="000000"/>
+                </a:solidFill>
+                <a:latin typeface="Arial"/>
+                <a:ea typeface="DejaVu Sans"/>
+              </a:rPr>
+              <a:t>The default inittab file tells init to run the commands in the file</a:t>
+            </a:r>
+            <a:endParaRPr b="0" lang="en-US" sz="2230" spc="-1" strike="noStrike">
               <a:solidFill>
                 <a:srgbClr val="000000"/>
               </a:solidFill>
@@ -23365,111 +23105,114 @@
               </a:lnSpc>
             </a:pPr>
             <a:r>
-              <a:rPr b="0" lang="en-US" sz="1800" spc="-1" strike="noStrike">
-                <a:solidFill>
-                  <a:srgbClr val="000000"/>
-                </a:solidFill>
-                <a:latin typeface="Arial"/>
-                <a:ea typeface="DejaVu Sans"/>
-              </a:rPr>
-              <a:t>▶ </a:t>
-            </a:r>
-            <a:r>
-              <a:rPr b="0" lang="en-US" sz="1800" spc="-1" strike="noStrike">
-                <a:solidFill>
-                  <a:srgbClr val="000000"/>
-                </a:solidFill>
-                <a:latin typeface="Arial"/>
-                <a:ea typeface="DejaVu Sans"/>
-              </a:rPr>
-              <a:t>Configured using files stored in the EFI System Partition</a:t>
-            </a:r>
-            <a:br>
-              <a:rPr sz="1800"/>
-            </a:br>
-            <a:br>
-              <a:rPr sz="1800"/>
-            </a:br>
-            <a:r>
-              <a:rPr b="0" lang="en-US" sz="1800" spc="-1" strike="noStrike">
-                <a:solidFill>
-                  <a:srgbClr val="000000"/>
-                </a:solidFill>
-                <a:latin typeface="Arial"/>
-                <a:ea typeface="DejaVu Sans"/>
-              </a:rPr>
-              <a:t>▶ Part of the systemd project, even though obviously distinct from systemd itself</a:t>
-            </a:r>
-            <a:endParaRPr b="0" lang="en-US" sz="1800" spc="-1" strike="noStrike">
-              <a:solidFill>
-                <a:srgbClr val="000000"/>
-              </a:solidFill>
-              <a:latin typeface="Arial"/>
-            </a:endParaRPr>
-          </a:p>
-          <a:p>
-            <a:pPr>
-              <a:lnSpc>
-                <a:spcPct val="100000"/>
-              </a:lnSpc>
-            </a:pPr>
-            <a:endParaRPr b="0" lang="en-US" sz="1800" spc="-1" strike="noStrike">
-              <a:solidFill>
-                <a:srgbClr val="000000"/>
-              </a:solidFill>
-              <a:latin typeface="Arial"/>
-            </a:endParaRPr>
-          </a:p>
-          <a:p>
-            <a:pPr>
-              <a:lnSpc>
-                <a:spcPct val="100000"/>
-              </a:lnSpc>
-            </a:pPr>
-            <a:r>
-              <a:rPr b="0" lang="en-US" sz="1800" spc="-1" strike="noStrike">
-                <a:solidFill>
-                  <a:srgbClr val="000000"/>
-                </a:solidFill>
-                <a:latin typeface="Arial"/>
-                <a:ea typeface="DejaVu Sans"/>
-              </a:rPr>
-              <a:t>▶ </a:t>
-            </a:r>
-            <a:r>
-              <a:rPr b="0" lang="en-US" sz="1800" spc="-1" strike="noStrike">
-                <a:solidFill>
-                  <a:srgbClr val="000000"/>
-                </a:solidFill>
-                <a:latin typeface="Arial"/>
-                <a:ea typeface="DejaVu Sans"/>
-              </a:rPr>
-              <a:t>systemd-boot is a UEFI boot manager which executes configured EFI images.</a:t>
-            </a:r>
-            <a:endParaRPr b="0" lang="en-US" sz="1800" spc="-1" strike="noStrike">
-              <a:solidFill>
-                <a:srgbClr val="000000"/>
-              </a:solidFill>
-              <a:latin typeface="Arial"/>
-            </a:endParaRPr>
-          </a:p>
-          <a:p>
-            <a:pPr>
-              <a:lnSpc>
-                <a:spcPct val="100000"/>
-              </a:lnSpc>
-            </a:pPr>
-            <a:endParaRPr b="0" lang="en-US" sz="1800" spc="-1" strike="noStrike">
-              <a:solidFill>
-                <a:srgbClr val="000000"/>
-              </a:solidFill>
-              <a:latin typeface="Arial"/>
-            </a:endParaRPr>
-          </a:p>
-          <a:p>
-            <a:pPr>
-              <a:lnSpc>
-                <a:spcPct val="100000"/>
+              <a:rPr b="0" lang="en-US" sz="2230" spc="-1" strike="noStrike">
+                <a:solidFill>
+                  <a:srgbClr val="000000"/>
+                </a:solidFill>
+                <a:latin typeface="Arial"/>
+                <a:ea typeface="DejaVu Sans"/>
+              </a:rPr>
+              <a:t>/etc/rc.d/rcS. In addition, init spawns programs to present login</a:t>
+            </a:r>
+            <a:endParaRPr b="0" lang="en-US" sz="2230" spc="-1" strike="noStrike">
+              <a:solidFill>
+                <a:srgbClr val="000000"/>
+              </a:solidFill>
+              <a:latin typeface="Arial"/>
+            </a:endParaRPr>
+          </a:p>
+          <a:p>
+            <a:pPr>
+              <a:lnSpc>
+                <a:spcPts val="1023"/>
+              </a:lnSpc>
+            </a:pPr>
+            <a:endParaRPr b="0" lang="en-US" sz="2230" spc="-1" strike="noStrike">
+              <a:solidFill>
+                <a:srgbClr val="000000"/>
+              </a:solidFill>
+              <a:latin typeface="Arial"/>
+            </a:endParaRPr>
+          </a:p>
+          <a:p>
+            <a:pPr>
+              <a:lnSpc>
+                <a:spcPts val="1023"/>
+              </a:lnSpc>
+            </a:pPr>
+            <a:endParaRPr b="0" lang="en-US" sz="2230" spc="-1" strike="noStrike">
+              <a:solidFill>
+                <a:srgbClr val="000000"/>
+              </a:solidFill>
+              <a:latin typeface="Arial"/>
+            </a:endParaRPr>
+          </a:p>
+          <a:p>
+            <a:pPr>
+              <a:lnSpc>
+                <a:spcPts val="1023"/>
+              </a:lnSpc>
+            </a:pPr>
+            <a:r>
+              <a:rPr b="0" lang="en-US" sz="2230" spc="-1" strike="noStrike">
+                <a:solidFill>
+                  <a:srgbClr val="000000"/>
+                </a:solidFill>
+                <a:latin typeface="Arial"/>
+                <a:ea typeface="DejaVu Sans"/>
+              </a:rPr>
+              <a:t>prompts on two virtual terminals.</a:t>
+            </a:r>
+            <a:endParaRPr b="0" lang="en-US" sz="2230" spc="-1" strike="noStrike">
+              <a:solidFill>
+                <a:srgbClr val="000000"/>
+              </a:solidFill>
+              <a:latin typeface="Arial"/>
+            </a:endParaRPr>
+          </a:p>
+          <a:p>
+            <a:pPr>
+              <a:lnSpc>
+                <a:spcPts val="1023"/>
+              </a:lnSpc>
+            </a:pPr>
+            <a:endParaRPr b="0" lang="en-US" sz="2230" spc="-1" strike="noStrike">
+              <a:solidFill>
+                <a:srgbClr val="000000"/>
+              </a:solidFill>
+              <a:latin typeface="Arial"/>
+            </a:endParaRPr>
+          </a:p>
+          <a:p>
+            <a:pPr>
+              <a:lnSpc>
+                <a:spcPts val="1023"/>
+              </a:lnSpc>
+            </a:pPr>
+            <a:endParaRPr b="0" lang="en-US" sz="2230" spc="-1" strike="noStrike">
+              <a:solidFill>
+                <a:srgbClr val="000000"/>
+              </a:solidFill>
+              <a:latin typeface="Arial"/>
+            </a:endParaRPr>
+          </a:p>
+          <a:p>
+            <a:pPr>
+              <a:lnSpc>
+                <a:spcPts val="1023"/>
+              </a:lnSpc>
+            </a:pPr>
+            <a:endParaRPr b="0" lang="en-US" sz="2230" spc="-1" strike="noStrike">
+              <a:solidFill>
+                <a:srgbClr val="000000"/>
+              </a:solidFill>
+              <a:latin typeface="Arial"/>
+            </a:endParaRPr>
+          </a:p>
+          <a:p>
+            <a:pPr>
+              <a:lnSpc>
+                <a:spcPts val="1023"/>
               </a:lnSpc>
               <a:spcBef>
                 <a:spcPts val="1191"/>
@@ -23479,59 +23222,26 @@
               </a:spcAft>
             </a:pPr>
             <a:r>
-              <a:rPr b="0" lang="en-US" sz="1800" spc="-1" strike="noStrike">
-                <a:solidFill>
-                  <a:srgbClr val="000000"/>
-                </a:solidFill>
-                <a:latin typeface="Arial"/>
-                <a:ea typeface="DejaVu Sans"/>
-              </a:rPr>
-              <a:t>▶ </a:t>
-            </a:r>
-            <a:r>
-              <a:rPr b="0" lang="en-US" sz="1800" spc="-1" strike="noStrike">
-                <a:solidFill>
-                  <a:srgbClr val="000000"/>
-                </a:solidFill>
-                <a:latin typeface="Arial"/>
-                <a:ea typeface="DejaVu Sans"/>
-              </a:rPr>
-              <a:t>systemd-boot operates on the EFI System Partition (ESP) only. Configuration file fragments, kernels, initrds, other EFI images need to reside on the ESP. Linux kernels need to be built with CONFIG_EFI_STUB to be able to be directly executed as an EFI image.  </a:t>
-            </a:r>
-            <a:endParaRPr b="0" lang="en-US" sz="1800" spc="-1" strike="noStrike">
-              <a:solidFill>
-                <a:srgbClr val="000000"/>
-              </a:solidFill>
-              <a:latin typeface="Arial"/>
-            </a:endParaRPr>
-          </a:p>
-          <a:p>
-            <a:pPr>
-              <a:lnSpc>
-                <a:spcPct val="100000"/>
-              </a:lnSpc>
-            </a:pPr>
-            <a:r>
-              <a:rPr b="1" lang="en-US" sz="1800" spc="-1" strike="noStrike">
-                <a:solidFill>
-                  <a:srgbClr val="000000"/>
-                </a:solidFill>
-                <a:latin typeface="Arial"/>
-                <a:ea typeface="DejaVu Sans"/>
-              </a:rPr>
-              <a:t>https://www.freedesktop.org/wiki/Software/systemd/systemd-boot/</a:t>
-            </a:r>
-            <a:endParaRPr b="0" lang="en-US" sz="1800" spc="-1" strike="noStrike">
-              <a:solidFill>
-                <a:srgbClr val="000000"/>
-              </a:solidFill>
-              <a:latin typeface="Arial"/>
-            </a:endParaRPr>
-          </a:p>
-          <a:p>
-            <a:pPr>
-              <a:lnSpc>
-                <a:spcPct val="100000"/>
+              <a:rPr b="0" lang="en-IN" sz="2230" spc="-1" strike="noStrike">
+                <a:solidFill>
+                  <a:srgbClr val="000000"/>
+                </a:solidFill>
+                <a:latin typeface="Arial"/>
+                <a:ea typeface="DejaVu Sans"/>
+              </a:rPr>
+              <a:t>In Ubuntu: systemd is in use, but /etc/rc0.d still exists for</a:t>
+            </a:r>
+            <a:endParaRPr b="0" lang="en-US" sz="2230" spc="-1" strike="noStrike">
+              <a:solidFill>
+                <a:srgbClr val="000000"/>
+              </a:solidFill>
+              <a:latin typeface="Arial"/>
+            </a:endParaRPr>
+          </a:p>
+          <a:p>
+            <a:pPr>
+              <a:lnSpc>
+                <a:spcPts val="1023"/>
               </a:lnSpc>
               <a:spcBef>
                 <a:spcPts val="1191"/>
@@ -23541,9 +23251,19 @@
               </a:spcAft>
             </a:pPr>
             <a:br>
-              <a:rPr sz="1000"/>
+              <a:rPr sz="2230"/>
             </a:br>
-            <a:endParaRPr b="0" lang="en-US" sz="1000" spc="-1" strike="noStrike">
+            <a:r>
+              <a:rPr b="0" lang="en-IN" sz="2230" spc="-1" strike="noStrike">
+                <a:solidFill>
+                  <a:srgbClr val="000000"/>
+                </a:solidFill>
+                <a:latin typeface="Arial"/>
+                <a:ea typeface="DejaVu Sans"/>
+              </a:rPr>
+              <a:t>compatibility reasons.</a:t>
+            </a:r>
+            <a:endParaRPr b="0" lang="en-US" sz="2230" spc="-1" strike="noStrike">
               <a:solidFill>
                 <a:srgbClr val="000000"/>
               </a:solidFill>
@@ -23552,6 +23272,29 @@
           </a:p>
         </p:txBody>
       </p:sp>
+      <p:pic>
+        <p:nvPicPr>
+          <p:cNvPr id="225" name="" descr=""/>
+          <p:cNvPicPr/>
+          <p:nvPr/>
+        </p:nvPicPr>
+        <p:blipFill>
+          <a:blip r:embed="rId2"/>
+          <a:stretch/>
+        </p:blipFill>
+        <p:spPr>
+          <a:xfrm>
+            <a:off x="228600" y="4148640"/>
+            <a:ext cx="8913600" cy="1996560"/>
+          </a:xfrm>
+          <a:prstGeom prst="rect">
+            <a:avLst/>
+          </a:prstGeom>
+          <a:ln w="0">
+            <a:noFill/>
+          </a:ln>
+        </p:spPr>
+      </p:pic>
     </p:spTree>
   </p:cSld>
   <mc:AlternateContent>
@@ -23582,39 +23325,16 @@
           <a:chExt cx="0" cy="0"/>
         </a:xfrm>
       </p:grpSpPr>
-      <p:pic>
-        <p:nvPicPr>
-          <p:cNvPr id="226" name="Picture 1" descr=""/>
-          <p:cNvPicPr/>
-          <p:nvPr/>
-        </p:nvPicPr>
-        <p:blipFill>
-          <a:blip r:embed="rId1"/>
-          <a:stretch/>
-        </p:blipFill>
-        <p:spPr>
-          <a:xfrm>
-            <a:off x="146160" y="68760"/>
-            <a:ext cx="8539200" cy="1758600"/>
-          </a:xfrm>
-          <a:prstGeom prst="rect">
-            <a:avLst/>
-          </a:prstGeom>
-          <a:ln w="0">
-            <a:noFill/>
-          </a:ln>
-        </p:spPr>
-      </p:pic>
       <p:sp>
         <p:nvSpPr>
-          <p:cNvPr id="227" name="CustomShape 1"/>
+          <p:cNvPr id="226" name=""/>
           <p:cNvSpPr/>
           <p:nvPr/>
         </p:nvSpPr>
         <p:spPr>
           <a:xfrm>
-            <a:off x="331920" y="266760"/>
-            <a:ext cx="7781400" cy="1833480"/>
+            <a:off x="505080" y="457200"/>
+            <a:ext cx="5436720" cy="600480"/>
           </a:xfrm>
           <a:prstGeom prst="rect">
             <a:avLst/>
@@ -23631,9 +23351,230 @@
           <a:fontRef idx="minor"/>
         </p:style>
         <p:txBody>
-          <a:bodyPr wrap="none" lIns="0" rIns="0" tIns="0" bIns="0" anchor="t">
+          <a:bodyPr lIns="90000" rIns="90000" tIns="45000" bIns="45000" anchor="t">
             <a:noAutofit/>
           </a:bodyPr>
+          <a:p>
+            <a:pPr>
+              <a:lnSpc>
+                <a:spcPct val="100000"/>
+              </a:lnSpc>
+            </a:pPr>
+            <a:r>
+              <a:rPr b="1" lang="en-US" sz="1800" spc="-1" strike="noStrike">
+                <a:solidFill>
+                  <a:srgbClr val="000000"/>
+                </a:solidFill>
+                <a:latin typeface="Arial"/>
+                <a:ea typeface="Noto Sans CJK SC"/>
+              </a:rPr>
+              <a:t>Systemd-boot : Simple UEFI boot manager</a:t>
+            </a:r>
+            <a:endParaRPr b="0" lang="en-US" sz="1800" spc="-1" strike="noStrike">
+              <a:solidFill>
+                <a:srgbClr val="000000"/>
+              </a:solidFill>
+              <a:latin typeface="Arial"/>
+            </a:endParaRPr>
+          </a:p>
+        </p:txBody>
+      </p:sp>
+      <p:sp>
+        <p:nvSpPr>
+          <p:cNvPr id="227" name=""/>
+          <p:cNvSpPr/>
+          <p:nvPr/>
+        </p:nvSpPr>
+        <p:spPr>
+          <a:xfrm>
+            <a:off x="411480" y="1057320"/>
+            <a:ext cx="8502120" cy="5173200"/>
+          </a:xfrm>
+          <a:prstGeom prst="rect">
+            <a:avLst/>
+          </a:prstGeom>
+          <a:noFill/>
+          <a:ln w="0">
+            <a:noFill/>
+          </a:ln>
+        </p:spPr>
+        <p:style>
+          <a:lnRef idx="0"/>
+          <a:fillRef idx="0"/>
+          <a:effectRef idx="0"/>
+          <a:fontRef idx="minor"/>
+        </p:style>
+        <p:txBody>
+          <a:bodyPr lIns="90000" rIns="90000" tIns="45000" bIns="45000" anchor="t">
+            <a:noAutofit/>
+          </a:bodyPr>
+          <a:p>
+            <a:pPr>
+              <a:lnSpc>
+                <a:spcPct val="100000"/>
+              </a:lnSpc>
+            </a:pPr>
+            <a:endParaRPr b="0" lang="en-US" sz="1800" spc="-1" strike="noStrike">
+              <a:solidFill>
+                <a:srgbClr val="000000"/>
+              </a:solidFill>
+              <a:latin typeface="Arial"/>
+            </a:endParaRPr>
+          </a:p>
+          <a:p>
+            <a:pPr>
+              <a:lnSpc>
+                <a:spcPct val="100000"/>
+              </a:lnSpc>
+            </a:pPr>
+            <a:r>
+              <a:rPr b="0" lang="en-US" sz="1800" spc="-1" strike="noStrike">
+                <a:solidFill>
+                  <a:srgbClr val="000000"/>
+                </a:solidFill>
+                <a:latin typeface="Arial"/>
+                <a:ea typeface="DejaVu Sans"/>
+              </a:rPr>
+              <a:t>▶ </a:t>
+            </a:r>
+            <a:r>
+              <a:rPr b="0" lang="en-US" sz="1800" spc="-1" strike="noStrike">
+                <a:solidFill>
+                  <a:srgbClr val="000000"/>
+                </a:solidFill>
+                <a:latin typeface="Arial"/>
+                <a:ea typeface="DejaVu Sans"/>
+              </a:rPr>
+              <a:t>Useful alternative to GRUB for UEFI systems: simpler than GRUB</a:t>
+            </a:r>
+            <a:endParaRPr b="0" lang="en-US" sz="1800" spc="-1" strike="noStrike">
+              <a:solidFill>
+                <a:srgbClr val="000000"/>
+              </a:solidFill>
+              <a:latin typeface="Arial"/>
+            </a:endParaRPr>
+          </a:p>
+          <a:p>
+            <a:pPr>
+              <a:lnSpc>
+                <a:spcPct val="100000"/>
+              </a:lnSpc>
+            </a:pPr>
+            <a:endParaRPr b="0" lang="en-US" sz="1800" spc="-1" strike="noStrike">
+              <a:solidFill>
+                <a:srgbClr val="000000"/>
+              </a:solidFill>
+              <a:latin typeface="Arial"/>
+            </a:endParaRPr>
+          </a:p>
+          <a:p>
+            <a:pPr>
+              <a:lnSpc>
+                <a:spcPct val="100000"/>
+              </a:lnSpc>
+            </a:pPr>
+            <a:r>
+              <a:rPr b="0" lang="en-US" sz="1800" spc="-1" strike="noStrike">
+                <a:solidFill>
+                  <a:srgbClr val="000000"/>
+                </a:solidFill>
+                <a:latin typeface="Arial"/>
+                <a:ea typeface="DejaVu Sans"/>
+              </a:rPr>
+              <a:t>▶ </a:t>
+            </a:r>
+            <a:r>
+              <a:rPr b="0" lang="en-US" sz="1800" spc="-1" strike="noStrike">
+                <a:solidFill>
+                  <a:srgbClr val="000000"/>
+                </a:solidFill>
+                <a:latin typeface="Arial"/>
+                <a:ea typeface="DejaVu Sans"/>
+              </a:rPr>
+              <a:t>Configured using files stored in the EFI System Partition</a:t>
+            </a:r>
+            <a:br>
+              <a:rPr sz="1800"/>
+            </a:br>
+            <a:br>
+              <a:rPr sz="1800"/>
+            </a:br>
+            <a:r>
+              <a:rPr b="0" lang="en-US" sz="1800" spc="-1" strike="noStrike">
+                <a:solidFill>
+                  <a:srgbClr val="000000"/>
+                </a:solidFill>
+                <a:latin typeface="Arial"/>
+                <a:ea typeface="DejaVu Sans"/>
+              </a:rPr>
+              <a:t>▶ Part of the systemd project, even though obviously distinct from systemd itself</a:t>
+            </a:r>
+            <a:endParaRPr b="0" lang="en-US" sz="1800" spc="-1" strike="noStrike">
+              <a:solidFill>
+                <a:srgbClr val="000000"/>
+              </a:solidFill>
+              <a:latin typeface="Arial"/>
+            </a:endParaRPr>
+          </a:p>
+          <a:p>
+            <a:pPr>
+              <a:lnSpc>
+                <a:spcPct val="100000"/>
+              </a:lnSpc>
+            </a:pPr>
+            <a:endParaRPr b="0" lang="en-US" sz="1800" spc="-1" strike="noStrike">
+              <a:solidFill>
+                <a:srgbClr val="000000"/>
+              </a:solidFill>
+              <a:latin typeface="Arial"/>
+            </a:endParaRPr>
+          </a:p>
+          <a:p>
+            <a:pPr>
+              <a:lnSpc>
+                <a:spcPct val="100000"/>
+              </a:lnSpc>
+            </a:pPr>
+            <a:r>
+              <a:rPr b="0" lang="en-US" sz="1800" spc="-1" strike="noStrike">
+                <a:solidFill>
+                  <a:srgbClr val="000000"/>
+                </a:solidFill>
+                <a:latin typeface="Arial"/>
+                <a:ea typeface="DejaVu Sans"/>
+              </a:rPr>
+              <a:t>▶ </a:t>
+            </a:r>
+            <a:r>
+              <a:rPr b="0" lang="en-US" sz="1800" spc="-1" strike="noStrike">
+                <a:solidFill>
+                  <a:srgbClr val="000000"/>
+                </a:solidFill>
+                <a:latin typeface="Arial"/>
+                <a:ea typeface="DejaVu Sans"/>
+              </a:rPr>
+              <a:t>systemd-boot is a UEFI boot manager which executes configured EFI images.</a:t>
+            </a:r>
+            <a:endParaRPr b="0" lang="en-US" sz="1800" spc="-1" strike="noStrike">
+              <a:solidFill>
+                <a:srgbClr val="000000"/>
+              </a:solidFill>
+              <a:latin typeface="Arial"/>
+            </a:endParaRPr>
+          </a:p>
+          <a:p>
+            <a:pPr>
+              <a:lnSpc>
+                <a:spcPct val="100000"/>
+              </a:lnSpc>
+            </a:pPr>
+            <a:endParaRPr b="0" lang="en-US" sz="1800" spc="-1" strike="noStrike">
+              <a:solidFill>
+                <a:srgbClr val="000000"/>
+              </a:solidFill>
+              <a:latin typeface="Arial"/>
+            </a:endParaRPr>
+          </a:p>
           <a:p>
             <a:pPr>
               <a:lnSpc>
@@ -23647,144 +23588,71 @@
               </a:spcAft>
             </a:pPr>
             <a:r>
-              <a:rPr b="1" lang="en-US" sz="2240" spc="-1" strike="noStrike">
-                <a:solidFill>
-                  <a:srgbClr val="000000"/>
-                </a:solidFill>
-                <a:latin typeface="Arial Bold"/>
-                <a:ea typeface="DejaVu Sans"/>
-              </a:rPr>
-              <a:t>Init Runlevels</a:t>
-            </a:r>
-            <a:r>
-              <a:rPr b="0" lang="en-US" sz="2230" spc="-1" strike="noStrike">
-                <a:solidFill>
-                  <a:srgbClr val="000000"/>
-                </a:solidFill>
-                <a:latin typeface="Arial"/>
-                <a:ea typeface="DejaVu Sans"/>
-              </a:rPr>
-              <a:t>: </a:t>
-            </a:r>
-            <a:r>
-              <a:rPr b="1" lang="en-US" sz="2230" spc="-1" strike="noStrike">
-                <a:solidFill>
-                  <a:srgbClr val="000000"/>
-                </a:solidFill>
-                <a:latin typeface="Arial"/>
-                <a:ea typeface="DejaVu Sans"/>
-              </a:rPr>
-              <a:t>/etc/rc0.d (SysVinit)</a:t>
-            </a:r>
+              <a:rPr b="0" lang="en-US" sz="1800" spc="-1" strike="noStrike">
+                <a:solidFill>
+                  <a:srgbClr val="000000"/>
+                </a:solidFill>
+                <a:latin typeface="Arial"/>
+                <a:ea typeface="DejaVu Sans"/>
+              </a:rPr>
+              <a:t>▶ </a:t>
+            </a:r>
+            <a:r>
+              <a:rPr b="0" lang="en-US" sz="1800" spc="-1" strike="noStrike">
+                <a:solidFill>
+                  <a:srgbClr val="000000"/>
+                </a:solidFill>
+                <a:latin typeface="Arial"/>
+                <a:ea typeface="DejaVu Sans"/>
+              </a:rPr>
+              <a:t>systemd-boot operates on the EFI System Partition (ESP) only. Configuration file fragments, kernels, initrds, other EFI images need to reside on the ESP. Linux kernels need to be built with CONFIG_EFI_STUB to be able to be directly executed as an EFI image.  </a:t>
+            </a:r>
+            <a:endParaRPr b="0" lang="en-US" sz="1800" spc="-1" strike="noStrike">
+              <a:solidFill>
+                <a:srgbClr val="000000"/>
+              </a:solidFill>
+              <a:latin typeface="Arial"/>
+            </a:endParaRPr>
+          </a:p>
+          <a:p>
+            <a:pPr>
+              <a:lnSpc>
+                <a:spcPct val="100000"/>
+              </a:lnSpc>
+            </a:pPr>
+            <a:r>
+              <a:rPr b="1" lang="en-US" sz="1800" spc="-1" strike="noStrike">
+                <a:solidFill>
+                  <a:srgbClr val="000000"/>
+                </a:solidFill>
+                <a:latin typeface="Arial"/>
+                <a:ea typeface="DejaVu Sans"/>
+              </a:rPr>
+              <a:t>https://www.freedesktop.org/wiki/Software/systemd/systemd-boot/</a:t>
+            </a:r>
+            <a:endParaRPr b="0" lang="en-US" sz="1800" spc="-1" strike="noStrike">
+              <a:solidFill>
+                <a:srgbClr val="000000"/>
+              </a:solidFill>
+              <a:latin typeface="Arial"/>
+            </a:endParaRPr>
+          </a:p>
+          <a:p>
+            <a:pPr>
+              <a:lnSpc>
+                <a:spcPct val="100000"/>
+              </a:lnSpc>
+              <a:spcBef>
+                <a:spcPts val="1191"/>
+              </a:spcBef>
+              <a:spcAft>
+                <a:spcPts val="992"/>
+              </a:spcAft>
+            </a:pPr>
             <a:br>
-              <a:rPr sz="2230"/>
+              <a:rPr sz="1000"/>
             </a:br>
-            <a:r>
-              <a:rPr b="0" lang="en-US" sz="2230" spc="-1" strike="noStrike">
-                <a:solidFill>
-                  <a:srgbClr val="000000"/>
-                </a:solidFill>
-                <a:latin typeface="Arial"/>
-                <a:ea typeface="DejaVu Sans"/>
-              </a:rPr>
-              <a:t>The idea behind operating different services at</a:t>
-            </a:r>
-            <a:endParaRPr b="0" lang="en-US" sz="2230" spc="-1" strike="noStrike">
-              <a:solidFill>
-                <a:srgbClr val="000000"/>
-              </a:solidFill>
-              <a:latin typeface="Arial"/>
-            </a:endParaRPr>
-          </a:p>
-          <a:p>
-            <a:pPr>
-              <a:lnSpc>
-                <a:spcPct val="100000"/>
-              </a:lnSpc>
-            </a:pPr>
-            <a:r>
-              <a:rPr b="0" lang="en-US" sz="2230" spc="-1" strike="noStrike">
-                <a:solidFill>
-                  <a:srgbClr val="000000"/>
-                </a:solidFill>
-                <a:latin typeface="Arial"/>
-                <a:ea typeface="DejaVu Sans"/>
-              </a:rPr>
-              <a:t>different run levels essentially revolves around the fact that</a:t>
-            </a:r>
-            <a:endParaRPr b="0" lang="en-US" sz="2230" spc="-1" strike="noStrike">
-              <a:solidFill>
-                <a:srgbClr val="000000"/>
-              </a:solidFill>
-              <a:latin typeface="Arial"/>
-            </a:endParaRPr>
-          </a:p>
-          <a:p>
-            <a:pPr>
-              <a:lnSpc>
-                <a:spcPct val="100000"/>
-              </a:lnSpc>
-            </a:pPr>
-            <a:r>
-              <a:rPr b="0" lang="en-US" sz="2230" spc="-1" strike="noStrike">
-                <a:solidFill>
-                  <a:srgbClr val="000000"/>
-                </a:solidFill>
-                <a:latin typeface="Arial"/>
-                <a:ea typeface="DejaVu Sans"/>
-              </a:rPr>
-              <a:t>different systems can be used in a different ways. The following</a:t>
-            </a:r>
-            <a:endParaRPr b="0" lang="en-US" sz="2230" spc="-1" strike="noStrike">
-              <a:solidFill>
-                <a:srgbClr val="000000"/>
-              </a:solidFill>
-              <a:latin typeface="Arial"/>
-            </a:endParaRPr>
-          </a:p>
-          <a:p>
-            <a:pPr>
-              <a:lnSpc>
-                <a:spcPts val="1023"/>
-              </a:lnSpc>
-            </a:pPr>
-            <a:endParaRPr b="0" lang="en-US" sz="2230" spc="-1" strike="noStrike">
-              <a:solidFill>
-                <a:srgbClr val="000000"/>
-              </a:solidFill>
-              <a:latin typeface="Arial"/>
-            </a:endParaRPr>
-          </a:p>
-          <a:p>
-            <a:pPr>
-              <a:lnSpc>
-                <a:spcPts val="1023"/>
-              </a:lnSpc>
-            </a:pPr>
-            <a:endParaRPr b="0" lang="en-US" sz="2230" spc="-1" strike="noStrike">
-              <a:solidFill>
-                <a:srgbClr val="000000"/>
-              </a:solidFill>
-              <a:latin typeface="Arial"/>
-            </a:endParaRPr>
-          </a:p>
-          <a:p>
-            <a:pPr>
-              <a:lnSpc>
-                <a:spcPts val="1023"/>
-              </a:lnSpc>
-            </a:pPr>
-            <a:r>
-              <a:rPr b="0" lang="en-US" sz="2230" spc="-1" strike="noStrike">
-                <a:solidFill>
-                  <a:srgbClr val="000000"/>
-                </a:solidFill>
-                <a:latin typeface="Arial"/>
-                <a:ea typeface="DejaVu Sans"/>
-              </a:rPr>
-              <a:t>runlevels are defined in Red Hat Linux :</a:t>
-            </a:r>
-            <a:endParaRPr b="0" lang="en-US" sz="2230" spc="-1" strike="noStrike">
+            <a:endParaRPr b="0" lang="en-US" sz="1000" spc="-1" strike="noStrike">
               <a:solidFill>
                 <a:srgbClr val="000000"/>
               </a:solidFill>
@@ -23793,29 +23661,6 @@
           </a:p>
         </p:txBody>
       </p:sp>
-      <p:pic>
-        <p:nvPicPr>
-          <p:cNvPr id="228" name="" descr=""/>
-          <p:cNvPicPr/>
-          <p:nvPr/>
-        </p:nvPicPr>
-        <p:blipFill>
-          <a:blip r:embed="rId2"/>
-          <a:stretch/>
-        </p:blipFill>
-        <p:spPr>
-          <a:xfrm>
-            <a:off x="1143000" y="1855800"/>
-            <a:ext cx="5996160" cy="4314960"/>
-          </a:xfrm>
-          <a:prstGeom prst="rect">
-            <a:avLst/>
-          </a:prstGeom>
-          <a:ln w="0">
-            <a:noFill/>
-          </a:ln>
-        </p:spPr>
-      </p:pic>
     </p:spTree>
   </p:cSld>
   <mc:AlternateContent>
@@ -23855,7 +23700,7 @@
         <p:spPr>
           <a:xfrm>
             <a:off x="60840" y="298080"/>
-            <a:ext cx="7709760" cy="2900520"/>
+            <a:ext cx="7709400" cy="2900160"/>
           </a:xfrm>
           <a:prstGeom prst="rect">
             <a:avLst/>
@@ -24189,6 +24034,270 @@
           </a:p>
         </p:txBody>
       </p:sp>
+    </p:spTree>
+  </p:cSld>
+  <mc:AlternateContent>
+    <mc:Choice Requires="p14">
+      <p:transition spd="slow" p14:dur="2000"/>
+    </mc:Choice>
+    <mc:Fallback>
+      <p:transition spd="slow"/>
+    </mc:Fallback>
+  </mc:AlternateContent>
+</p:sld>
+</file>
+
+<file path=ppt/slides/slide30.xml><?xml version="1.0" encoding="utf-8"?>
+<p:sld xmlns:a="http://schemas.openxmlformats.org/drawingml/2006/main" xmlns:p="http://schemas.openxmlformats.org/presentationml/2006/main" xmlns:r="http://schemas.openxmlformats.org/officeDocument/2006/relationships" xmlns:p14="http://schemas.microsoft.com/office/powerpoint/2010/main" xmlns:p15="http://schemas.microsoft.com/office/powerpoint/2012/main" xmlns:mc="http://schemas.openxmlformats.org/markup-compatibility/2006">
+  <p:cSld>
+    <p:spTree>
+      <p:nvGrpSpPr>
+        <p:cNvPr id="1" name=""/>
+        <p:cNvGrpSpPr/>
+        <p:nvPr/>
+      </p:nvGrpSpPr>
+      <p:grpSpPr>
+        <a:xfrm>
+          <a:off x="0" y="0"/>
+          <a:ext cx="0" cy="0"/>
+          <a:chOff x="0" y="0"/>
+          <a:chExt cx="0" cy="0"/>
+        </a:xfrm>
+      </p:grpSpPr>
+      <p:pic>
+        <p:nvPicPr>
+          <p:cNvPr id="228" name="Picture 1" descr=""/>
+          <p:cNvPicPr/>
+          <p:nvPr/>
+        </p:nvPicPr>
+        <p:blipFill>
+          <a:blip r:embed="rId1"/>
+          <a:stretch/>
+        </p:blipFill>
+        <p:spPr>
+          <a:xfrm>
+            <a:off x="146160" y="68760"/>
+            <a:ext cx="8538840" cy="1758240"/>
+          </a:xfrm>
+          <a:prstGeom prst="rect">
+            <a:avLst/>
+          </a:prstGeom>
+          <a:ln w="0">
+            <a:noFill/>
+          </a:ln>
+        </p:spPr>
+      </p:pic>
+      <p:sp>
+        <p:nvSpPr>
+          <p:cNvPr id="229" name="CustomShape 1"/>
+          <p:cNvSpPr/>
+          <p:nvPr/>
+        </p:nvSpPr>
+        <p:spPr>
+          <a:xfrm>
+            <a:off x="331920" y="266760"/>
+            <a:ext cx="7781040" cy="1833120"/>
+          </a:xfrm>
+          <a:prstGeom prst="rect">
+            <a:avLst/>
+          </a:prstGeom>
+          <a:noFill/>
+          <a:ln w="0">
+            <a:noFill/>
+          </a:ln>
+        </p:spPr>
+        <p:style>
+          <a:lnRef idx="0"/>
+          <a:fillRef idx="0"/>
+          <a:effectRef idx="0"/>
+          <a:fontRef idx="minor"/>
+        </p:style>
+        <p:txBody>
+          <a:bodyPr wrap="none" lIns="0" rIns="0" tIns="0" bIns="0" anchor="t">
+            <a:noAutofit/>
+          </a:bodyPr>
+          <a:p>
+            <a:pPr>
+              <a:lnSpc>
+                <a:spcPct val="100000"/>
+              </a:lnSpc>
+              <a:spcBef>
+                <a:spcPts val="1191"/>
+              </a:spcBef>
+              <a:spcAft>
+                <a:spcPts val="992"/>
+              </a:spcAft>
+            </a:pPr>
+            <a:r>
+              <a:rPr b="1" lang="en-US" sz="2240" spc="-1" strike="noStrike">
+                <a:solidFill>
+                  <a:srgbClr val="000000"/>
+                </a:solidFill>
+                <a:latin typeface="Arial Bold"/>
+                <a:ea typeface="DejaVu Sans"/>
+              </a:rPr>
+              <a:t>Init Runlevels</a:t>
+            </a:r>
+            <a:r>
+              <a:rPr b="0" lang="en-US" sz="2230" spc="-1" strike="noStrike">
+                <a:solidFill>
+                  <a:srgbClr val="000000"/>
+                </a:solidFill>
+                <a:latin typeface="Arial"/>
+                <a:ea typeface="DejaVu Sans"/>
+              </a:rPr>
+              <a:t>: </a:t>
+            </a:r>
+            <a:r>
+              <a:rPr b="1" lang="en-US" sz="2230" spc="-1" strike="noStrike">
+                <a:solidFill>
+                  <a:srgbClr val="000000"/>
+                </a:solidFill>
+                <a:latin typeface="Arial"/>
+                <a:ea typeface="DejaVu Sans"/>
+              </a:rPr>
+              <a:t>/etc/rc0.d (SysVinit)</a:t>
+            </a:r>
+            <a:br>
+              <a:rPr sz="2230"/>
+            </a:br>
+            <a:r>
+              <a:rPr b="0" lang="en-US" sz="2230" spc="-1" strike="noStrike">
+                <a:solidFill>
+                  <a:srgbClr val="000000"/>
+                </a:solidFill>
+                <a:latin typeface="Arial"/>
+                <a:ea typeface="DejaVu Sans"/>
+              </a:rPr>
+              <a:t>The idea behind operating different services at</a:t>
+            </a:r>
+            <a:endParaRPr b="0" lang="en-US" sz="2230" spc="-1" strike="noStrike">
+              <a:solidFill>
+                <a:srgbClr val="000000"/>
+              </a:solidFill>
+              <a:latin typeface="Arial"/>
+            </a:endParaRPr>
+          </a:p>
+          <a:p>
+            <a:pPr>
+              <a:lnSpc>
+                <a:spcPct val="100000"/>
+              </a:lnSpc>
+            </a:pPr>
+            <a:r>
+              <a:rPr b="0" lang="en-US" sz="2230" spc="-1" strike="noStrike">
+                <a:solidFill>
+                  <a:srgbClr val="000000"/>
+                </a:solidFill>
+                <a:latin typeface="Arial"/>
+                <a:ea typeface="DejaVu Sans"/>
+              </a:rPr>
+              <a:t>different run levels essentially revolves around the fact that</a:t>
+            </a:r>
+            <a:endParaRPr b="0" lang="en-US" sz="2230" spc="-1" strike="noStrike">
+              <a:solidFill>
+                <a:srgbClr val="000000"/>
+              </a:solidFill>
+              <a:latin typeface="Arial"/>
+            </a:endParaRPr>
+          </a:p>
+          <a:p>
+            <a:pPr>
+              <a:lnSpc>
+                <a:spcPct val="100000"/>
+              </a:lnSpc>
+            </a:pPr>
+            <a:r>
+              <a:rPr b="0" lang="en-US" sz="2230" spc="-1" strike="noStrike">
+                <a:solidFill>
+                  <a:srgbClr val="000000"/>
+                </a:solidFill>
+                <a:latin typeface="Arial"/>
+                <a:ea typeface="DejaVu Sans"/>
+              </a:rPr>
+              <a:t>different systems can be used in a different ways. The following</a:t>
+            </a:r>
+            <a:endParaRPr b="0" lang="en-US" sz="2230" spc="-1" strike="noStrike">
+              <a:solidFill>
+                <a:srgbClr val="000000"/>
+              </a:solidFill>
+              <a:latin typeface="Arial"/>
+            </a:endParaRPr>
+          </a:p>
+          <a:p>
+            <a:pPr>
+              <a:lnSpc>
+                <a:spcPts val="1023"/>
+              </a:lnSpc>
+            </a:pPr>
+            <a:endParaRPr b="0" lang="en-US" sz="2230" spc="-1" strike="noStrike">
+              <a:solidFill>
+                <a:srgbClr val="000000"/>
+              </a:solidFill>
+              <a:latin typeface="Arial"/>
+            </a:endParaRPr>
+          </a:p>
+          <a:p>
+            <a:pPr>
+              <a:lnSpc>
+                <a:spcPts val="1023"/>
+              </a:lnSpc>
+            </a:pPr>
+            <a:endParaRPr b="0" lang="en-US" sz="2230" spc="-1" strike="noStrike">
+              <a:solidFill>
+                <a:srgbClr val="000000"/>
+              </a:solidFill>
+              <a:latin typeface="Arial"/>
+            </a:endParaRPr>
+          </a:p>
+          <a:p>
+            <a:pPr>
+              <a:lnSpc>
+                <a:spcPts val="1023"/>
+              </a:lnSpc>
+            </a:pPr>
+            <a:r>
+              <a:rPr b="0" lang="en-US" sz="2230" spc="-1" strike="noStrike">
+                <a:solidFill>
+                  <a:srgbClr val="000000"/>
+                </a:solidFill>
+                <a:latin typeface="Arial"/>
+                <a:ea typeface="DejaVu Sans"/>
+              </a:rPr>
+              <a:t>runlevels are defined in Red Hat Linux :</a:t>
+            </a:r>
+            <a:endParaRPr b="0" lang="en-US" sz="2230" spc="-1" strike="noStrike">
+              <a:solidFill>
+                <a:srgbClr val="000000"/>
+              </a:solidFill>
+              <a:latin typeface="Arial"/>
+            </a:endParaRPr>
+          </a:p>
+        </p:txBody>
+      </p:sp>
+      <p:pic>
+        <p:nvPicPr>
+          <p:cNvPr id="230" name="" descr=""/>
+          <p:cNvPicPr/>
+          <p:nvPr/>
+        </p:nvPicPr>
+        <p:blipFill>
+          <a:blip r:embed="rId2"/>
+          <a:stretch/>
+        </p:blipFill>
+        <p:spPr>
+          <a:xfrm>
+            <a:off x="1143000" y="1855800"/>
+            <a:ext cx="5995800" cy="4314600"/>
+          </a:xfrm>
+          <a:prstGeom prst="rect">
+            <a:avLst/>
+          </a:prstGeom>
+          <a:ln w="0">
+            <a:noFill/>
+          </a:ln>
+        </p:spPr>
+      </p:pic>
     </p:spTree>
   </p:cSld>
   <mc:AlternateContent>
@@ -24228,7 +24337,7 @@
         <p:spPr>
           <a:xfrm>
             <a:off x="467640" y="72000"/>
-            <a:ext cx="8201160" cy="1454400"/>
+            <a:ext cx="8200800" cy="1454040"/>
           </a:xfrm>
           <a:prstGeom prst="rect">
             <a:avLst/>
@@ -24744,7 +24853,7 @@
         <p:spPr>
           <a:xfrm>
             <a:off x="183600" y="147600"/>
-            <a:ext cx="8958240" cy="2391840"/>
+            <a:ext cx="8957880" cy="2391480"/>
           </a:xfrm>
           <a:prstGeom prst="rect">
             <a:avLst/>
@@ -25002,7 +25111,7 @@
         <p:spPr>
           <a:xfrm>
             <a:off x="192600" y="2658600"/>
-            <a:ext cx="8685000" cy="2903760"/>
+            <a:ext cx="8684640" cy="2903400"/>
           </a:xfrm>
           <a:prstGeom prst="rect">
             <a:avLst/>
@@ -25362,8 +25471,8 @@
         </p:blipFill>
         <p:spPr>
           <a:xfrm>
-            <a:off x="1371600" y="-1209240"/>
-            <a:ext cx="7112160" cy="5322240"/>
+            <a:off x="1371600" y="228600"/>
+            <a:ext cx="7111800" cy="3920040"/>
           </a:xfrm>
           <a:prstGeom prst="rect">
             <a:avLst/>
@@ -25382,7 +25491,7 @@
         <p:spPr>
           <a:xfrm>
             <a:off x="2541960" y="648000"/>
-            <a:ext cx="2493720" cy="708480"/>
+            <a:ext cx="2493360" cy="708120"/>
           </a:xfrm>
           <a:prstGeom prst="rect">
             <a:avLst/>
@@ -25436,7 +25545,7 @@
         <p:spPr>
           <a:xfrm>
             <a:off x="204120" y="1008000"/>
-            <a:ext cx="8790120" cy="1813680"/>
+            <a:ext cx="8789760" cy="1813320"/>
           </a:xfrm>
           <a:prstGeom prst="rect">
             <a:avLst/>
@@ -25605,7 +25714,7 @@
         <p:spPr>
           <a:xfrm>
             <a:off x="224280" y="2869920"/>
-            <a:ext cx="7774920" cy="708480"/>
+            <a:ext cx="7774560" cy="708120"/>
           </a:xfrm>
           <a:prstGeom prst="rect">
             <a:avLst/>
@@ -25659,7 +25768,7 @@
         <p:spPr>
           <a:xfrm>
             <a:off x="225720" y="3009600"/>
-            <a:ext cx="9033840" cy="1809720"/>
+            <a:ext cx="9033480" cy="1809360"/>
           </a:xfrm>
           <a:prstGeom prst="rect">
             <a:avLst/>
@@ -25798,7 +25907,7 @@
         <p:spPr>
           <a:xfrm>
             <a:off x="216000" y="4343400"/>
-            <a:ext cx="8697600" cy="1096920"/>
+            <a:ext cx="8697240" cy="1096560"/>
           </a:xfrm>
           <a:prstGeom prst="rect">
             <a:avLst/>
@@ -25944,7 +26053,7 @@
         <p:spPr>
           <a:xfrm>
             <a:off x="108000" y="5297760"/>
-            <a:ext cx="8898120" cy="852480"/>
+            <a:ext cx="8897760" cy="852120"/>
           </a:xfrm>
           <a:prstGeom prst="rect">
             <a:avLst/>
@@ -26052,7 +26161,7 @@
         <p:spPr>
           <a:xfrm>
             <a:off x="0" y="-76320"/>
-            <a:ext cx="9136080" cy="6837480"/>
+            <a:ext cx="9135720" cy="6837120"/>
           </a:xfrm>
           <a:prstGeom prst="rect">
             <a:avLst/>
@@ -26071,7 +26180,7 @@
         <p:spPr>
           <a:xfrm>
             <a:off x="271080" y="266760"/>
-            <a:ext cx="8642520" cy="906840"/>
+            <a:ext cx="8642160" cy="906480"/>
           </a:xfrm>
           <a:prstGeom prst="rect">
             <a:avLst/>
@@ -26597,7 +26706,7 @@
         <p:spPr>
           <a:xfrm>
             <a:off x="252360" y="1371600"/>
-            <a:ext cx="7778520" cy="1211760"/>
+            <a:ext cx="7778160" cy="1211400"/>
           </a:xfrm>
           <a:prstGeom prst="rect">
             <a:avLst/>
@@ -26710,7 +26819,7 @@
         <p:spPr>
           <a:xfrm>
             <a:off x="267120" y="2309040"/>
-            <a:ext cx="8228880" cy="3346200"/>
+            <a:ext cx="8228520" cy="3345840"/>
           </a:xfrm>
           <a:prstGeom prst="rect">
             <a:avLst/>
@@ -27011,7 +27120,7 @@
         <p:spPr>
           <a:xfrm>
             <a:off x="288000" y="187560"/>
-            <a:ext cx="7917120" cy="1821600"/>
+            <a:ext cx="7916760" cy="1821240"/>
           </a:xfrm>
           <a:prstGeom prst="rect">
             <a:avLst/>
@@ -27330,7 +27439,7 @@
         <p:spPr>
           <a:xfrm>
             <a:off x="288000" y="1924200"/>
-            <a:ext cx="4111560" cy="588960"/>
+            <a:ext cx="4111200" cy="588600"/>
           </a:xfrm>
           <a:prstGeom prst="rect">
             <a:avLst/>
@@ -27384,7 +27493,7 @@
         <p:spPr>
           <a:xfrm>
             <a:off x="312120" y="2083680"/>
-            <a:ext cx="7023600" cy="588960"/>
+            <a:ext cx="7023240" cy="588600"/>
           </a:xfrm>
           <a:prstGeom prst="rect">
             <a:avLst/>
@@ -27500,7 +27609,7 @@
         <p:spPr>
           <a:xfrm>
             <a:off x="288000" y="2480040"/>
-            <a:ext cx="8063640" cy="3346200"/>
+            <a:ext cx="8063280" cy="3345840"/>
           </a:xfrm>
           <a:prstGeom prst="rect">
             <a:avLst/>
@@ -27837,7 +27946,7 @@
         <p:spPr>
           <a:xfrm>
             <a:off x="331560" y="5496480"/>
-            <a:ext cx="8353440" cy="1211760"/>
+            <a:ext cx="8353080" cy="1211400"/>
           </a:xfrm>
           <a:prstGeom prst="rect">
             <a:avLst/>
@@ -28062,7 +28171,7 @@
         <p:spPr>
           <a:xfrm>
             <a:off x="432000" y="360000"/>
-            <a:ext cx="8710200" cy="1875240"/>
+            <a:ext cx="8709840" cy="1874880"/>
           </a:xfrm>
           <a:prstGeom prst="rect">
             <a:avLst/>

</xml_diff>